<commit_message>
Revise talk deck: tighter flow, real signature comparison, consistent layout
Slide 5 now shows her baseline signature beside today's, with the
feature table; slide 6 maps the five delirium features onto the visit;
titles, captions and doodle placement are consistent; the 0% stat is
replaced with a sourced figure.

Co-Authored-By: Claude Fable 5.1 <noreply@anthropic.com>
Claude-Session: https://claude.ai/code/session_013zf8N3BNKm8ntFDtGarkNG
</commit_message>
<xml_diff>
--- a/docs/talk/ernie-talk.pptx
+++ b/docs/talk/ernie-talk.pptx
@@ -509,7 +509,7 @@
           <a:p>
             <a:r>
               <a:rPr lang="en-US" dirty="0"/>
-              <a:t>0:00. One line. "This is ernie, a daily visit for someone like Margaret. Five minutes: who she is, what is missing in her care, what we built, why delirium, and what is next."</a:t>
+              <a:t>0:00. One breath: "This is ernie, a daily visit for someone like Margaret. Five minutes: who she is, what is missing in her care, what we built, how it works, what is next."</a:t>
             </a:r>
             <a:endParaRPr lang="en-US" dirty="0"/>
           </a:p>
@@ -597,7 +597,7 @@
           <a:p>
             <a:r>
               <a:rPr lang="en-US" dirty="0"/>
-              <a:t>0:30. Margaret is a person, not a use case. Hypoactive delirium is withdrawal; the first anyone knows is the ER. It is missed in 60 to 75 percent of hospital cases, and nothing at home looks for it at all. The cause is usually cheap to fix if you catch it.</a:t>
+              <a:t>0:30. Margaret is a person, not a use case. Hypoactive delirium is withdrawal; the first anyone knows is the ER. Missed in 60 to 75 percent of hospital cases, and nothing at home looks at all. The thesis in one line: delirium is a change from your own baseline, and the home never had one.</a:t>
             </a:r>
             <a:endParaRPr lang="en-US" dirty="0"/>
           </a:p>
@@ -685,7 +685,7 @@
           <a:p>
             <a:r>
               <a:rPr lang="en-US" dirty="0"/>
-              <a:t>1:15. Value-based care moved the risk to providers: readmission penalties, 36 billion a year in readmissions, delirium and heart failure at the top of the list. The outcome is decided at home, between visits, and nobody is there. So the product is a daily visit. Sources: HCUP 2020, CMS HRRP, artifact ledger.</a:t>
+              <a:t>1:15. Value-based care moved the risk to providers: readmission penalties up to three percent of Medicare payments, 36 billion a year in readmissions, heart failure and delirium at the top of the list. The outcome is decided at home, between visits, and nobody is there. So the product is a daily visit.</a:t>
             </a:r>
             <a:endParaRPr lang="en-US" dirty="0"/>
           </a:p>
@@ -773,7 +773,7 @@
           <a:p>
             <a:r>
               <a:rPr lang="en-US" dirty="0"/>
-              <a:t>1:15 to 3:00. Play the 75-second clip, or click through. Narrate: she signs in (motor baseline, orientation); she answers a nurse's questions in her own words (a model reads what she meant, never advises); she does a puzzle and her granddaughter joins (attention, visuospatial, and the social pull); goodbye. Nothing on her screen is a score. Then switch to the next slide: what the phone saw.</a:t>
+              <a:t>1:15 to 3:00. Play the 75-second clip, or click through. She signs in (a motor baseline, and the date is the orientation item). She answers a nurse's questions in her own words; a model reads what she meant and never advises. She does a puzzle and her granddaughter joins (attention, visuospatial, and the reason to open the app). Goodbye. Nothing on her screen is ever a score.</a:t>
             </a:r>
             <a:endParaRPr lang="en-US" dirty="0"/>
           </a:p>
@@ -861,7 +861,7 @@
           <a:p>
             <a:r>
               <a:rPr lang="en-US" dirty="0"/>
-              <a:t>3:00. This is the backend view from the same visit, real numbers. Her signature today took 4.1 seconds against a usual 3.1, and she paused four times longer between strokes. Nine features, robust z against her own five-day baseline. She never sees this; the family gets one plain sentence, the clinic gets the numbers.</a:t>
+              <a:t>3:00. Same visit, real numbers. Five ordinary signings form her baseline; today she took 4.5 seconds against her usual 3.1 and paused four times longer between strokes. To the eye the strip looks the same. Nine features, robust z against her own usual. The family gets one plain sentence; she gets a thank-you.</a:t>
             </a:r>
             <a:endParaRPr lang="en-US" dirty="0"/>
           </a:p>
@@ -949,7 +949,7 @@
           <a:p>
             <a:r>
               <a:rPr lang="en-US" dirty="0"/>
-              <a:t>3:45. CAM, 4AT, UB-2: all measure attention, orientation, disorganised thinking and arousal, once a shift at best, in hospital. The fifth feature, fluctuation, needs the same measure every day, at home, against the person's own normal. That is the white space. And 40 percent of delirium is preventable with cheap responses, so a flag is worth having.</a:t>
+              <a:t>3:45. CAM, 4AT, UB-2: all measure attention, orientation, disorganised thinking and arousal, once a shift at best, in hospital. The fifth, fluctuation, needs the same measure every day, at home, against the person's own normal. That is the white space. And 40 percent of delirium is preventable with cheap responses, so a flag is worth having.</a:t>
             </a:r>
             <a:endParaRPr lang="en-US" dirty="0"/>
           </a:p>
@@ -1037,7 +1037,7 @@
           <a:p>
             <a:r>
               <a:rPr lang="en-US" dirty="0"/>
-              <a:t>4:20. Two shipped scripts, delirium watch and heart failure watch. The rails matter: the nurse owns the wording, the model only reads answers, and nothing is ever told to Margaret about a score. The explanation layer, on the right, is the design: what changed, what it usually means, who to call before the ER. Say clearly it is not built yet.</a:t>
+              <a:t>4:20. Two shipped scripts, delirium watch and heart failure watch. The rails: the nurse owns the wording, the model only reads answers, and Margaret is never told a score. The explanation layer on the right is the design: what changed, what it usually means, who to call before the ER. Say clearly it is not built yet.</a:t>
             </a:r>
             <a:endParaRPr lang="en-US" dirty="0"/>
           </a:p>
@@ -1727,24 +1727,24 @@
         </p:nvSpPr>
         <p:spPr>
           <a:xfrm>
-            <a:off x="548640" y="457200"/>
-            <a:ext cx="5120640" cy="640080"/>
-          </a:xfrm>
-          <a:prstGeom prst="rect">
-            <a:avLst/>
-          </a:prstGeom>
-          <a:noFill/>
-          <a:ln/>
-        </p:spPr>
-        <p:txBody>
-          <a:bodyPr wrap="square" lIns="0" tIns="0" rIns="0" bIns="0" rtlCol="0" anchor="ctr"/>
-          <a:lstStyle/>
-          <a:p>
-            <a:pPr indent="0" marL="0">
-              <a:buNone/>
-            </a:pPr>
-            <a:r>
-              <a:rPr lang="en-US" sz="4000" b="1" dirty="0">
+            <a:off x="548640" y="365760"/>
+            <a:ext cx="5303520" cy="594360"/>
+          </a:xfrm>
+          <a:prstGeom prst="rect">
+            <a:avLst/>
+          </a:prstGeom>
+          <a:noFill/>
+          <a:ln/>
+        </p:spPr>
+        <p:txBody>
+          <a:bodyPr wrap="square" lIns="0" tIns="0" rIns="0" bIns="0" rtlCol="0" anchor="ctr"/>
+          <a:lstStyle/>
+          <a:p>
+            <a:pPr indent="0" marL="0">
+              <a:buNone/>
+            </a:pPr>
+            <a:r>
+              <a:rPr lang="en-US" sz="3200" b="1" dirty="0">
                 <a:solidFill>
                   <a:srgbClr val="111827"/>
                 </a:solidFill>
@@ -1754,7 +1754,7 @@
               </a:rPr>
               <a:t>Margaret is 84.</a:t>
             </a:r>
-            <a:endParaRPr lang="en-US" sz="4000" dirty="0"/>
+            <a:endParaRPr lang="en-US" sz="3200" dirty="0"/>
           </a:p>
         </p:txBody>
       </p:sp>
@@ -1766,24 +1766,24 @@
         </p:nvSpPr>
         <p:spPr>
           <a:xfrm>
-            <a:off x="548640" y="1188720"/>
-            <a:ext cx="4937760" cy="1097280"/>
-          </a:xfrm>
-          <a:prstGeom prst="rect">
-            <a:avLst/>
-          </a:prstGeom>
-          <a:noFill/>
-          <a:ln/>
-        </p:spPr>
-        <p:txBody>
-          <a:bodyPr wrap="square" lIns="0" tIns="0" rIns="0" bIns="0" rtlCol="0" anchor="ctr"/>
-          <a:lstStyle/>
-          <a:p>
-            <a:pPr indent="0" marL="0">
-              <a:buNone/>
-            </a:pPr>
-            <a:r>
-              <a:rPr lang="en-US" sz="2400" dirty="0">
+            <a:off x="548640" y="1051560"/>
+            <a:ext cx="5120640" cy="1005840"/>
+          </a:xfrm>
+          <a:prstGeom prst="rect">
+            <a:avLst/>
+          </a:prstGeom>
+          <a:noFill/>
+          <a:ln/>
+        </p:spPr>
+        <p:txBody>
+          <a:bodyPr wrap="square" lIns="0" tIns="0" rIns="0" bIns="0" rtlCol="0" anchor="ctr"/>
+          <a:lstStyle/>
+          <a:p>
+            <a:pPr indent="0" marL="0">
+              <a:buNone/>
+            </a:pPr>
+            <a:r>
+              <a:rPr lang="en-US" sz="2100" dirty="0">
                 <a:solidFill>
                   <a:srgbClr val="111827"/>
                 </a:solidFill>
@@ -1791,9 +1791,9 @@
                 <a:ea typeface="Arial" pitchFamily="34" charset="-122"/>
                 <a:cs typeface="Arial" pitchFamily="34" charset="-120"/>
               </a:rPr>
-              <a:t>Every morning she signs Ernie’s book. This morning she didn’t.</a:t>
-            </a:r>
-            <a:endParaRPr lang="en-US" sz="2400" dirty="0"/>
+              <a:t>Every morning she signs Ernie’s book. This morning she was slower, and nobody was there to notice.</a:t>
+            </a:r>
+            <a:endParaRPr lang="en-US" sz="2100" dirty="0"/>
           </a:p>
         </p:txBody>
       </p:sp>
@@ -1805,24 +1805,24 @@
         </p:nvSpPr>
         <p:spPr>
           <a:xfrm>
-            <a:off x="548640" y="2331720"/>
-            <a:ext cx="4937760" cy="1280160"/>
-          </a:xfrm>
-          <a:prstGeom prst="rect">
-            <a:avLst/>
-          </a:prstGeom>
-          <a:noFill/>
-          <a:ln/>
-        </p:spPr>
-        <p:txBody>
-          <a:bodyPr wrap="square" lIns="0" tIns="0" rIns="0" bIns="0" rtlCol="0" anchor="ctr"/>
-          <a:lstStyle/>
-          <a:p>
-            <a:pPr indent="0" marL="0">
-              <a:buNone/>
-            </a:pPr>
-            <a:r>
-              <a:rPr lang="en-US" sz="1500" dirty="0">
+            <a:off x="548640" y="2148840"/>
+            <a:ext cx="5120640" cy="1143000"/>
+          </a:xfrm>
+          <a:prstGeom prst="rect">
+            <a:avLst/>
+          </a:prstGeom>
+          <a:noFill/>
+          <a:ln/>
+        </p:spPr>
+        <p:txBody>
+          <a:bodyPr wrap="square" lIns="0" tIns="0" rIns="0" bIns="0" rtlCol="0" anchor="ctr"/>
+          <a:lstStyle/>
+          <a:p>
+            <a:pPr indent="0" marL="0">
+              <a:buNone/>
+            </a:pPr>
+            <a:r>
+              <a:rPr lang="en-US" sz="1400" dirty="0">
                 <a:solidFill>
                   <a:srgbClr val="4B5563"/>
                 </a:solidFill>
@@ -1830,9 +1830,9 @@
                 <a:ea typeface="Arial" pitchFamily="34" charset="-122"/>
                 <a:cs typeface="Arial" pitchFamily="34" charset="-120"/>
               </a:rPr>
-              <a:t>Hypoactive delirium, the most common kind, looks like nothing at all: quieter, slower, a little withdrawn. It has a cause you can treat in a day: an infection, dehydration, a new tablet.</a:t>
-            </a:r>
-            <a:endParaRPr lang="en-US" sz="1500" dirty="0"/>
+              <a:t>Hypoactive delirium, the most common kind, looks like nothing at all: quieter, slower, a little withdrawn. The cause is usually cheap to fix on the day: an infection, dehydration, a new tablet. Missed, it ends in the emergency room.</a:t>
+            </a:r>
+            <a:endParaRPr lang="en-US" sz="1400" dirty="0"/>
           </a:p>
         </p:txBody>
       </p:sp>
@@ -1844,8 +1844,8 @@
         </p:nvSpPr>
         <p:spPr>
           <a:xfrm>
-            <a:off x="548640" y="3703320"/>
-            <a:ext cx="2286000" cy="960120"/>
+            <a:off x="548640" y="3383280"/>
+            <a:ext cx="2468880" cy="960120"/>
           </a:xfrm>
           <a:prstGeom prst="roundRect">
             <a:avLst>
@@ -1871,8 +1871,8 @@
         </p:nvSpPr>
         <p:spPr>
           <a:xfrm>
-            <a:off x="685800" y="3749040"/>
-            <a:ext cx="2103120" cy="502920"/>
+            <a:off x="685800" y="3429000"/>
+            <a:ext cx="2286000" cy="502920"/>
           </a:xfrm>
           <a:prstGeom prst="rect">
             <a:avLst/>
@@ -1910,8 +1910,8 @@
         </p:nvSpPr>
         <p:spPr>
           <a:xfrm>
-            <a:off x="685800" y="4251960"/>
-            <a:ext cx="2103120" cy="320040"/>
+            <a:off x="685800" y="3931920"/>
+            <a:ext cx="2286000" cy="365760"/>
           </a:xfrm>
           <a:prstGeom prst="rect">
             <a:avLst/>
@@ -1935,7 +1935,7 @@
                 <a:ea typeface="Arial" pitchFamily="34" charset="-122"/>
                 <a:cs typeface="Arial" pitchFamily="34" charset="-120"/>
               </a:rPr>
-              <a:t>missed, even in hospital</a:t>
+              <a:t>of cases missed, even in hospital</a:t>
             </a:r>
             <a:endParaRPr lang="en-US" sz="1100" dirty="0"/>
           </a:p>
@@ -1949,7 +1949,7 @@
         </p:nvSpPr>
         <p:spPr>
           <a:xfrm>
-            <a:off x="3017520" y="3703320"/>
+            <a:off x="3200400" y="3383280"/>
             <a:ext cx="2468880" cy="960120"/>
           </a:xfrm>
           <a:prstGeom prst="roundRect">
@@ -1976,7 +1976,7 @@
         </p:nvSpPr>
         <p:spPr>
           <a:xfrm>
-            <a:off x="3154680" y="3749040"/>
+            <a:off x="3337560" y="3429000"/>
             <a:ext cx="2286000" cy="502920"/>
           </a:xfrm>
           <a:prstGeom prst="rect">
@@ -2001,7 +2001,7 @@
                 <a:ea typeface="Arial" pitchFamily="34" charset="-122"/>
                 <a:cs typeface="Arial" pitchFamily="34" charset="-120"/>
               </a:rPr>
-              <a:t>0%</a:t>
+              <a:t>7 M</a:t>
             </a:r>
             <a:endParaRPr lang="en-US" sz="3000" dirty="0"/>
           </a:p>
@@ -2015,8 +2015,8 @@
         </p:nvSpPr>
         <p:spPr>
           <a:xfrm>
-            <a:off x="3154680" y="4251960"/>
-            <a:ext cx="2286000" cy="320040"/>
+            <a:off x="3337560" y="3931920"/>
+            <a:ext cx="2286000" cy="365760"/>
           </a:xfrm>
           <a:prstGeom prst="rect">
             <a:avLst/>
@@ -2040,7 +2040,7 @@
                 <a:ea typeface="Arial" pitchFamily="34" charset="-122"/>
                 <a:cs typeface="Arial" pitchFamily="34" charset="-120"/>
               </a:rPr>
-              <a:t>noticed at home, where it starts</a:t>
+              <a:t>hospital episodes a year in the US</a:t>
             </a:r>
             <a:endParaRPr lang="en-US" sz="1100" dirty="0"/>
           </a:p>
@@ -2048,7 +2048,46 @@
       </p:sp>
       <p:sp>
         <p:nvSpPr>
-          <p:cNvPr id="11" name="Shape 9"/>
+          <p:cNvPr id="11" name="Text 9"/>
+          <p:cNvSpPr txBox="1"/>
+          <p:nvPr/>
+        </p:nvSpPr>
+        <p:spPr>
+          <a:xfrm>
+            <a:off x="548640" y="4480560"/>
+            <a:ext cx="5120640" cy="411480"/>
+          </a:xfrm>
+          <a:prstGeom prst="rect">
+            <a:avLst/>
+          </a:prstGeom>
+          <a:noFill/>
+          <a:ln/>
+        </p:spPr>
+        <p:txBody>
+          <a:bodyPr wrap="square" lIns="0" tIns="0" rIns="0" bIns="0" rtlCol="0" anchor="ctr"/>
+          <a:lstStyle/>
+          <a:p>
+            <a:pPr indent="0" marL="0">
+              <a:buNone/>
+            </a:pPr>
+            <a:r>
+              <a:rPr lang="en-US" sz="1400" i="1" dirty="0">
+                <a:solidFill>
+                  <a:srgbClr val="1E40AF"/>
+                </a:solidFill>
+                <a:latin typeface="Arial" pitchFamily="34" charset="0"/>
+                <a:ea typeface="Arial" pitchFamily="34" charset="-122"/>
+                <a:cs typeface="Arial" pitchFamily="34" charset="-120"/>
+              </a:rPr>
+              <a:t>Delirium is a change from your own baseline. The home never had one.</a:t>
+            </a:r>
+            <a:endParaRPr lang="en-US" sz="1400" dirty="0"/>
+          </a:p>
+        </p:txBody>
+      </p:sp>
+      <p:sp>
+        <p:nvSpPr>
+          <p:cNvPr id="12" name="Shape 10"/>
           <p:cNvSpPr/>
           <p:nvPr/>
         </p:nvSpPr>
@@ -2075,7 +2114,7 @@
       </p:sp>
       <p:pic>
         <p:nvPicPr>
-          <p:cNvPr id="12" name="Image 0" descr="../shots/03-book-page-c.png">    </p:cNvPr>
+          <p:cNvPr id="13" name="Image 0" descr="../shots/03-book-page-c.png">    </p:cNvPr>
           <p:cNvPicPr>
             <a:picLocks noChangeAspect="1"/>
           </p:cNvPicPr>
@@ -2091,30 +2130,6 @@
           <a:xfrm>
             <a:off x="6492240" y="457200"/>
             <a:ext cx="2042881" cy="4206240"/>
-          </a:xfrm>
-          <a:prstGeom prst="rect">
-            <a:avLst/>
-          </a:prstGeom>
-        </p:spPr>
-      </p:pic>
-      <p:pic>
-        <p:nvPicPr>
-          <p:cNvPr id="13" name="Image 1" descr="../shots/doodle-cat-with-no-face-blue.png">    </p:cNvPr>
-          <p:cNvPicPr>
-            <a:picLocks noChangeAspect="1"/>
-          </p:cNvPicPr>
-          <p:nvPr/>
-        </p:nvPicPr>
-        <p:blipFill>
-          <a:blip r:embed="rId2"/>
-          <a:stretch>
-            <a:fillRect/>
-          </a:stretch>
-        </p:blipFill>
-        <p:spPr>
-          <a:xfrm>
-            <a:off x="5349240" y="3611880"/>
-            <a:ext cx="1005840" cy="1005840"/>
           </a:xfrm>
           <a:prstGeom prst="rect">
             <a:avLst/>
@@ -2161,24 +2176,24 @@
         </p:nvSpPr>
         <p:spPr>
           <a:xfrm>
-            <a:off x="548640" y="411480"/>
-            <a:ext cx="7040880" cy="640080"/>
-          </a:xfrm>
-          <a:prstGeom prst="rect">
-            <a:avLst/>
-          </a:prstGeom>
-          <a:noFill/>
-          <a:ln/>
-        </p:spPr>
-        <p:txBody>
-          <a:bodyPr wrap="square" lIns="0" tIns="0" rIns="0" bIns="0" rtlCol="0" anchor="ctr"/>
-          <a:lstStyle/>
-          <a:p>
-            <a:pPr indent="0" marL="0">
-              <a:buNone/>
-            </a:pPr>
-            <a:r>
-              <a:rPr lang="en-US" sz="2700" b="1" dirty="0">
+            <a:off x="548640" y="365760"/>
+            <a:ext cx="7040880" cy="594360"/>
+          </a:xfrm>
+          <a:prstGeom prst="rect">
+            <a:avLst/>
+          </a:prstGeom>
+          <a:noFill/>
+          <a:ln/>
+        </p:spPr>
+        <p:txBody>
+          <a:bodyPr wrap="square" lIns="0" tIns="0" rIns="0" bIns="0" rtlCol="0" anchor="ctr"/>
+          <a:lstStyle/>
+          <a:p>
+            <a:pPr indent="0" marL="0">
+              <a:buNone/>
+            </a:pPr>
+            <a:r>
+              <a:rPr lang="en-US" sz="3200" b="1" dirty="0">
                 <a:solidFill>
                   <a:srgbClr val="111827"/>
                 </a:solidFill>
@@ -2186,9 +2201,9 @@
                 <a:ea typeface="Arial" pitchFamily="34" charset="-122"/>
                 <a:cs typeface="Arial" pitchFamily="34" charset="-120"/>
               </a:rPr>
-              <a:t>The missing link is the 30 days at home.</a:t>
-            </a:r>
-            <a:endParaRPr lang="en-US" sz="2700" dirty="0"/>
+              <a:t>The gap is the 30 days at home.</a:t>
+            </a:r>
+            <a:endParaRPr lang="en-US" sz="3200" dirty="0"/>
           </a:p>
         </p:txBody>
       </p:sp>
@@ -2200,24 +2215,24 @@
         </p:nvSpPr>
         <p:spPr>
           <a:xfrm>
-            <a:off x="548640" y="1097280"/>
-            <a:ext cx="8046720" cy="640080"/>
-          </a:xfrm>
-          <a:prstGeom prst="rect">
-            <a:avLst/>
-          </a:prstGeom>
-          <a:noFill/>
-          <a:ln/>
-        </p:spPr>
-        <p:txBody>
-          <a:bodyPr wrap="square" lIns="0" tIns="0" rIns="0" bIns="0" rtlCol="0" anchor="ctr"/>
-          <a:lstStyle/>
-          <a:p>
-            <a:pPr indent="0" marL="0">
-              <a:buNone/>
-            </a:pPr>
-            <a:r>
-              <a:rPr lang="en-US" sz="1600" dirty="0">
+            <a:off x="548640" y="960120"/>
+            <a:ext cx="7040880" cy="548640"/>
+          </a:xfrm>
+          <a:prstGeom prst="rect">
+            <a:avLst/>
+          </a:prstGeom>
+          <a:noFill/>
+          <a:ln/>
+        </p:spPr>
+        <p:txBody>
+          <a:bodyPr wrap="square" lIns="0" tIns="0" rIns="0" bIns="0" rtlCol="0" anchor="ctr"/>
+          <a:lstStyle/>
+          <a:p>
+            <a:pPr indent="0" marL="0">
+              <a:buNone/>
+            </a:pPr>
+            <a:r>
+              <a:rPr lang="en-US" sz="1500" dirty="0">
                 <a:solidFill>
                   <a:srgbClr val="4B5563"/>
                 </a:solidFill>
@@ -2225,9 +2240,9 @@
                 <a:ea typeface="Arial" pitchFamily="34" charset="-122"/>
                 <a:cs typeface="Arial" pitchFamily="34" charset="-120"/>
               </a:rPr>
-              <a:t>Value-based care pays providers for outcomes. The outcome is decided at home, between visits. Nobody is there daily.</a:t>
-            </a:r>
-            <a:endParaRPr lang="en-US" sz="1600" dirty="0"/>
+              <a:t>Value-based care makes providers carry the risk for outcomes. The outcome is decided at home, between visits, where nobody looks.</a:t>
+            </a:r>
+            <a:endParaRPr lang="en-US" sz="1500" dirty="0"/>
           </a:p>
         </p:txBody>
       </p:sp>
@@ -2239,12 +2254,12 @@
         </p:nvSpPr>
         <p:spPr>
           <a:xfrm>
-            <a:off x="548640" y="1965960"/>
-            <a:ext cx="2468880" cy="1234440"/>
+            <a:off x="548640" y="1874520"/>
+            <a:ext cx="2468880" cy="1188720"/>
           </a:xfrm>
           <a:prstGeom prst="roundRect">
             <a:avLst>
-              <a:gd name="adj" fmla="val 11111"/>
+              <a:gd name="adj" fmla="val 11538"/>
             </a:avLst>
           </a:prstGeom>
           <a:solidFill>
@@ -2266,7 +2281,7 @@
         </p:nvSpPr>
         <p:spPr>
           <a:xfrm>
-            <a:off x="731520" y="2057400"/>
+            <a:off x="731520" y="1965960"/>
             <a:ext cx="2194560" cy="457200"/>
           </a:xfrm>
           <a:prstGeom prst="rect">
@@ -2305,8 +2320,8 @@
         </p:nvSpPr>
         <p:spPr>
           <a:xfrm>
-            <a:off x="731520" y="2514600"/>
-            <a:ext cx="2194560" cy="594360"/>
+            <a:off x="731520" y="2423160"/>
+            <a:ext cx="2194560" cy="548640"/>
           </a:xfrm>
           <a:prstGeom prst="rect">
             <a:avLst/>
@@ -2330,7 +2345,7 @@
                 <a:ea typeface="Arial" pitchFamily="34" charset="-122"/>
                 <a:cs typeface="Arial" pitchFamily="34" charset="-120"/>
               </a:rPr>
-              <a:t>A plan on the fridge</a:t>
+              <a:t>A plan on the fridge.</a:t>
             </a:r>
             <a:endParaRPr lang="en-US" sz="1300" dirty="0"/>
           </a:p>
@@ -2344,7 +2359,7 @@
         </p:nvSpPr>
         <p:spPr>
           <a:xfrm>
-            <a:off x="2999232" y="2286000"/>
+            <a:off x="2999232" y="2194560"/>
             <a:ext cx="411480" cy="548640"/>
           </a:xfrm>
           <a:prstGeom prst="rect">
@@ -2383,12 +2398,12 @@
         </p:nvSpPr>
         <p:spPr>
           <a:xfrm>
-            <a:off x="3337560" y="1965960"/>
-            <a:ext cx="2468880" cy="1234440"/>
+            <a:off x="3337560" y="1874520"/>
+            <a:ext cx="2468880" cy="1188720"/>
           </a:xfrm>
           <a:prstGeom prst="roundRect">
             <a:avLst>
-              <a:gd name="adj" fmla="val 11111"/>
+              <a:gd name="adj" fmla="val 11538"/>
             </a:avLst>
           </a:prstGeom>
           <a:solidFill>
@@ -2410,7 +2425,7 @@
         </p:nvSpPr>
         <p:spPr>
           <a:xfrm>
-            <a:off x="3520440" y="2057400"/>
+            <a:off x="3520440" y="1965960"/>
             <a:ext cx="2194560" cy="457200"/>
           </a:xfrm>
           <a:prstGeom prst="rect">
@@ -2449,8 +2464,8 @@
         </p:nvSpPr>
         <p:spPr>
           <a:xfrm>
-            <a:off x="3520440" y="2514600"/>
-            <a:ext cx="2194560" cy="594360"/>
+            <a:off x="3520440" y="2423160"/>
+            <a:ext cx="2194560" cy="548640"/>
           </a:xfrm>
           <a:prstGeom prst="rect">
             <a:avLst/>
@@ -2474,7 +2489,7 @@
                 <a:ea typeface="Arial" pitchFamily="34" charset="-122"/>
                 <a:cs typeface="Arial" pitchFamily="34" charset="-120"/>
               </a:rPr>
-              <a:t>Nobody looks. The signal is quiet.</a:t>
+              <a:t>Quiet. Nobody looks.</a:t>
             </a:r>
             <a:endParaRPr lang="en-US" sz="1300" dirty="0"/>
           </a:p>
@@ -2488,7 +2503,7 @@
         </p:nvSpPr>
         <p:spPr>
           <a:xfrm>
-            <a:off x="5788152" y="2286000"/>
+            <a:off x="5788152" y="2194560"/>
             <a:ext cx="411480" cy="548640"/>
           </a:xfrm>
           <a:prstGeom prst="rect">
@@ -2527,12 +2542,12 @@
         </p:nvSpPr>
         <p:spPr>
           <a:xfrm>
-            <a:off x="6126480" y="1965960"/>
-            <a:ext cx="2468880" cy="1234440"/>
+            <a:off x="6126480" y="1874520"/>
+            <a:ext cx="2468880" cy="1188720"/>
           </a:xfrm>
           <a:prstGeom prst="roundRect">
             <a:avLst>
-              <a:gd name="adj" fmla="val 11111"/>
+              <a:gd name="adj" fmla="val 11538"/>
             </a:avLst>
           </a:prstGeom>
           <a:solidFill>
@@ -2554,7 +2569,7 @@
         </p:nvSpPr>
         <p:spPr>
           <a:xfrm>
-            <a:off x="6309360" y="2057400"/>
+            <a:off x="6309360" y="1965960"/>
             <a:ext cx="2194560" cy="457200"/>
           </a:xfrm>
           <a:prstGeom prst="rect">
@@ -2593,8 +2608,8 @@
         </p:nvSpPr>
         <p:spPr>
           <a:xfrm>
-            <a:off x="6309360" y="2514600"/>
-            <a:ext cx="2194560" cy="594360"/>
+            <a:off x="6309360" y="2423160"/>
+            <a:ext cx="2194560" cy="548640"/>
           </a:xfrm>
           <a:prstGeom prst="rect">
             <a:avLst/>
@@ -2632,8 +2647,8 @@
         </p:nvSpPr>
         <p:spPr>
           <a:xfrm>
-            <a:off x="548640" y="3520440"/>
-            <a:ext cx="1920240" cy="548640"/>
+            <a:off x="548640" y="3429000"/>
+            <a:ext cx="1828800" cy="548640"/>
           </a:xfrm>
           <a:prstGeom prst="rect">
             <a:avLst/>
@@ -2671,8 +2686,8 @@
         </p:nvSpPr>
         <p:spPr>
           <a:xfrm>
-            <a:off x="548640" y="4069080"/>
-            <a:ext cx="1920240" cy="548640"/>
+            <a:off x="548640" y="3977640"/>
+            <a:ext cx="1828800" cy="365760"/>
           </a:xfrm>
           <a:prstGeom prst="rect">
             <a:avLst/>
@@ -2696,7 +2711,7 @@
                 <a:ea typeface="Arial" pitchFamily="34" charset="-122"/>
                 <a:cs typeface="Arial" pitchFamily="34" charset="-120"/>
               </a:rPr>
-              <a:t>a year in 30-day readmissions</a:t>
+              <a:t>a year in readmissions</a:t>
             </a:r>
             <a:endParaRPr lang="en-US" sz="1100" dirty="0"/>
           </a:p>
@@ -2710,8 +2725,8 @@
         </p:nvSpPr>
         <p:spPr>
           <a:xfrm>
-            <a:off x="2606040" y="3520440"/>
-            <a:ext cx="1920240" cy="548640"/>
+            <a:off x="2514600" y="3429000"/>
+            <a:ext cx="1828800" cy="548640"/>
           </a:xfrm>
           <a:prstGeom prst="rect">
             <a:avLst/>
@@ -2749,8 +2764,8 @@
         </p:nvSpPr>
         <p:spPr>
           <a:xfrm>
-            <a:off x="2606040" y="4069080"/>
-            <a:ext cx="1920240" cy="548640"/>
+            <a:off x="2514600" y="3977640"/>
+            <a:ext cx="1828800" cy="365760"/>
           </a:xfrm>
           <a:prstGeom prst="rect">
             <a:avLst/>
@@ -2788,8 +2803,8 @@
         </p:nvSpPr>
         <p:spPr>
           <a:xfrm>
-            <a:off x="4663440" y="3520440"/>
-            <a:ext cx="1920240" cy="548640"/>
+            <a:off x="4480560" y="3429000"/>
+            <a:ext cx="1828800" cy="548640"/>
           </a:xfrm>
           <a:prstGeom prst="rect">
             <a:avLst/>
@@ -2827,8 +2842,8 @@
         </p:nvSpPr>
         <p:spPr>
           <a:xfrm>
-            <a:off x="4663440" y="4069080"/>
-            <a:ext cx="1920240" cy="548640"/>
+            <a:off x="4480560" y="3977640"/>
+            <a:ext cx="1828800" cy="365760"/>
           </a:xfrm>
           <a:prstGeom prst="rect">
             <a:avLst/>
@@ -2852,7 +2867,7 @@
                 <a:ea typeface="Arial" pitchFamily="34" charset="-122"/>
                 <a:cs typeface="Arial" pitchFamily="34" charset="-120"/>
               </a:rPr>
-              <a:t>of Medicare payments at risk (HRRP)</a:t>
+              <a:t>of Medicare payments at risk</a:t>
             </a:r>
             <a:endParaRPr lang="en-US" sz="1100" dirty="0"/>
           </a:p>
@@ -2866,8 +2881,8 @@
         </p:nvSpPr>
         <p:spPr>
           <a:xfrm>
-            <a:off x="6720840" y="3520440"/>
-            <a:ext cx="1920240" cy="548640"/>
+            <a:off x="6446520" y="3429000"/>
+            <a:ext cx="1828800" cy="548640"/>
           </a:xfrm>
           <a:prstGeom prst="rect">
             <a:avLst/>
@@ -2905,8 +2920,8 @@
         </p:nvSpPr>
         <p:spPr>
           <a:xfrm>
-            <a:off x="6720840" y="4069080"/>
-            <a:ext cx="1920240" cy="548640"/>
+            <a:off x="6446520" y="3977640"/>
+            <a:ext cx="1828800" cy="365760"/>
           </a:xfrm>
           <a:prstGeom prst="rect">
             <a:avLst/>
@@ -2933,12 +2948,51 @@
               <a:t>extra per delirium episode</a:t>
             </a:r>
             <a:endParaRPr lang="en-US" sz="1100" dirty="0"/>
+          </a:p>
+        </p:txBody>
+      </p:sp>
+      <p:sp>
+        <p:nvSpPr>
+          <p:cNvPr id="23" name="Text 21"/>
+          <p:cNvSpPr txBox="1"/>
+          <p:nvPr/>
+        </p:nvSpPr>
+        <p:spPr>
+          <a:xfrm>
+            <a:off x="548640" y="4526280"/>
+            <a:ext cx="5486400" cy="274320"/>
+          </a:xfrm>
+          <a:prstGeom prst="rect">
+            <a:avLst/>
+          </a:prstGeom>
+          <a:noFill/>
+          <a:ln/>
+        </p:spPr>
+        <p:txBody>
+          <a:bodyPr wrap="square" lIns="0" tIns="0" rIns="0" bIns="0" rtlCol="0" anchor="ctr"/>
+          <a:lstStyle/>
+          <a:p>
+            <a:pPr indent="0" marL="0">
+              <a:buNone/>
+            </a:pPr>
+            <a:r>
+              <a:rPr lang="en-US" sz="900" dirty="0">
+                <a:solidFill>
+                  <a:srgbClr val="9CA3AF"/>
+                </a:solidFill>
+                <a:latin typeface="Arial" pitchFamily="34" charset="0"/>
+                <a:ea typeface="Arial" pitchFamily="34" charset="-122"/>
+                <a:cs typeface="Arial" pitchFamily="34" charset="-120"/>
+              </a:rPr>
+              <a:t>HCUP 2020 · CMS HRRP · AHRQ</a:t>
+            </a:r>
+            <a:endParaRPr lang="en-US" sz="900" dirty="0"/>
           </a:p>
         </p:txBody>
       </p:sp>
       <p:pic>
         <p:nvPicPr>
-          <p:cNvPr id="23" name="Image 0" descr="../shots/doodle-half-a-house-blue.png">    </p:cNvPr>
+          <p:cNvPr id="24" name="Image 0" descr="../shots/doodle-half-a-house-blue.png">    </p:cNvPr>
           <p:cNvPicPr>
             <a:picLocks noChangeAspect="1"/>
           </p:cNvPicPr>
@@ -2952,8 +3006,8 @@
         </p:blipFill>
         <p:spPr>
           <a:xfrm>
-            <a:off x="7726680" y="228600"/>
-            <a:ext cx="1051560" cy="1051560"/>
+            <a:off x="7818120" y="4069080"/>
+            <a:ext cx="960120" cy="960120"/>
           </a:xfrm>
           <a:prstGeom prst="rect">
             <a:avLst/>
@@ -3017,7 +3071,7 @@
               <a:buNone/>
             </a:pPr>
             <a:r>
-              <a:rPr lang="en-US" sz="3400" b="1" dirty="0">
+              <a:rPr lang="en-US" sz="3200" b="1" dirty="0">
                 <a:solidFill>
                   <a:srgbClr val="111827"/>
                 </a:solidFill>
@@ -3027,7 +3081,7 @@
               </a:rPr>
               <a:t>No tests. Just a visit.</a:t>
             </a:r>
-            <a:endParaRPr lang="en-US" sz="3400" dirty="0"/>
+            <a:endParaRPr lang="en-US" sz="3200" dirty="0"/>
           </a:p>
         </p:txBody>
       </p:sp>
@@ -3039,8 +3093,8 @@
         </p:nvSpPr>
         <p:spPr>
           <a:xfrm>
-            <a:off x="548640" y="960120"/>
-            <a:ext cx="8046720" cy="457200"/>
+            <a:off x="548640" y="914400"/>
+            <a:ext cx="8046720" cy="548640"/>
           </a:xfrm>
           <a:prstGeom prst="rect">
             <a:avLst/>
@@ -3064,7 +3118,7 @@
                 <a:ea typeface="Arial" pitchFamily="34" charset="-122"/>
                 <a:cs typeface="Arial" pitchFamily="34" charset="-120"/>
               </a:rPr>
-              <a:t>Sign in, a few questions in her own words, a puzzle with Anna, goodbye. Every one of them is also a measurement.</a:t>
+              <a:t>She makes something every day: a signature, her own words, a finished picture. Each one is also a measurement.</a:t>
             </a:r>
             <a:endParaRPr lang="en-US" sz="1500" dirty="0"/>
           </a:p>
@@ -3078,12 +3132,12 @@
         </p:nvSpPr>
         <p:spPr>
           <a:xfrm>
-            <a:off x="493776" y="1545336"/>
-            <a:ext cx="1508658" cy="2990088"/>
+            <a:off x="493776" y="1572768"/>
+            <a:ext cx="1464247" cy="2898648"/>
           </a:xfrm>
           <a:prstGeom prst="roundRect">
             <a:avLst>
-              <a:gd name="adj" fmla="val 13334"/>
+              <a:gd name="adj" fmla="val 13739"/>
             </a:avLst>
           </a:prstGeom>
           <a:solidFill>
@@ -3113,8 +3167,8 @@
         </p:blipFill>
         <p:spPr>
           <a:xfrm>
-            <a:off x="548640" y="1600200"/>
-            <a:ext cx="1398930" cy="2880360"/>
+            <a:off x="548640" y="1627632"/>
+            <a:ext cx="1354519" cy="2788920"/>
           </a:xfrm>
           <a:prstGeom prst="rect">
             <a:avLst/>
@@ -3129,24 +3183,63 @@
         </p:nvSpPr>
         <p:spPr>
           <a:xfrm>
-            <a:off x="274320" y="4572000"/>
-            <a:ext cx="1947570" cy="457200"/>
-          </a:xfrm>
-          <a:prstGeom prst="rect">
-            <a:avLst/>
-          </a:prstGeom>
-          <a:noFill/>
-          <a:ln/>
-        </p:spPr>
-        <p:txBody>
-          <a:bodyPr wrap="square" lIns="0" tIns="0" rIns="0" bIns="0" rtlCol="0" anchor="t"/>
+            <a:off x="228600" y="4507992"/>
+            <a:ext cx="1994599" cy="256032"/>
+          </a:xfrm>
+          <a:prstGeom prst="rect">
+            <a:avLst/>
+          </a:prstGeom>
+          <a:noFill/>
+          <a:ln/>
+        </p:spPr>
+        <p:txBody>
+          <a:bodyPr wrap="square" lIns="0" tIns="0" rIns="0" bIns="0" rtlCol="0" anchor="ctr"/>
           <a:lstStyle/>
           <a:p>
             <a:pPr algn="ctr" indent="0" marL="0">
               <a:buNone/>
             </a:pPr>
             <a:r>
-              <a:rPr lang="en-US" sz="1200" dirty="0">
+              <a:rPr lang="en-US" sz="1300" b="1" dirty="0">
+                <a:solidFill>
+                  <a:srgbClr val="111827"/>
+                </a:solidFill>
+                <a:latin typeface="Arial" pitchFamily="34" charset="0"/>
+                <a:ea typeface="Arial" pitchFamily="34" charset="-122"/>
+                <a:cs typeface="Arial" pitchFamily="34" charset="-120"/>
+              </a:rPr>
+              <a:t>Sign the book</a:t>
+            </a:r>
+            <a:endParaRPr lang="en-US" sz="1300" dirty="0"/>
+          </a:p>
+        </p:txBody>
+      </p:sp>
+      <p:sp>
+        <p:nvSpPr>
+          <p:cNvPr id="7" name="Text 4"/>
+          <p:cNvSpPr txBox="1"/>
+          <p:nvPr/>
+        </p:nvSpPr>
+        <p:spPr>
+          <a:xfrm>
+            <a:off x="228600" y="4764024"/>
+            <a:ext cx="1994599" cy="274320"/>
+          </a:xfrm>
+          <a:prstGeom prst="rect">
+            <a:avLst/>
+          </a:prstGeom>
+          <a:noFill/>
+          <a:ln/>
+        </p:spPr>
+        <p:txBody>
+          <a:bodyPr wrap="square" lIns="0" tIns="0" rIns="0" bIns="0" rtlCol="0" anchor="ctr"/>
+          <a:lstStyle/>
+          <a:p>
+            <a:pPr algn="ctr" indent="0" marL="0">
+              <a:buNone/>
+            </a:pPr>
+            <a:r>
+              <a:rPr lang="en-US" sz="1000" dirty="0">
                 <a:solidFill>
                   <a:srgbClr val="4B5563"/>
                 </a:solidFill>
@@ -3154,26 +3247,26 @@
                 <a:ea typeface="Arial" pitchFamily="34" charset="-122"/>
                 <a:cs typeface="Arial" pitchFamily="34" charset="-120"/>
               </a:rPr>
-              <a:t>1  Sign the book</a:t>
-            </a:r>
-            <a:endParaRPr lang="en-US" sz="1200" dirty="0"/>
-          </a:p>
-        </p:txBody>
-      </p:sp>
-      <p:sp>
-        <p:nvSpPr>
-          <p:cNvPr id="7" name="Shape 4"/>
+              <a:t>motor baseline · orientation</a:t>
+            </a:r>
+            <a:endParaRPr lang="en-US" sz="1000" dirty="0"/>
+          </a:p>
+        </p:txBody>
+      </p:sp>
+      <p:sp>
+        <p:nvSpPr>
+          <p:cNvPr id="8" name="Shape 5"/>
           <p:cNvSpPr/>
           <p:nvPr/>
         </p:nvSpPr>
         <p:spPr>
           <a:xfrm>
-            <a:off x="2551074" y="1545336"/>
-            <a:ext cx="1508658" cy="2990088"/>
+            <a:off x="2506663" y="1572768"/>
+            <a:ext cx="1464247" cy="2898648"/>
           </a:xfrm>
           <a:prstGeom prst="roundRect">
             <a:avLst>
-              <a:gd name="adj" fmla="val 13334"/>
+              <a:gd name="adj" fmla="val 13739"/>
             </a:avLst>
           </a:prstGeom>
           <a:solidFill>
@@ -3189,7 +3282,7 @@
       </p:sp>
       <p:pic>
         <p:nvPicPr>
-          <p:cNvPr id="8" name="Image 1" descr="../shots/04-chat-invite-c.png">    </p:cNvPr>
+          <p:cNvPr id="9" name="Image 1" descr="../shots/05-chat-question-c.png">    </p:cNvPr>
           <p:cNvPicPr>
             <a:picLocks noChangeAspect="1"/>
           </p:cNvPicPr>
@@ -3203,8 +3296,8 @@
         </p:blipFill>
         <p:spPr>
           <a:xfrm>
-            <a:off x="2605938" y="1600200"/>
-            <a:ext cx="1398930" cy="2880360"/>
+            <a:off x="2561527" y="1627632"/>
+            <a:ext cx="1354519" cy="2788920"/>
           </a:xfrm>
           <a:prstGeom prst="rect">
             <a:avLst/>
@@ -3213,30 +3306,69 @@
       </p:pic>
       <p:sp>
         <p:nvSpPr>
-          <p:cNvPr id="9" name="Text 5"/>
-          <p:cNvSpPr txBox="1"/>
-          <p:nvPr/>
-        </p:nvSpPr>
-        <p:spPr>
-          <a:xfrm>
-            <a:off x="2331618" y="4572000"/>
-            <a:ext cx="1947570" cy="457200"/>
-          </a:xfrm>
-          <a:prstGeom prst="rect">
-            <a:avLst/>
-          </a:prstGeom>
-          <a:noFill/>
-          <a:ln/>
-        </p:spPr>
-        <p:txBody>
-          <a:bodyPr wrap="square" lIns="0" tIns="0" rIns="0" bIns="0" rtlCol="0" anchor="t"/>
+          <p:cNvPr id="10" name="Text 6"/>
+          <p:cNvSpPr txBox="1"/>
+          <p:nvPr/>
+        </p:nvSpPr>
+        <p:spPr>
+          <a:xfrm>
+            <a:off x="2241487" y="4507992"/>
+            <a:ext cx="1994599" cy="256032"/>
+          </a:xfrm>
+          <a:prstGeom prst="rect">
+            <a:avLst/>
+          </a:prstGeom>
+          <a:noFill/>
+          <a:ln/>
+        </p:spPr>
+        <p:txBody>
+          <a:bodyPr wrap="square" lIns="0" tIns="0" rIns="0" bIns="0" rtlCol="0" anchor="ctr"/>
           <a:lstStyle/>
           <a:p>
             <a:pPr algn="ctr" indent="0" marL="0">
               <a:buNone/>
             </a:pPr>
             <a:r>
-              <a:rPr lang="en-US" sz="1200" dirty="0">
+              <a:rPr lang="en-US" sz="1300" b="1" dirty="0">
+                <a:solidFill>
+                  <a:srgbClr val="111827"/>
+                </a:solidFill>
+                <a:latin typeface="Arial" pitchFamily="34" charset="0"/>
+                <a:ea typeface="Arial" pitchFamily="34" charset="-122"/>
+                <a:cs typeface="Arial" pitchFamily="34" charset="-120"/>
+              </a:rPr>
+              <a:t>A few questions</a:t>
+            </a:r>
+            <a:endParaRPr lang="en-US" sz="1300" dirty="0"/>
+          </a:p>
+        </p:txBody>
+      </p:sp>
+      <p:sp>
+        <p:nvSpPr>
+          <p:cNvPr id="11" name="Text 7"/>
+          <p:cNvSpPr txBox="1"/>
+          <p:nvPr/>
+        </p:nvSpPr>
+        <p:spPr>
+          <a:xfrm>
+            <a:off x="2241487" y="4764024"/>
+            <a:ext cx="1994599" cy="274320"/>
+          </a:xfrm>
+          <a:prstGeom prst="rect">
+            <a:avLst/>
+          </a:prstGeom>
+          <a:noFill/>
+          <a:ln/>
+        </p:spPr>
+        <p:txBody>
+          <a:bodyPr wrap="square" lIns="0" tIns="0" rIns="0" bIns="0" rtlCol="0" anchor="ctr"/>
+          <a:lstStyle/>
+          <a:p>
+            <a:pPr algn="ctr" indent="0" marL="0">
+              <a:buNone/>
+            </a:pPr>
+            <a:r>
+              <a:rPr lang="en-US" sz="1000" dirty="0">
                 <a:solidFill>
                   <a:srgbClr val="4B5563"/>
                 </a:solidFill>
@@ -3244,26 +3376,26 @@
                 <a:ea typeface="Arial" pitchFamily="34" charset="-122"/>
                 <a:cs typeface="Arial" pitchFamily="34" charset="-120"/>
               </a:rPr>
-              <a:t>2  A few questions</a:t>
-            </a:r>
-            <a:endParaRPr lang="en-US" sz="1200" dirty="0"/>
-          </a:p>
-        </p:txBody>
-      </p:sp>
-      <p:sp>
-        <p:nvSpPr>
-          <p:cNvPr id="10" name="Shape 6"/>
+              <a:t>her own words · latency</a:t>
+            </a:r>
+            <a:endParaRPr lang="en-US" sz="1000" dirty="0"/>
+          </a:p>
+        </p:txBody>
+      </p:sp>
+      <p:sp>
+        <p:nvSpPr>
+          <p:cNvPr id="12" name="Shape 8"/>
           <p:cNvSpPr/>
           <p:nvPr/>
         </p:nvSpPr>
         <p:spPr>
           <a:xfrm>
-            <a:off x="4608371" y="1545336"/>
-            <a:ext cx="1508658" cy="2990088"/>
+            <a:off x="4519550" y="1572768"/>
+            <a:ext cx="1464247" cy="2898648"/>
           </a:xfrm>
           <a:prstGeom prst="roundRect">
             <a:avLst>
-              <a:gd name="adj" fmla="val 13334"/>
+              <a:gd name="adj" fmla="val 13739"/>
             </a:avLst>
           </a:prstGeom>
           <a:solidFill>
@@ -3279,7 +3411,7 @@
       </p:sp>
       <p:pic>
         <p:nvPicPr>
-          <p:cNvPr id="11" name="Image 2" descr="../shots/07-puzzle-anna-c.png">    </p:cNvPr>
+          <p:cNvPr id="13" name="Image 2" descr="../shots/07-puzzle-anna-c.png">    </p:cNvPr>
           <p:cNvPicPr>
             <a:picLocks noChangeAspect="1"/>
           </p:cNvPicPr>
@@ -3293,8 +3425,8 @@
         </p:blipFill>
         <p:spPr>
           <a:xfrm>
-            <a:off x="4663235" y="1600200"/>
-            <a:ext cx="1398930" cy="2880360"/>
+            <a:off x="4574414" y="1627632"/>
+            <a:ext cx="1354519" cy="2788920"/>
           </a:xfrm>
           <a:prstGeom prst="rect">
             <a:avLst/>
@@ -3303,30 +3435,69 @@
       </p:pic>
       <p:sp>
         <p:nvSpPr>
-          <p:cNvPr id="12" name="Text 7"/>
-          <p:cNvSpPr txBox="1"/>
-          <p:nvPr/>
-        </p:nvSpPr>
-        <p:spPr>
-          <a:xfrm>
-            <a:off x="4388915" y="4572000"/>
-            <a:ext cx="1947570" cy="457200"/>
-          </a:xfrm>
-          <a:prstGeom prst="rect">
-            <a:avLst/>
-          </a:prstGeom>
-          <a:noFill/>
-          <a:ln/>
-        </p:spPr>
-        <p:txBody>
-          <a:bodyPr wrap="square" lIns="0" tIns="0" rIns="0" bIns="0" rtlCol="0" anchor="t"/>
+          <p:cNvPr id="14" name="Text 9"/>
+          <p:cNvSpPr txBox="1"/>
+          <p:nvPr/>
+        </p:nvSpPr>
+        <p:spPr>
+          <a:xfrm>
+            <a:off x="4254374" y="4507992"/>
+            <a:ext cx="1994599" cy="256032"/>
+          </a:xfrm>
+          <a:prstGeom prst="rect">
+            <a:avLst/>
+          </a:prstGeom>
+          <a:noFill/>
+          <a:ln/>
+        </p:spPr>
+        <p:txBody>
+          <a:bodyPr wrap="square" lIns="0" tIns="0" rIns="0" bIns="0" rtlCol="0" anchor="ctr"/>
           <a:lstStyle/>
           <a:p>
             <a:pPr algn="ctr" indent="0" marL="0">
               <a:buNone/>
             </a:pPr>
             <a:r>
-              <a:rPr lang="en-US" sz="1200" dirty="0">
+              <a:rPr lang="en-US" sz="1300" b="1" dirty="0">
+                <a:solidFill>
+                  <a:srgbClr val="111827"/>
+                </a:solidFill>
+                <a:latin typeface="Arial" pitchFamily="34" charset="0"/>
+                <a:ea typeface="Arial" pitchFamily="34" charset="-122"/>
+                <a:cs typeface="Arial" pitchFamily="34" charset="-120"/>
+              </a:rPr>
+              <a:t>A puzzle, with Anna</a:t>
+            </a:r>
+            <a:endParaRPr lang="en-US" sz="1300" dirty="0"/>
+          </a:p>
+        </p:txBody>
+      </p:sp>
+      <p:sp>
+        <p:nvSpPr>
+          <p:cNvPr id="15" name="Text 10"/>
+          <p:cNvSpPr txBox="1"/>
+          <p:nvPr/>
+        </p:nvSpPr>
+        <p:spPr>
+          <a:xfrm>
+            <a:off x="4254374" y="4764024"/>
+            <a:ext cx="1994599" cy="274320"/>
+          </a:xfrm>
+          <a:prstGeom prst="rect">
+            <a:avLst/>
+          </a:prstGeom>
+          <a:noFill/>
+          <a:ln/>
+        </p:spPr>
+        <p:txBody>
+          <a:bodyPr wrap="square" lIns="0" tIns="0" rIns="0" bIns="0" rtlCol="0" anchor="ctr"/>
+          <a:lstStyle/>
+          <a:p>
+            <a:pPr algn="ctr" indent="0" marL="0">
+              <a:buNone/>
+            </a:pPr>
+            <a:r>
+              <a:rPr lang="en-US" sz="1000" dirty="0">
                 <a:solidFill>
                   <a:srgbClr val="4B5563"/>
                 </a:solidFill>
@@ -3334,26 +3505,26 @@
                 <a:ea typeface="Arial" pitchFamily="34" charset="-122"/>
                 <a:cs typeface="Arial" pitchFamily="34" charset="-120"/>
               </a:rPr>
-              <a:t>3  A puzzle, with Anna</a:t>
-            </a:r>
-            <a:endParaRPr lang="en-US" sz="1200" dirty="0"/>
-          </a:p>
-        </p:txBody>
-      </p:sp>
-      <p:sp>
-        <p:nvSpPr>
-          <p:cNvPr id="13" name="Shape 8"/>
+              <a:t>attention · space · company</a:t>
+            </a:r>
+            <a:endParaRPr lang="en-US" sz="1000" dirty="0"/>
+          </a:p>
+        </p:txBody>
+      </p:sp>
+      <p:sp>
+        <p:nvSpPr>
+          <p:cNvPr id="16" name="Shape 11"/>
           <p:cNvSpPr/>
           <p:nvPr/>
         </p:nvSpPr>
         <p:spPr>
           <a:xfrm>
-            <a:off x="6665669" y="1545336"/>
-            <a:ext cx="1508658" cy="2990088"/>
+            <a:off x="6532437" y="1572768"/>
+            <a:ext cx="1464247" cy="2898648"/>
           </a:xfrm>
           <a:prstGeom prst="roundRect">
             <a:avLst>
-              <a:gd name="adj" fmla="val 13334"/>
+              <a:gd name="adj" fmla="val 13739"/>
             </a:avLst>
           </a:prstGeom>
           <a:solidFill>
@@ -3369,7 +3540,7 @@
       </p:sp>
       <p:pic>
         <p:nvPicPr>
-          <p:cNvPr id="14" name="Image 3" descr="../shots/08-goodbye-c.png">    </p:cNvPr>
+          <p:cNvPr id="17" name="Image 3" descr="../shots/08-goodbye-c.png">    </p:cNvPr>
           <p:cNvPicPr>
             <a:picLocks noChangeAspect="1"/>
           </p:cNvPicPr>
@@ -3383,8 +3554,8 @@
         </p:blipFill>
         <p:spPr>
           <a:xfrm>
-            <a:off x="6720533" y="1600200"/>
-            <a:ext cx="1398930" cy="2880360"/>
+            <a:off x="6587301" y="1627632"/>
+            <a:ext cx="1354519" cy="2788920"/>
           </a:xfrm>
           <a:prstGeom prst="rect">
             <a:avLst/>
@@ -3393,30 +3564,69 @@
       </p:pic>
       <p:sp>
         <p:nvSpPr>
-          <p:cNvPr id="15" name="Text 9"/>
-          <p:cNvSpPr txBox="1"/>
-          <p:nvPr/>
-        </p:nvSpPr>
-        <p:spPr>
-          <a:xfrm>
-            <a:off x="6446213" y="4572000"/>
-            <a:ext cx="1947570" cy="457200"/>
-          </a:xfrm>
-          <a:prstGeom prst="rect">
-            <a:avLst/>
-          </a:prstGeom>
-          <a:noFill/>
-          <a:ln/>
-        </p:spPr>
-        <p:txBody>
-          <a:bodyPr wrap="square" lIns="0" tIns="0" rIns="0" bIns="0" rtlCol="0" anchor="t"/>
+          <p:cNvPr id="18" name="Text 12"/>
+          <p:cNvSpPr txBox="1"/>
+          <p:nvPr/>
+        </p:nvSpPr>
+        <p:spPr>
+          <a:xfrm>
+            <a:off x="6267261" y="4507992"/>
+            <a:ext cx="1994599" cy="256032"/>
+          </a:xfrm>
+          <a:prstGeom prst="rect">
+            <a:avLst/>
+          </a:prstGeom>
+          <a:noFill/>
+          <a:ln/>
+        </p:spPr>
+        <p:txBody>
+          <a:bodyPr wrap="square" lIns="0" tIns="0" rIns="0" bIns="0" rtlCol="0" anchor="ctr"/>
           <a:lstStyle/>
           <a:p>
             <a:pPr algn="ctr" indent="0" marL="0">
               <a:buNone/>
             </a:pPr>
             <a:r>
-              <a:rPr lang="en-US" sz="1200" dirty="0">
+              <a:rPr lang="en-US" sz="1300" b="1" dirty="0">
+                <a:solidFill>
+                  <a:srgbClr val="111827"/>
+                </a:solidFill>
+                <a:latin typeface="Arial" pitchFamily="34" charset="0"/>
+                <a:ea typeface="Arial" pitchFamily="34" charset="-122"/>
+                <a:cs typeface="Arial" pitchFamily="34" charset="-120"/>
+              </a:rPr>
+              <a:t>Goodbye</a:t>
+            </a:r>
+            <a:endParaRPr lang="en-US" sz="1300" dirty="0"/>
+          </a:p>
+        </p:txBody>
+      </p:sp>
+      <p:sp>
+        <p:nvSpPr>
+          <p:cNvPr id="19" name="Text 13"/>
+          <p:cNvSpPr txBox="1"/>
+          <p:nvPr/>
+        </p:nvSpPr>
+        <p:spPr>
+          <a:xfrm>
+            <a:off x="6267261" y="4764024"/>
+            <a:ext cx="1994599" cy="274320"/>
+          </a:xfrm>
+          <a:prstGeom prst="rect">
+            <a:avLst/>
+          </a:prstGeom>
+          <a:noFill/>
+          <a:ln/>
+        </p:spPr>
+        <p:txBody>
+          <a:bodyPr wrap="square" lIns="0" tIns="0" rIns="0" bIns="0" rtlCol="0" anchor="ctr"/>
+          <a:lstStyle/>
+          <a:p>
+            <a:pPr algn="ctr" indent="0" marL="0">
+              <a:buNone/>
+            </a:pPr>
+            <a:r>
+              <a:rPr lang="en-US" sz="1000" dirty="0">
                 <a:solidFill>
                   <a:srgbClr val="4B5563"/>
                 </a:solidFill>
@@ -3424,9 +3634,9 @@
                 <a:ea typeface="Arial" pitchFamily="34" charset="-122"/>
                 <a:cs typeface="Arial" pitchFamily="34" charset="-120"/>
               </a:rPr>
-              <a:t>4  Goodbye</a:t>
-            </a:r>
-            <a:endParaRPr lang="en-US" sz="1200" dirty="0"/>
+              <a:t>did she come · how fast</a:t>
+            </a:r>
+            <a:endParaRPr lang="en-US" sz="1000" dirty="0"/>
           </a:p>
         </p:txBody>
       </p:sp>
@@ -3487,7 +3697,7 @@
               <a:buNone/>
             </a:pPr>
             <a:r>
-              <a:rPr lang="en-US" sz="3400" b="1" dirty="0">
+              <a:rPr lang="en-US" sz="3200" b="1" dirty="0">
                 <a:solidFill>
                   <a:srgbClr val="111827"/>
                 </a:solidFill>
@@ -3497,7 +3707,7 @@
               </a:rPr>
               <a:t>What the phone saw.</a:t>
             </a:r>
-            <a:endParaRPr lang="en-US" sz="3400" dirty="0"/>
+            <a:endParaRPr lang="en-US" sz="3200" dirty="0"/>
           </a:p>
         </p:txBody>
       </p:sp>
@@ -3510,19 +3720,19 @@
         <p:spPr>
           <a:xfrm>
             <a:off x="548640" y="1051560"/>
-            <a:ext cx="4480560" cy="1188720"/>
+            <a:ext cx="4480560" cy="960120"/>
           </a:xfrm>
           <a:prstGeom prst="roundRect">
             <a:avLst>
-              <a:gd name="adj" fmla="val 11538"/>
+              <a:gd name="adj" fmla="val 14286"/>
             </a:avLst>
           </a:prstGeom>
           <a:solidFill>
-            <a:srgbClr val="DBEAFE"/>
+            <a:srgbClr val="FDE2E2"/>
           </a:solidFill>
-          <a:ln w="12700">
+          <a:ln w="19050">
             <a:solidFill>
-              <a:srgbClr val="4B5563"/>
+              <a:srgbClr val="C8402F"/>
             </a:solidFill>
             <a:prstDash val="solid"/>
           </a:ln>
@@ -3536,26 +3746,26 @@
         </p:nvSpPr>
         <p:spPr>
           <a:xfrm>
-            <a:off x="731520" y="1143000"/>
-            <a:ext cx="4114800" cy="1005840"/>
-          </a:xfrm>
-          <a:prstGeom prst="rect">
-            <a:avLst/>
-          </a:prstGeom>
-          <a:noFill/>
-          <a:ln/>
-        </p:spPr>
-        <p:txBody>
-          <a:bodyPr wrap="square" lIns="0" tIns="0" rIns="0" bIns="0" rtlCol="0" anchor="ctr"/>
-          <a:lstStyle/>
-          <a:p>
-            <a:pPr indent="0" marL="0">
-              <a:buNone/>
-            </a:pPr>
-            <a:r>
-              <a:rPr lang="en-US" sz="1700" i="1" dirty="0">
-                <a:solidFill>
-                  <a:srgbClr val="1E40AF"/>
+            <a:off x="731520" y="1115568"/>
+            <a:ext cx="4114800" cy="822960"/>
+          </a:xfrm>
+          <a:prstGeom prst="rect">
+            <a:avLst/>
+          </a:prstGeom>
+          <a:noFill/>
+          <a:ln/>
+        </p:spPr>
+        <p:txBody>
+          <a:bodyPr wrap="square" lIns="0" tIns="0" rIns="0" bIns="0" rtlCol="0" anchor="ctr"/>
+          <a:lstStyle/>
+          <a:p>
+            <a:pPr indent="0" marL="0">
+              <a:buNone/>
+            </a:pPr>
+            <a:r>
+              <a:rPr lang="en-US" sz="1600" i="1" dirty="0">
+                <a:solidFill>
+                  <a:srgbClr val="C8402F"/>
                 </a:solidFill>
                 <a:latin typeface="Arial" pitchFamily="34" charset="0"/>
                 <a:ea typeface="Arial" pitchFamily="34" charset="-122"/>
@@ -3563,352 +3773,13 @@
               </a:rPr>
               <a:t>“Margaret’s signature was slower, more hesitant and a different shape than usual today.”</a:t>
             </a:r>
-            <a:endParaRPr lang="en-US" sz="1700" dirty="0"/>
-          </a:p>
-        </p:txBody>
-      </p:sp>
-      <p:sp>
-        <p:nvSpPr>
-          <p:cNvPr id="5" name="Text 3"/>
-          <p:cNvSpPr txBox="1"/>
-          <p:nvPr/>
-        </p:nvSpPr>
-        <p:spPr>
-          <a:xfrm>
-            <a:off x="548640" y="2423160"/>
-            <a:ext cx="1554480" cy="548640"/>
-          </a:xfrm>
-          <a:prstGeom prst="rect">
-            <a:avLst/>
-          </a:prstGeom>
-          <a:noFill/>
-          <a:ln/>
-        </p:spPr>
-        <p:txBody>
-          <a:bodyPr wrap="square" lIns="0" tIns="0" rIns="0" bIns="0" rtlCol="0" anchor="ctr"/>
-          <a:lstStyle/>
-          <a:p>
-            <a:pPr indent="0" marL="0">
-              <a:buNone/>
-            </a:pPr>
-            <a:r>
-              <a:rPr lang="en-US" sz="1300" b="1" dirty="0">
-                <a:solidFill>
-                  <a:srgbClr val="111827"/>
-                </a:solidFill>
-                <a:latin typeface="Arial" pitchFamily="34" charset="0"/>
-                <a:ea typeface="Arial" pitchFamily="34" charset="-122"/>
-                <a:cs typeface="Arial" pitchFamily="34" charset="-120"/>
-              </a:rPr>
-              <a:t>Her own baseline</a:t>
-            </a:r>
-            <a:endParaRPr lang="en-US" sz="1300" dirty="0"/>
-          </a:p>
-        </p:txBody>
-      </p:sp>
-      <p:sp>
-        <p:nvSpPr>
-          <p:cNvPr id="6" name="Text 4"/>
-          <p:cNvSpPr txBox="1"/>
-          <p:nvPr/>
-        </p:nvSpPr>
-        <p:spPr>
-          <a:xfrm>
-            <a:off x="2103120" y="2423160"/>
-            <a:ext cx="2926080" cy="548640"/>
-          </a:xfrm>
-          <a:prstGeom prst="rect">
-            <a:avLst/>
-          </a:prstGeom>
-          <a:noFill/>
-          <a:ln/>
-        </p:spPr>
-        <p:txBody>
-          <a:bodyPr wrap="square" lIns="0" tIns="0" rIns="0" bIns="0" rtlCol="0" anchor="ctr"/>
-          <a:lstStyle/>
-          <a:p>
-            <a:pPr indent="0" marL="0">
-              <a:buNone/>
-            </a:pPr>
-            <a:r>
-              <a:rPr lang="en-US" sz="1100" dirty="0">
-                <a:solidFill>
-                  <a:srgbClr val="4B5563"/>
-                </a:solidFill>
-                <a:latin typeface="Arial" pitchFamily="34" charset="0"/>
-                <a:ea typeface="Arial" pitchFamily="34" charset="-122"/>
-                <a:cs typeface="Arial" pitchFamily="34" charset="-120"/>
-              </a:rPr>
-              <a:t>Five signings, median and spread per feature. No population norms; delirium is a change from your usual.</a:t>
-            </a:r>
-            <a:endParaRPr lang="en-US" sz="1100" dirty="0"/>
-          </a:p>
-        </p:txBody>
-      </p:sp>
-      <p:sp>
-        <p:nvSpPr>
-          <p:cNvPr id="7" name="Text 5"/>
-          <p:cNvSpPr txBox="1"/>
-          <p:nvPr/>
-        </p:nvSpPr>
-        <p:spPr>
-          <a:xfrm>
-            <a:off x="548640" y="3026664"/>
-            <a:ext cx="1554480" cy="548640"/>
-          </a:xfrm>
-          <a:prstGeom prst="rect">
-            <a:avLst/>
-          </a:prstGeom>
-          <a:noFill/>
-          <a:ln/>
-        </p:spPr>
-        <p:txBody>
-          <a:bodyPr wrap="square" lIns="0" tIns="0" rIns="0" bIns="0" rtlCol="0" anchor="ctr"/>
-          <a:lstStyle/>
-          <a:p>
-            <a:pPr indent="0" marL="0">
-              <a:buNone/>
-            </a:pPr>
-            <a:r>
-              <a:rPr lang="en-US" sz="1300" b="1" dirty="0">
-                <a:solidFill>
-                  <a:srgbClr val="111827"/>
-                </a:solidFill>
-                <a:latin typeface="Arial" pitchFamily="34" charset="0"/>
-                <a:ea typeface="Arial" pitchFamily="34" charset="-122"/>
-                <a:cs typeface="Arial" pitchFamily="34" charset="-120"/>
-              </a:rPr>
-              <a:t>Nine features</a:t>
-            </a:r>
-            <a:endParaRPr lang="en-US" sz="1300" dirty="0"/>
-          </a:p>
-        </p:txBody>
-      </p:sp>
-      <p:sp>
-        <p:nvSpPr>
-          <p:cNvPr id="8" name="Text 6"/>
-          <p:cNvSpPr txBox="1"/>
-          <p:nvPr/>
-        </p:nvSpPr>
-        <p:spPr>
-          <a:xfrm>
-            <a:off x="2103120" y="3026664"/>
-            <a:ext cx="2926080" cy="548640"/>
-          </a:xfrm>
-          <a:prstGeom prst="rect">
-            <a:avLst/>
-          </a:prstGeom>
-          <a:noFill/>
-          <a:ln/>
-        </p:spPr>
-        <p:txBody>
-          <a:bodyPr wrap="square" lIns="0" tIns="0" rIns="0" bIns="0" rtlCol="0" anchor="ctr"/>
-          <a:lstStyle/>
-          <a:p>
-            <a:pPr indent="0" marL="0">
-              <a:buNone/>
-            </a:pPr>
-            <a:r>
-              <a:rPr lang="en-US" sz="1100" dirty="0">
-                <a:solidFill>
-                  <a:srgbClr val="4B5563"/>
-                </a:solidFill>
-                <a:latin typeface="Arial" pitchFamily="34" charset="0"/>
-                <a:ea typeface="Arial" pitchFamily="34" charset="-122"/>
-                <a:cs typeface="Arial" pitchFamily="34" charset="-120"/>
-              </a:rPr>
-              <a:t>Time to start, total time, pauses, strokes, speed, smoothness, size, shape.</a:t>
-            </a:r>
-            <a:endParaRPr lang="en-US" sz="1100" dirty="0"/>
-          </a:p>
-        </p:txBody>
-      </p:sp>
-      <p:sp>
-        <p:nvSpPr>
-          <p:cNvPr id="9" name="Text 7"/>
-          <p:cNvSpPr txBox="1"/>
-          <p:nvPr/>
-        </p:nvSpPr>
-        <p:spPr>
-          <a:xfrm>
-            <a:off x="548640" y="3630168"/>
-            <a:ext cx="1554480" cy="548640"/>
-          </a:xfrm>
-          <a:prstGeom prst="rect">
-            <a:avLst/>
-          </a:prstGeom>
-          <a:noFill/>
-          <a:ln/>
-        </p:spPr>
-        <p:txBody>
-          <a:bodyPr wrap="square" lIns="0" tIns="0" rIns="0" bIns="0" rtlCol="0" anchor="ctr"/>
-          <a:lstStyle/>
-          <a:p>
-            <a:pPr indent="0" marL="0">
-              <a:buNone/>
-            </a:pPr>
-            <a:r>
-              <a:rPr lang="en-US" sz="1300" b="1" dirty="0">
-                <a:solidFill>
-                  <a:srgbClr val="111827"/>
-                </a:solidFill>
-                <a:latin typeface="Arial" pitchFamily="34" charset="0"/>
-                <a:ea typeface="Arial" pitchFamily="34" charset="-122"/>
-                <a:cs typeface="Arial" pitchFamily="34" charset="-120"/>
-              </a:rPr>
-              <a:t>Robust z</a:t>
-            </a:r>
-            <a:endParaRPr lang="en-US" sz="1300" dirty="0"/>
-          </a:p>
-        </p:txBody>
-      </p:sp>
-      <p:sp>
-        <p:nvSpPr>
-          <p:cNvPr id="10" name="Text 8"/>
-          <p:cNvSpPr txBox="1"/>
-          <p:nvPr/>
-        </p:nvSpPr>
-        <p:spPr>
-          <a:xfrm>
-            <a:off x="2103120" y="3630168"/>
-            <a:ext cx="2926080" cy="548640"/>
-          </a:xfrm>
-          <a:prstGeom prst="rect">
-            <a:avLst/>
-          </a:prstGeom>
-          <a:noFill/>
-          <a:ln/>
-        </p:spPr>
-        <p:txBody>
-          <a:bodyPr wrap="square" lIns="0" tIns="0" rIns="0" bIns="0" rtlCol="0" anchor="ctr"/>
-          <a:lstStyle/>
-          <a:p>
-            <a:pPr indent="0" marL="0">
-              <a:buNone/>
-            </a:pPr>
-            <a:r>
-              <a:rPr lang="en-US" sz="1100" dirty="0">
-                <a:solidFill>
-                  <a:srgbClr val="4B5563"/>
-                </a:solidFill>
-                <a:latin typeface="Arial" pitchFamily="34" charset="0"/>
-                <a:ea typeface="Arial" pitchFamily="34" charset="-122"/>
-                <a:cs typeface="Arial" pitchFamily="34" charset="-120"/>
-              </a:rPr>
-              <a:t>Today minus usual, over the spread. Two features past 2 is different from usual; three days is a trend.</a:t>
-            </a:r>
-            <a:endParaRPr lang="en-US" sz="1100" dirty="0"/>
-          </a:p>
-        </p:txBody>
-      </p:sp>
-      <p:sp>
-        <p:nvSpPr>
-          <p:cNvPr id="11" name="Text 9"/>
-          <p:cNvSpPr txBox="1"/>
-          <p:nvPr/>
-        </p:nvSpPr>
-        <p:spPr>
-          <a:xfrm>
-            <a:off x="548640" y="4233672"/>
-            <a:ext cx="1554480" cy="548640"/>
-          </a:xfrm>
-          <a:prstGeom prst="rect">
-            <a:avLst/>
-          </a:prstGeom>
-          <a:noFill/>
-          <a:ln/>
-        </p:spPr>
-        <p:txBody>
-          <a:bodyPr wrap="square" lIns="0" tIns="0" rIns="0" bIns="0" rtlCol="0" anchor="ctr"/>
-          <a:lstStyle/>
-          <a:p>
-            <a:pPr indent="0" marL="0">
-              <a:buNone/>
-            </a:pPr>
-            <a:r>
-              <a:rPr lang="en-US" sz="1300" b="1" dirty="0">
-                <a:solidFill>
-                  <a:srgbClr val="111827"/>
-                </a:solidFill>
-                <a:latin typeface="Arial" pitchFamily="34" charset="0"/>
-                <a:ea typeface="Arial" pitchFamily="34" charset="-122"/>
-                <a:cs typeface="Arial" pitchFamily="34" charset="-120"/>
-              </a:rPr>
-              <a:t>Who sees it</a:t>
-            </a:r>
-            <a:endParaRPr lang="en-US" sz="1300" dirty="0"/>
-          </a:p>
-        </p:txBody>
-      </p:sp>
-      <p:sp>
-        <p:nvSpPr>
-          <p:cNvPr id="12" name="Text 10"/>
-          <p:cNvSpPr txBox="1"/>
-          <p:nvPr/>
-        </p:nvSpPr>
-        <p:spPr>
-          <a:xfrm>
-            <a:off x="2103120" y="4233672"/>
-            <a:ext cx="2926080" cy="548640"/>
-          </a:xfrm>
-          <a:prstGeom prst="rect">
-            <a:avLst/>
-          </a:prstGeom>
-          <a:noFill/>
-          <a:ln/>
-        </p:spPr>
-        <p:txBody>
-          <a:bodyPr wrap="square" lIns="0" tIns="0" rIns="0" bIns="0" rtlCol="0" anchor="ctr"/>
-          <a:lstStyle/>
-          <a:p>
-            <a:pPr indent="0" marL="0">
-              <a:buNone/>
-            </a:pPr>
-            <a:r>
-              <a:rPr lang="en-US" sz="1100" dirty="0">
-                <a:solidFill>
-                  <a:srgbClr val="4B5563"/>
-                </a:solidFill>
-                <a:latin typeface="Arial" pitchFamily="34" charset="0"/>
-                <a:ea typeface="Arial" pitchFamily="34" charset="-122"/>
-                <a:cs typeface="Arial" pitchFamily="34" charset="-120"/>
-              </a:rPr>
-              <a:t>The family and the clinic. Margaret sees a thank-you and her page in the book.</a:t>
-            </a:r>
-            <a:endParaRPr lang="en-US" sz="1100" dirty="0"/>
-          </a:p>
-        </p:txBody>
-      </p:sp>
-      <p:sp>
-        <p:nvSpPr>
-          <p:cNvPr id="13" name="Shape 11"/>
-          <p:cNvSpPr/>
-          <p:nvPr/>
-        </p:nvSpPr>
-        <p:spPr>
-          <a:xfrm>
-            <a:off x="5349240" y="411480"/>
-            <a:ext cx="3429000" cy="4343400"/>
-          </a:xfrm>
-          <a:prstGeom prst="roundRect">
-            <a:avLst>
-              <a:gd name="adj" fmla="val 4000"/>
-            </a:avLst>
-          </a:prstGeom>
-          <a:solidFill>
-            <a:srgbClr val="F3F4F6"/>
-          </a:solidFill>
-          <a:ln w="12700">
-            <a:solidFill>
-              <a:srgbClr val="4B5563"/>
-            </a:solidFill>
-            <a:prstDash val="solid"/>
-          </a:ln>
-        </p:spPr>
+            <a:endParaRPr lang="en-US" sz="1600" dirty="0"/>
+          </a:p>
+        </p:txBody>
       </p:sp>
       <p:pic>
         <p:nvPicPr>
-          <p:cNvPr id="14" name="Image 0" descr="../shots/backend-fit.png">    </p:cNvPr>
+          <p:cNvPr id="5" name="Image 0" descr="../shots/14-sig-baseline.png">    </p:cNvPr>
           <p:cNvPicPr>
             <a:picLocks noChangeAspect="1"/>
           </p:cNvPicPr>
@@ -3922,8 +3793,275 @@
         </p:blipFill>
         <p:spPr>
           <a:xfrm>
-            <a:off x="5486400" y="548640"/>
-            <a:ext cx="3154680" cy="3959781"/>
+            <a:off x="548640" y="2194560"/>
+            <a:ext cx="2103120" cy="1488057"/>
+          </a:xfrm>
+          <a:prstGeom prst="rect">
+            <a:avLst/>
+          </a:prstGeom>
+        </p:spPr>
+      </p:pic>
+      <p:pic>
+        <p:nvPicPr>
+          <p:cNvPr id="6" name="Image 1" descr="../shots/15-sig-today.png">    </p:cNvPr>
+          <p:cNvPicPr>
+            <a:picLocks noChangeAspect="1"/>
+          </p:cNvPicPr>
+          <p:nvPr/>
+        </p:nvPicPr>
+        <p:blipFill>
+          <a:blip r:embed="rId2"/>
+          <a:stretch>
+            <a:fillRect/>
+          </a:stretch>
+        </p:blipFill>
+        <p:spPr>
+          <a:xfrm>
+            <a:off x="2926080" y="2194560"/>
+            <a:ext cx="2103120" cy="1488057"/>
+          </a:xfrm>
+          <a:prstGeom prst="rect">
+            <a:avLst/>
+          </a:prstGeom>
+        </p:spPr>
+      </p:pic>
+      <p:sp>
+        <p:nvSpPr>
+          <p:cNvPr id="7" name="Text 3"/>
+          <p:cNvSpPr txBox="1"/>
+          <p:nvPr/>
+        </p:nvSpPr>
+        <p:spPr>
+          <a:xfrm>
+            <a:off x="548640" y="3794760"/>
+            <a:ext cx="4480560" cy="365760"/>
+          </a:xfrm>
+          <a:prstGeom prst="rect">
+            <a:avLst/>
+          </a:prstGeom>
+          <a:noFill/>
+          <a:ln/>
+        </p:spPr>
+        <p:txBody>
+          <a:bodyPr wrap="square" lIns="0" tIns="0" rIns="0" bIns="0" rtlCol="0" anchor="ctr"/>
+          <a:lstStyle/>
+          <a:p>
+            <a:pPr indent="0" marL="0">
+              <a:buNone/>
+            </a:pPr>
+            <a:r>
+              <a:rPr lang="en-US" sz="1300" b="1" dirty="0">
+                <a:solidFill>
+                  <a:srgbClr val="111827"/>
+                </a:solidFill>
+                <a:latin typeface="Arial" pitchFamily="34" charset="0"/>
+                <a:ea typeface="Arial" pitchFamily="34" charset="-122"/>
+                <a:cs typeface="Arial" pitchFamily="34" charset="-120"/>
+              </a:rPr>
+              <a:t>Her usual, and today. It looks the same. It wasn’t.</a:t>
+            </a:r>
+            <a:endParaRPr lang="en-US" sz="1300" dirty="0"/>
+          </a:p>
+        </p:txBody>
+      </p:sp>
+      <p:sp>
+        <p:nvSpPr>
+          <p:cNvPr id="8" name="Text 4"/>
+          <p:cNvSpPr txBox="1"/>
+          <p:nvPr/>
+        </p:nvSpPr>
+        <p:spPr>
+          <a:xfrm>
+            <a:off x="548640" y="4206240"/>
+            <a:ext cx="4480560" cy="457200"/>
+          </a:xfrm>
+          <a:prstGeom prst="rect">
+            <a:avLst/>
+          </a:prstGeom>
+          <a:noFill/>
+          <a:ln/>
+        </p:spPr>
+        <p:txBody>
+          <a:bodyPr wrap="square" lIns="0" tIns="0" rIns="0" bIns="0" rtlCol="0" anchor="ctr"/>
+          <a:lstStyle/>
+          <a:p>
+            <a:pPr indent="0" marL="0">
+              <a:buNone/>
+            </a:pPr>
+            <a:r>
+              <a:rPr lang="en-US" sz="1100" dirty="0">
+                <a:solidFill>
+                  <a:srgbClr val="4B5563"/>
+                </a:solidFill>
+                <a:latin typeface="Arial" pitchFamily="34" charset="0"/>
+                <a:ea typeface="Arial" pitchFamily="34" charset="-122"/>
+                <a:cs typeface="Arial" pitchFamily="34" charset="-120"/>
+              </a:rPr>
+              <a:t>What the family sees. Margaret sees a thank-you and her page in the book.</a:t>
+            </a:r>
+            <a:endParaRPr lang="en-US" sz="1100" dirty="0"/>
+          </a:p>
+        </p:txBody>
+      </p:sp>
+      <p:pic>
+        <p:nvPicPr>
+          <p:cNvPr id="9" name="Image 2" descr="../shots/ztable-5.png">    </p:cNvPr>
+          <p:cNvPicPr>
+            <a:picLocks noChangeAspect="1"/>
+          </p:cNvPicPr>
+          <p:nvPr/>
+        </p:nvPicPr>
+        <p:blipFill>
+          <a:blip r:embed="rId3"/>
+          <a:stretch>
+            <a:fillRect/>
+          </a:stretch>
+        </p:blipFill>
+        <p:spPr>
+          <a:xfrm>
+            <a:off x="5349240" y="1051560"/>
+            <a:ext cx="3429000" cy="1330083"/>
+          </a:xfrm>
+          <a:prstGeom prst="rect">
+            <a:avLst/>
+          </a:prstGeom>
+        </p:spPr>
+      </p:pic>
+      <p:sp>
+        <p:nvSpPr>
+          <p:cNvPr id="10" name="Text 5"/>
+          <p:cNvSpPr txBox="1"/>
+          <p:nvPr/>
+        </p:nvSpPr>
+        <p:spPr>
+          <a:xfrm>
+            <a:off x="5349240" y="2514600"/>
+            <a:ext cx="3429000" cy="685800"/>
+          </a:xfrm>
+          <a:prstGeom prst="rect">
+            <a:avLst/>
+          </a:prstGeom>
+          <a:noFill/>
+          <a:ln/>
+        </p:spPr>
+        <p:txBody>
+          <a:bodyPr wrap="square" lIns="0" tIns="0" rIns="0" bIns="0" rtlCol="0" anchor="ctr"/>
+          <a:lstStyle/>
+          <a:p>
+            <a:pPr indent="0" marL="0">
+              <a:buNone/>
+            </a:pPr>
+            <a:r>
+              <a:rPr lang="en-US" sz="1100" dirty="0">
+                <a:solidFill>
+                  <a:srgbClr val="4B5563"/>
+                </a:solidFill>
+                <a:latin typeface="Arial" pitchFamily="34" charset="0"/>
+                <a:ea typeface="Arial" pitchFamily="34" charset="-122"/>
+                <a:cs typeface="Arial" pitchFamily="34" charset="-120"/>
+              </a:rPr>
+              <a:t>Nine features against her own five-day baseline: time to start, total time, pauses, strokes, speed, smoothness, size, shape.</a:t>
+            </a:r>
+            <a:endParaRPr lang="en-US" sz="1100" dirty="0"/>
+          </a:p>
+        </p:txBody>
+      </p:sp>
+      <p:sp>
+        <p:nvSpPr>
+          <p:cNvPr id="11" name="Text 6"/>
+          <p:cNvSpPr txBox="1"/>
+          <p:nvPr/>
+        </p:nvSpPr>
+        <p:spPr>
+          <a:xfrm>
+            <a:off x="5349240" y="3246120"/>
+            <a:ext cx="3429000" cy="685800"/>
+          </a:xfrm>
+          <a:prstGeom prst="rect">
+            <a:avLst/>
+          </a:prstGeom>
+          <a:noFill/>
+          <a:ln/>
+        </p:spPr>
+        <p:txBody>
+          <a:bodyPr wrap="square" lIns="0" tIns="0" rIns="0" bIns="0" rtlCol="0" anchor="ctr"/>
+          <a:lstStyle/>
+          <a:p>
+            <a:pPr indent="0" marL="0">
+              <a:buNone/>
+            </a:pPr>
+            <a:r>
+              <a:rPr lang="en-US" sz="1100" dirty="0">
+                <a:solidFill>
+                  <a:srgbClr val="4B5563"/>
+                </a:solidFill>
+                <a:latin typeface="Arial" pitchFamily="34" charset="0"/>
+                <a:ea typeface="Arial" pitchFamily="34" charset="-122"/>
+                <a:cs typeface="Arial" pitchFamily="34" charset="-120"/>
+              </a:rPr>
+              <a:t>Robust z: today minus her usual, over her usual spread. Well outside on two features is a flag. Three days is a trend.</a:t>
+            </a:r>
+            <a:endParaRPr lang="en-US" sz="1100" dirty="0"/>
+          </a:p>
+        </p:txBody>
+      </p:sp>
+      <p:sp>
+        <p:nvSpPr>
+          <p:cNvPr id="12" name="Text 7"/>
+          <p:cNvSpPr txBox="1"/>
+          <p:nvPr/>
+        </p:nvSpPr>
+        <p:spPr>
+          <a:xfrm>
+            <a:off x="5349240" y="3977640"/>
+            <a:ext cx="3429000" cy="274320"/>
+          </a:xfrm>
+          <a:prstGeom prst="rect">
+            <a:avLst/>
+          </a:prstGeom>
+          <a:noFill/>
+          <a:ln/>
+        </p:spPr>
+        <p:txBody>
+          <a:bodyPr wrap="square" lIns="0" tIns="0" rIns="0" bIns="0" rtlCol="0" anchor="ctr"/>
+          <a:lstStyle/>
+          <a:p>
+            <a:pPr indent="0" marL="0">
+              <a:buNone/>
+            </a:pPr>
+            <a:r>
+              <a:rPr lang="en-US" sz="900" i="1" dirty="0">
+                <a:solidFill>
+                  <a:srgbClr val="9CA3AF"/>
+                </a:solidFill>
+                <a:latin typeface="Arial" pitchFamily="34" charset="0"/>
+                <a:ea typeface="Arial" pitchFamily="34" charset="-122"/>
+                <a:cs typeface="Arial" pitchFamily="34" charset="-120"/>
+              </a:rPr>
+              <a:t>Real numbers from the demo build.</a:t>
+            </a:r>
+            <a:endParaRPr lang="en-US" sz="900" dirty="0"/>
+          </a:p>
+        </p:txBody>
+      </p:sp>
+      <p:pic>
+        <p:nvPicPr>
+          <p:cNvPr id="13" name="Image 3" descr="../shots/doodle-cat-with-no-face-blue.png">    </p:cNvPr>
+          <p:cNvPicPr>
+            <a:picLocks noChangeAspect="1"/>
+          </p:cNvPicPr>
+          <p:nvPr/>
+        </p:nvPicPr>
+        <p:blipFill>
+          <a:blip r:embed="rId4"/>
+          <a:stretch>
+            <a:fillRect/>
+          </a:stretch>
+        </p:blipFill>
+        <p:spPr>
+          <a:xfrm>
+            <a:off x="7818120" y="4069080"/>
+            <a:ext cx="960120" cy="960120"/>
           </a:xfrm>
           <a:prstGeom prst="rect">
             <a:avLst/>
@@ -3971,23 +4109,23 @@
         <p:spPr>
           <a:xfrm>
             <a:off x="548640" y="365760"/>
-            <a:ext cx="5486400" cy="594360"/>
-          </a:xfrm>
-          <a:prstGeom prst="rect">
-            <a:avLst/>
-          </a:prstGeom>
-          <a:noFill/>
-          <a:ln/>
-        </p:spPr>
-        <p:txBody>
-          <a:bodyPr wrap="square" lIns="0" tIns="0" rIns="0" bIns="0" rtlCol="0" anchor="ctr"/>
-          <a:lstStyle/>
-          <a:p>
-            <a:pPr indent="0" marL="0">
-              <a:buNone/>
-            </a:pPr>
-            <a:r>
-              <a:rPr lang="en-US" sz="3400" b="1" dirty="0">
+            <a:ext cx="8046720" cy="594360"/>
+          </a:xfrm>
+          <a:prstGeom prst="rect">
+            <a:avLst/>
+          </a:prstGeom>
+          <a:noFill/>
+          <a:ln/>
+        </p:spPr>
+        <p:txBody>
+          <a:bodyPr wrap="square" lIns="0" tIns="0" rIns="0" bIns="0" rtlCol="0" anchor="ctr"/>
+          <a:lstStyle/>
+          <a:p>
+            <a:pPr indent="0" marL="0">
+              <a:buNone/>
+            </a:pPr>
+            <a:r>
+              <a:rPr lang="en-US" sz="3200" b="1" dirty="0">
                 <a:solidFill>
                   <a:srgbClr val="111827"/>
                 </a:solidFill>
@@ -3995,9 +4133,9 @@
                 <a:ea typeface="Arial" pitchFamily="34" charset="-122"/>
                 <a:cs typeface="Arial" pitchFamily="34" charset="-120"/>
               </a:rPr>
-              <a:t>Why delirium first.</a:t>
-            </a:r>
-            <a:endParaRPr lang="en-US" sz="3400" dirty="0"/>
+              <a:t>Five things, one visit.</a:t>
+            </a:r>
+            <a:endParaRPr lang="en-US" sz="3200" dirty="0"/>
           </a:p>
         </p:txBody>
       </p:sp>
@@ -4009,8 +4147,8 @@
         </p:nvSpPr>
         <p:spPr>
           <a:xfrm>
-            <a:off x="548640" y="960120"/>
-            <a:ext cx="5669280" cy="594360"/>
+            <a:off x="548640" y="914400"/>
+            <a:ext cx="8046720" cy="548640"/>
           </a:xfrm>
           <a:prstGeom prst="rect">
             <a:avLst/>
@@ -4034,7 +4172,7 @@
                 <a:ea typeface="Arial" pitchFamily="34" charset="-122"/>
                 <a:cs typeface="Arial" pitchFamily="34" charset="-120"/>
               </a:rPr>
-              <a:t>Every instrument measures the same four things. None can see the fifth, because nobody re-tests hours later. A daily visit can.</a:t>
+              <a:t>Every bedside instrument checks the first four, once a shift, in hospital. None sees the fifth, because nobody comes back hours later.</a:t>
             </a:r>
             <a:endParaRPr lang="en-US" sz="1500" dirty="0"/>
           </a:p>
@@ -4048,12 +4186,12 @@
         </p:nvSpPr>
         <p:spPr>
           <a:xfrm>
-            <a:off x="548640" y="1691640"/>
-            <a:ext cx="1828800" cy="1188720"/>
+            <a:off x="548640" y="1600200"/>
+            <a:ext cx="2514600" cy="1143000"/>
           </a:xfrm>
           <a:prstGeom prst="roundRect">
             <a:avLst>
-              <a:gd name="adj" fmla="val 11538"/>
+              <a:gd name="adj" fmla="val 12000"/>
             </a:avLst>
           </a:prstGeom>
           <a:solidFill>
@@ -4075,24 +4213,24 @@
         </p:nvSpPr>
         <p:spPr>
           <a:xfrm>
-            <a:off x="685800" y="1801368"/>
-            <a:ext cx="1600200" cy="365760"/>
-          </a:xfrm>
-          <a:prstGeom prst="rect">
-            <a:avLst/>
-          </a:prstGeom>
-          <a:noFill/>
-          <a:ln/>
-        </p:spPr>
-        <p:txBody>
-          <a:bodyPr wrap="square" lIns="0" tIns="0" rIns="0" bIns="0" rtlCol="0" anchor="ctr"/>
-          <a:lstStyle/>
-          <a:p>
-            <a:pPr indent="0" marL="0">
-              <a:buNone/>
-            </a:pPr>
-            <a:r>
-              <a:rPr lang="en-US" sz="1400" b="1" dirty="0">
+            <a:off x="713232" y="1709928"/>
+            <a:ext cx="2194560" cy="347472"/>
+          </a:xfrm>
+          <a:prstGeom prst="rect">
+            <a:avLst/>
+          </a:prstGeom>
+          <a:noFill/>
+          <a:ln/>
+        </p:spPr>
+        <p:txBody>
+          <a:bodyPr wrap="square" lIns="0" tIns="0" rIns="0" bIns="0" rtlCol="0" anchor="ctr"/>
+          <a:lstStyle/>
+          <a:p>
+            <a:pPr indent="0" marL="0">
+              <a:buNone/>
+            </a:pPr>
+            <a:r>
+              <a:rPr lang="en-US" sz="1500" b="1" dirty="0">
                 <a:solidFill>
                   <a:srgbClr val="111827"/>
                 </a:solidFill>
@@ -4102,7 +4240,7 @@
               </a:rPr>
               <a:t>Attention</a:t>
             </a:r>
-            <a:endParaRPr lang="en-US" sz="1400" dirty="0"/>
+            <a:endParaRPr lang="en-US" sz="1500" dirty="0"/>
           </a:p>
         </p:txBody>
       </p:sp>
@@ -4114,24 +4252,24 @@
         </p:nvSpPr>
         <p:spPr>
           <a:xfrm>
-            <a:off x="685800" y="2194560"/>
-            <a:ext cx="1600200" cy="640080"/>
-          </a:xfrm>
-          <a:prstGeom prst="rect">
-            <a:avLst/>
-          </a:prstGeom>
-          <a:noFill/>
-          <a:ln/>
-        </p:spPr>
-        <p:txBody>
-          <a:bodyPr wrap="square" lIns="0" tIns="0" rIns="0" bIns="0" rtlCol="0" anchor="ctr"/>
-          <a:lstStyle/>
-          <a:p>
-            <a:pPr indent="0" marL="0">
-              <a:buNone/>
-            </a:pPr>
-            <a:r>
-              <a:rPr lang="en-US" sz="1050" dirty="0">
+            <a:off x="713232" y="2075688"/>
+            <a:ext cx="2194560" cy="640080"/>
+          </a:xfrm>
+          <a:prstGeom prst="rect">
+            <a:avLst/>
+          </a:prstGeom>
+          <a:noFill/>
+          <a:ln/>
+        </p:spPr>
+        <p:txBody>
+          <a:bodyPr wrap="square" lIns="0" tIns="0" rIns="0" bIns="0" rtlCol="0" anchor="ctr"/>
+          <a:lstStyle/>
+          <a:p>
+            <a:pPr indent="0" marL="0">
+              <a:buNone/>
+            </a:pPr>
+            <a:r>
+              <a:rPr lang="en-US" sz="1100" dirty="0">
                 <a:solidFill>
                   <a:srgbClr val="4B5563"/>
                 </a:solidFill>
@@ -4139,9 +4277,9 @@
                 <a:ea typeface="Arial" pitchFamily="34" charset="-122"/>
                 <a:cs typeface="Arial" pitchFamily="34" charset="-120"/>
               </a:rPr>
-              <a:t>days backwards, search time in the puzzle</a:t>
-            </a:r>
-            <a:endParaRPr lang="en-US" sz="1050" dirty="0"/>
+              <a:t>Days backwards in the chat. Search time between pieces in the puzzle.</a:t>
+            </a:r>
+            <a:endParaRPr lang="en-US" sz="1100" dirty="0"/>
           </a:p>
         </p:txBody>
       </p:sp>
@@ -4153,12 +4291,12 @@
         </p:nvSpPr>
         <p:spPr>
           <a:xfrm>
-            <a:off x="2514600" y="1691640"/>
-            <a:ext cx="1828800" cy="1188720"/>
+            <a:off x="3337560" y="1600200"/>
+            <a:ext cx="2514600" cy="1143000"/>
           </a:xfrm>
           <a:prstGeom prst="roundRect">
             <a:avLst>
-              <a:gd name="adj" fmla="val 11538"/>
+              <a:gd name="adj" fmla="val 12000"/>
             </a:avLst>
           </a:prstGeom>
           <a:solidFill>
@@ -4180,24 +4318,24 @@
         </p:nvSpPr>
         <p:spPr>
           <a:xfrm>
-            <a:off x="2651760" y="1801368"/>
-            <a:ext cx="1600200" cy="365760"/>
-          </a:xfrm>
-          <a:prstGeom prst="rect">
-            <a:avLst/>
-          </a:prstGeom>
-          <a:noFill/>
-          <a:ln/>
-        </p:spPr>
-        <p:txBody>
-          <a:bodyPr wrap="square" lIns="0" tIns="0" rIns="0" bIns="0" rtlCol="0" anchor="ctr"/>
-          <a:lstStyle/>
-          <a:p>
-            <a:pPr indent="0" marL="0">
-              <a:buNone/>
-            </a:pPr>
-            <a:r>
-              <a:rPr lang="en-US" sz="1400" b="1" dirty="0">
+            <a:off x="3502152" y="1709928"/>
+            <a:ext cx="2194560" cy="347472"/>
+          </a:xfrm>
+          <a:prstGeom prst="rect">
+            <a:avLst/>
+          </a:prstGeom>
+          <a:noFill/>
+          <a:ln/>
+        </p:spPr>
+        <p:txBody>
+          <a:bodyPr wrap="square" lIns="0" tIns="0" rIns="0" bIns="0" rtlCol="0" anchor="ctr"/>
+          <a:lstStyle/>
+          <a:p>
+            <a:pPr indent="0" marL="0">
+              <a:buNone/>
+            </a:pPr>
+            <a:r>
+              <a:rPr lang="en-US" sz="1500" b="1" dirty="0">
                 <a:solidFill>
                   <a:srgbClr val="111827"/>
                 </a:solidFill>
@@ -4207,7 +4345,7 @@
               </a:rPr>
               <a:t>Orientation</a:t>
             </a:r>
-            <a:endParaRPr lang="en-US" sz="1400" dirty="0"/>
+            <a:endParaRPr lang="en-US" sz="1500" dirty="0"/>
           </a:p>
         </p:txBody>
       </p:sp>
@@ -4219,24 +4357,24 @@
         </p:nvSpPr>
         <p:spPr>
           <a:xfrm>
-            <a:off x="2651760" y="2194560"/>
-            <a:ext cx="1600200" cy="640080"/>
-          </a:xfrm>
-          <a:prstGeom prst="rect">
-            <a:avLst/>
-          </a:prstGeom>
-          <a:noFill/>
-          <a:ln/>
-        </p:spPr>
-        <p:txBody>
-          <a:bodyPr wrap="square" lIns="0" tIns="0" rIns="0" bIns="0" rtlCol="0" anchor="ctr"/>
-          <a:lstStyle/>
-          <a:p>
-            <a:pPr indent="0" marL="0">
-              <a:buNone/>
-            </a:pPr>
-            <a:r>
-              <a:rPr lang="en-US" sz="1050" dirty="0">
+            <a:off x="3502152" y="2075688"/>
+            <a:ext cx="2194560" cy="640080"/>
+          </a:xfrm>
+          <a:prstGeom prst="rect">
+            <a:avLst/>
+          </a:prstGeom>
+          <a:noFill/>
+          <a:ln/>
+        </p:spPr>
+        <p:txBody>
+          <a:bodyPr wrap="square" lIns="0" tIns="0" rIns="0" bIns="0" rtlCol="0" anchor="ctr"/>
+          <a:lstStyle/>
+          <a:p>
+            <a:pPr indent="0" marL="0">
+              <a:buNone/>
+            </a:pPr>
+            <a:r>
+              <a:rPr lang="en-US" sz="1100" dirty="0">
                 <a:solidFill>
                   <a:srgbClr val="4B5563"/>
                 </a:solidFill>
@@ -4244,9 +4382,9 @@
                 <a:ea typeface="Arial" pitchFamily="34" charset="-122"/>
                 <a:cs typeface="Arial" pitchFamily="34" charset="-120"/>
               </a:rPr>
-              <a:t>“What is today?” as a friend would ask</a:t>
-            </a:r>
-            <a:endParaRPr lang="en-US" sz="1050" dirty="0"/>
+              <a:t>“What is today?”, asked the way a friend would.</a:t>
+            </a:r>
+            <a:endParaRPr lang="en-US" sz="1100" dirty="0"/>
           </a:p>
         </p:txBody>
       </p:sp>
@@ -4258,12 +4396,12 @@
         </p:nvSpPr>
         <p:spPr>
           <a:xfrm>
-            <a:off x="4480560" y="1691640"/>
-            <a:ext cx="1828800" cy="1188720"/>
+            <a:off x="6126480" y="1600200"/>
+            <a:ext cx="2514600" cy="1143000"/>
           </a:xfrm>
           <a:prstGeom prst="roundRect">
             <a:avLst>
-              <a:gd name="adj" fmla="val 11538"/>
+              <a:gd name="adj" fmla="val 12000"/>
             </a:avLst>
           </a:prstGeom>
           <a:solidFill>
@@ -4285,24 +4423,24 @@
         </p:nvSpPr>
         <p:spPr>
           <a:xfrm>
-            <a:off x="4617720" y="1801368"/>
-            <a:ext cx="1600200" cy="365760"/>
-          </a:xfrm>
-          <a:prstGeom prst="rect">
-            <a:avLst/>
-          </a:prstGeom>
-          <a:noFill/>
-          <a:ln/>
-        </p:spPr>
-        <p:txBody>
-          <a:bodyPr wrap="square" lIns="0" tIns="0" rIns="0" bIns="0" rtlCol="0" anchor="ctr"/>
-          <a:lstStyle/>
-          <a:p>
-            <a:pPr indent="0" marL="0">
-              <a:buNone/>
-            </a:pPr>
-            <a:r>
-              <a:rPr lang="en-US" sz="1400" b="1" dirty="0">
+            <a:off x="6291072" y="1709928"/>
+            <a:ext cx="2194560" cy="347472"/>
+          </a:xfrm>
+          <a:prstGeom prst="rect">
+            <a:avLst/>
+          </a:prstGeom>
+          <a:noFill/>
+          <a:ln/>
+        </p:spPr>
+        <p:txBody>
+          <a:bodyPr wrap="square" lIns="0" tIns="0" rIns="0" bIns="0" rtlCol="0" anchor="ctr"/>
+          <a:lstStyle/>
+          <a:p>
+            <a:pPr indent="0" marL="0">
+              <a:buNone/>
+            </a:pPr>
+            <a:r>
+              <a:rPr lang="en-US" sz="1500" b="1" dirty="0">
                 <a:solidFill>
                   <a:srgbClr val="111827"/>
                 </a:solidFill>
@@ -4312,7 +4450,7 @@
               </a:rPr>
               <a:t>Disorganised thinking</a:t>
             </a:r>
-            <a:endParaRPr lang="en-US" sz="1400" dirty="0"/>
+            <a:endParaRPr lang="en-US" sz="1500" dirty="0"/>
           </a:p>
         </p:txBody>
       </p:sp>
@@ -4324,24 +4462,24 @@
         </p:nvSpPr>
         <p:spPr>
           <a:xfrm>
-            <a:off x="4617720" y="2194560"/>
-            <a:ext cx="1600200" cy="640080"/>
-          </a:xfrm>
-          <a:prstGeom prst="rect">
-            <a:avLst/>
-          </a:prstGeom>
-          <a:noFill/>
-          <a:ln/>
-        </p:spPr>
-        <p:txBody>
-          <a:bodyPr wrap="square" lIns="0" tIns="0" rIns="0" bIns="0" rtlCol="0" anchor="ctr"/>
-          <a:lstStyle/>
-          <a:p>
-            <a:pPr indent="0" marL="0">
-              <a:buNone/>
-            </a:pPr>
-            <a:r>
-              <a:rPr lang="en-US" sz="1050" dirty="0">
+            <a:off x="6291072" y="2075688"/>
+            <a:ext cx="2194560" cy="640080"/>
+          </a:xfrm>
+          <a:prstGeom prst="rect">
+            <a:avLst/>
+          </a:prstGeom>
+          <a:noFill/>
+          <a:ln/>
+        </p:spPr>
+        <p:txBody>
+          <a:bodyPr wrap="square" lIns="0" tIns="0" rIns="0" bIns="0" rtlCol="0" anchor="ctr"/>
+          <a:lstStyle/>
+          <a:p>
+            <a:pPr indent="0" marL="0">
+              <a:buNone/>
+            </a:pPr>
+            <a:r>
+              <a:rPr lang="en-US" sz="1100" dirty="0">
                 <a:solidFill>
                   <a:srgbClr val="4B5563"/>
                 </a:solidFill>
@@ -4349,9 +4487,9 @@
                 <a:ea typeface="Arial" pitchFamily="34" charset="-122"/>
                 <a:cs typeface="Arial" pitchFamily="34" charset="-120"/>
               </a:rPr>
-              <a:t>coherence of her own words, order in the puzzle</a:t>
-            </a:r>
-            <a:endParaRPr lang="en-US" sz="1050" dirty="0"/>
+              <a:t>Coherence of her own words. Order of placement in the puzzle.</a:t>
+            </a:r>
+            <a:endParaRPr lang="en-US" sz="1100" dirty="0"/>
           </a:p>
         </p:txBody>
       </p:sp>
@@ -4363,12 +4501,12 @@
         </p:nvSpPr>
         <p:spPr>
           <a:xfrm>
-            <a:off x="548640" y="3063240"/>
-            <a:ext cx="1828800" cy="1188720"/>
+            <a:off x="548640" y="2926080"/>
+            <a:ext cx="2514600" cy="1143000"/>
           </a:xfrm>
           <a:prstGeom prst="roundRect">
             <a:avLst>
-              <a:gd name="adj" fmla="val 11538"/>
+              <a:gd name="adj" fmla="val 12000"/>
             </a:avLst>
           </a:prstGeom>
           <a:solidFill>
@@ -4390,24 +4528,24 @@
         </p:nvSpPr>
         <p:spPr>
           <a:xfrm>
-            <a:off x="685800" y="3172968"/>
-            <a:ext cx="1600200" cy="365760"/>
-          </a:xfrm>
-          <a:prstGeom prst="rect">
-            <a:avLst/>
-          </a:prstGeom>
-          <a:noFill/>
-          <a:ln/>
-        </p:spPr>
-        <p:txBody>
-          <a:bodyPr wrap="square" lIns="0" tIns="0" rIns="0" bIns="0" rtlCol="0" anchor="ctr"/>
-          <a:lstStyle/>
-          <a:p>
-            <a:pPr indent="0" marL="0">
-              <a:buNone/>
-            </a:pPr>
-            <a:r>
-              <a:rPr lang="en-US" sz="1400" b="1" dirty="0">
+            <a:off x="713232" y="3035808"/>
+            <a:ext cx="2194560" cy="347472"/>
+          </a:xfrm>
+          <a:prstGeom prst="rect">
+            <a:avLst/>
+          </a:prstGeom>
+          <a:noFill/>
+          <a:ln/>
+        </p:spPr>
+        <p:txBody>
+          <a:bodyPr wrap="square" lIns="0" tIns="0" rIns="0" bIns="0" rtlCol="0" anchor="ctr"/>
+          <a:lstStyle/>
+          <a:p>
+            <a:pPr indent="0" marL="0">
+              <a:buNone/>
+            </a:pPr>
+            <a:r>
+              <a:rPr lang="en-US" sz="1500" b="1" dirty="0">
                 <a:solidFill>
                   <a:srgbClr val="111827"/>
                 </a:solidFill>
@@ -4417,7 +4555,7 @@
               </a:rPr>
               <a:t>Arousal</a:t>
             </a:r>
-            <a:endParaRPr lang="en-US" sz="1400" dirty="0"/>
+            <a:endParaRPr lang="en-US" sz="1500" dirty="0"/>
           </a:p>
         </p:txBody>
       </p:sp>
@@ -4429,24 +4567,24 @@
         </p:nvSpPr>
         <p:spPr>
           <a:xfrm>
-            <a:off x="685800" y="3566160"/>
-            <a:ext cx="1600200" cy="640080"/>
-          </a:xfrm>
-          <a:prstGeom prst="rect">
-            <a:avLst/>
-          </a:prstGeom>
-          <a:noFill/>
-          <a:ln/>
-        </p:spPr>
-        <p:txBody>
-          <a:bodyPr wrap="square" lIns="0" tIns="0" rIns="0" bIns="0" rtlCol="0" anchor="ctr"/>
-          <a:lstStyle/>
-          <a:p>
-            <a:pPr indent="0" marL="0">
-              <a:buNone/>
-            </a:pPr>
-            <a:r>
-              <a:rPr lang="en-US" sz="1050" dirty="0">
+            <a:off x="713232" y="3401568"/>
+            <a:ext cx="2194560" cy="640080"/>
+          </a:xfrm>
+          <a:prstGeom prst="rect">
+            <a:avLst/>
+          </a:prstGeom>
+          <a:noFill/>
+          <a:ln/>
+        </p:spPr>
+        <p:txBody>
+          <a:bodyPr wrap="square" lIns="0" tIns="0" rIns="0" bIns="0" rtlCol="0" anchor="ctr"/>
+          <a:lstStyle/>
+          <a:p>
+            <a:pPr indent="0" marL="0">
+              <a:buNone/>
+            </a:pPr>
+            <a:r>
+              <a:rPr lang="en-US" sz="1100" dirty="0">
                 <a:solidFill>
                   <a:srgbClr val="4B5563"/>
                 </a:solidFill>
@@ -4454,9 +4592,9 @@
                 <a:ea typeface="Arial" pitchFamily="34" charset="-122"/>
                 <a:cs typeface="Arial" pitchFamily="34" charset="-120"/>
               </a:rPr>
-              <a:t>did she open it, how fast did she start</a:t>
-            </a:r>
-            <a:endParaRPr lang="en-US" sz="1050" dirty="0"/>
+              <a:t>Did she open it. How long before the first stroke.</a:t>
+            </a:r>
+            <a:endParaRPr lang="en-US" sz="1100" dirty="0"/>
           </a:p>
         </p:txBody>
       </p:sp>
@@ -4468,12 +4606,12 @@
         </p:nvSpPr>
         <p:spPr>
           <a:xfrm>
-            <a:off x="2514600" y="3063240"/>
-            <a:ext cx="1828800" cy="1188720"/>
+            <a:off x="3337560" y="2926080"/>
+            <a:ext cx="2514600" cy="1143000"/>
           </a:xfrm>
           <a:prstGeom prst="roundRect">
             <a:avLst>
-              <a:gd name="adj" fmla="val 11538"/>
+              <a:gd name="adj" fmla="val 12000"/>
             </a:avLst>
           </a:prstGeom>
           <a:solidFill>
@@ -4495,24 +4633,24 @@
         </p:nvSpPr>
         <p:spPr>
           <a:xfrm>
-            <a:off x="2651760" y="3172968"/>
-            <a:ext cx="1600200" cy="365760"/>
-          </a:xfrm>
-          <a:prstGeom prst="rect">
-            <a:avLst/>
-          </a:prstGeom>
-          <a:noFill/>
-          <a:ln/>
-        </p:spPr>
-        <p:txBody>
-          <a:bodyPr wrap="square" lIns="0" tIns="0" rIns="0" bIns="0" rtlCol="0" anchor="ctr"/>
-          <a:lstStyle/>
-          <a:p>
-            <a:pPr indent="0" marL="0">
-              <a:buNone/>
-            </a:pPr>
-            <a:r>
-              <a:rPr lang="en-US" sz="1400" b="1" dirty="0">
+            <a:off x="3502152" y="3035808"/>
+            <a:ext cx="2194560" cy="347472"/>
+          </a:xfrm>
+          <a:prstGeom prst="rect">
+            <a:avLst/>
+          </a:prstGeom>
+          <a:noFill/>
+          <a:ln/>
+        </p:spPr>
+        <p:txBody>
+          <a:bodyPr wrap="square" lIns="0" tIns="0" rIns="0" bIns="0" rtlCol="0" anchor="ctr"/>
+          <a:lstStyle/>
+          <a:p>
+            <a:pPr indent="0" marL="0">
+              <a:buNone/>
+            </a:pPr>
+            <a:r>
+              <a:rPr lang="en-US" sz="1500" b="1" dirty="0">
                 <a:solidFill>
                   <a:srgbClr val="FFFFFF"/>
                 </a:solidFill>
@@ -4522,7 +4660,7 @@
               </a:rPr>
               <a:t>Fluctuation</a:t>
             </a:r>
-            <a:endParaRPr lang="en-US" sz="1400" dirty="0"/>
+            <a:endParaRPr lang="en-US" sz="1500" dirty="0"/>
           </a:p>
         </p:txBody>
       </p:sp>
@@ -4534,34 +4672,34 @@
         </p:nvSpPr>
         <p:spPr>
           <a:xfrm>
-            <a:off x="2651760" y="3566160"/>
-            <a:ext cx="1600200" cy="640080"/>
-          </a:xfrm>
-          <a:prstGeom prst="rect">
-            <a:avLst/>
-          </a:prstGeom>
-          <a:noFill/>
-          <a:ln/>
-        </p:spPr>
-        <p:txBody>
-          <a:bodyPr wrap="square" lIns="0" tIns="0" rIns="0" bIns="0" rtlCol="0" anchor="ctr"/>
-          <a:lstStyle/>
-          <a:p>
-            <a:pPr indent="0" marL="0">
-              <a:buNone/>
-            </a:pPr>
-            <a:r>
-              <a:rPr lang="en-US" sz="1050" dirty="0">
-                <a:solidFill>
-                  <a:srgbClr val="DBEAFE"/>
-                </a:solidFill>
-                <a:latin typeface="Arial" pitchFamily="34" charset="0"/>
-                <a:ea typeface="Arial" pitchFamily="34" charset="-122"/>
-                <a:cs typeface="Arial" pitchFamily="34" charset="-120"/>
-              </a:rPr>
-              <a:t>morning vs evening, day vs her own baseline</a:t>
-            </a:r>
-            <a:endParaRPr lang="en-US" sz="1050" dirty="0"/>
+            <a:off x="3502152" y="3401568"/>
+            <a:ext cx="2194560" cy="640080"/>
+          </a:xfrm>
+          <a:prstGeom prst="rect">
+            <a:avLst/>
+          </a:prstGeom>
+          <a:noFill/>
+          <a:ln/>
+        </p:spPr>
+        <p:txBody>
+          <a:bodyPr wrap="square" lIns="0" tIns="0" rIns="0" bIns="0" rtlCol="0" anchor="ctr"/>
+          <a:lstStyle/>
+          <a:p>
+            <a:pPr indent="0" marL="0">
+              <a:buNone/>
+            </a:pPr>
+            <a:r>
+              <a:rPr lang="en-US" sz="1100" dirty="0">
+                <a:solidFill>
+                  <a:srgbClr val="C7D2FE"/>
+                </a:solidFill>
+                <a:latin typeface="Arial" pitchFamily="34" charset="0"/>
+                <a:ea typeface="Arial" pitchFamily="34" charset="-122"/>
+                <a:cs typeface="Arial" pitchFamily="34" charset="-120"/>
+              </a:rPr>
+              <a:t>Morning against evening. Today against her own baseline.</a:t>
+            </a:r>
+            <a:endParaRPr lang="en-US" sz="1100" dirty="0"/>
           </a:p>
         </p:txBody>
       </p:sp>
@@ -4573,16 +4711,16 @@
         </p:nvSpPr>
         <p:spPr>
           <a:xfrm>
-            <a:off x="6492240" y="1691640"/>
-            <a:ext cx="2103120" cy="2560320"/>
+            <a:off x="6126480" y="2926080"/>
+            <a:ext cx="2514600" cy="1143000"/>
           </a:xfrm>
           <a:prstGeom prst="roundRect">
             <a:avLst>
-              <a:gd name="adj" fmla="val 6522"/>
+              <a:gd name="adj" fmla="val 12000"/>
             </a:avLst>
           </a:prstGeom>
           <a:solidFill>
-            <a:srgbClr val="DBEAFE"/>
+            <a:srgbClr val="1E40AF"/>
           </a:solidFill>
           <a:ln w="12700">
             <a:solidFill>
@@ -4600,24 +4738,102 @@
         </p:nvSpPr>
         <p:spPr>
           <a:xfrm>
-            <a:off x="6629400" y="1828800"/>
-            <a:ext cx="1828800" cy="731520"/>
-          </a:xfrm>
-          <a:prstGeom prst="rect">
-            <a:avLst/>
-          </a:prstGeom>
-          <a:noFill/>
-          <a:ln/>
-        </p:spPr>
-        <p:txBody>
-          <a:bodyPr wrap="square" lIns="0" tIns="0" rIns="0" bIns="0" rtlCol="0" anchor="ctr"/>
-          <a:lstStyle/>
-          <a:p>
-            <a:pPr indent="0" marL="0">
-              <a:buNone/>
-            </a:pPr>
-            <a:r>
-              <a:rPr lang="en-US" sz="4000" b="1" dirty="0">
+            <a:off x="6291072" y="3035808"/>
+            <a:ext cx="2194560" cy="347472"/>
+          </a:xfrm>
+          <a:prstGeom prst="rect">
+            <a:avLst/>
+          </a:prstGeom>
+          <a:noFill/>
+          <a:ln/>
+        </p:spPr>
+        <p:txBody>
+          <a:bodyPr wrap="square" lIns="0" tIns="0" rIns="0" bIns="0" rtlCol="0" anchor="ctr"/>
+          <a:lstStyle/>
+          <a:p>
+            <a:pPr indent="0" marL="0">
+              <a:buNone/>
+            </a:pPr>
+            <a:r>
+              <a:rPr lang="en-US" sz="1500" b="1" dirty="0">
+                <a:solidFill>
+                  <a:srgbClr val="FFFFFF"/>
+                </a:solidFill>
+                <a:latin typeface="Arial" pitchFamily="34" charset="0"/>
+                <a:ea typeface="Arial" pitchFamily="34" charset="-122"/>
+                <a:cs typeface="Arial" pitchFamily="34" charset="-120"/>
+              </a:rPr>
+              <a:t>40% preventable</a:t>
+            </a:r>
+            <a:endParaRPr lang="en-US" sz="1500" dirty="0"/>
+          </a:p>
+        </p:txBody>
+      </p:sp>
+      <p:sp>
+        <p:nvSpPr>
+          <p:cNvPr id="21" name="Text 19"/>
+          <p:cNvSpPr txBox="1"/>
+          <p:nvPr/>
+        </p:nvSpPr>
+        <p:spPr>
+          <a:xfrm>
+            <a:off x="6291072" y="3401568"/>
+            <a:ext cx="2194560" cy="640080"/>
+          </a:xfrm>
+          <a:prstGeom prst="rect">
+            <a:avLst/>
+          </a:prstGeom>
+          <a:noFill/>
+          <a:ln/>
+        </p:spPr>
+        <p:txBody>
+          <a:bodyPr wrap="square" lIns="0" tIns="0" rIns="0" bIns="0" rtlCol="0" anchor="ctr"/>
+          <a:lstStyle/>
+          <a:p>
+            <a:pPr indent="0" marL="0">
+              <a:buNone/>
+            </a:pPr>
+            <a:r>
+              <a:rPr lang="en-US" sz="1100" dirty="0">
+                <a:solidFill>
+                  <a:srgbClr val="C7D2FE"/>
+                </a:solidFill>
+                <a:latin typeface="Arial" pitchFamily="34" charset="0"/>
+                <a:ea typeface="Arial" pitchFamily="34" charset="-122"/>
+                <a:cs typeface="Arial" pitchFamily="34" charset="-120"/>
+              </a:rPr>
+              <a:t>Water, sleep, glasses, hearing aids, a phone call. A flag has a cheap answer.</a:t>
+            </a:r>
+            <a:endParaRPr lang="en-US" sz="1100" dirty="0"/>
+          </a:p>
+        </p:txBody>
+      </p:sp>
+      <p:sp>
+        <p:nvSpPr>
+          <p:cNvPr id="22" name="Text 20"/>
+          <p:cNvSpPr txBox="1"/>
+          <p:nvPr/>
+        </p:nvSpPr>
+        <p:spPr>
+          <a:xfrm>
+            <a:off x="548640" y="4343400"/>
+            <a:ext cx="7132320" cy="411480"/>
+          </a:xfrm>
+          <a:prstGeom prst="rect">
+            <a:avLst/>
+          </a:prstGeom>
+          <a:noFill/>
+          <a:ln/>
+        </p:spPr>
+        <p:txBody>
+          <a:bodyPr wrap="square" lIns="0" tIns="0" rIns="0" bIns="0" rtlCol="0" anchor="ctr"/>
+          <a:lstStyle/>
+          <a:p>
+            <a:pPr indent="0" marL="0">
+              <a:buNone/>
+            </a:pPr>
+            <a:r>
+              <a:rPr lang="en-US" sz="1400" i="1" dirty="0">
                 <a:solidFill>
                   <a:srgbClr val="1E40AF"/>
                 </a:solidFill>
@@ -4625,87 +4841,9 @@
                 <a:ea typeface="Arial" pitchFamily="34" charset="-122"/>
                 <a:cs typeface="Arial" pitchFamily="34" charset="-120"/>
               </a:rPr>
-              <a:t>40%</a:t>
-            </a:r>
-            <a:endParaRPr lang="en-US" sz="4000" dirty="0"/>
-          </a:p>
-        </p:txBody>
-      </p:sp>
-      <p:sp>
-        <p:nvSpPr>
-          <p:cNvPr id="21" name="Text 19"/>
-          <p:cNvSpPr txBox="1"/>
-          <p:nvPr/>
-        </p:nvSpPr>
-        <p:spPr>
-          <a:xfrm>
-            <a:off x="6629400" y="2560320"/>
-            <a:ext cx="1828800" cy="1554480"/>
-          </a:xfrm>
-          <a:prstGeom prst="rect">
-            <a:avLst/>
-          </a:prstGeom>
-          <a:noFill/>
-          <a:ln/>
-        </p:spPr>
-        <p:txBody>
-          <a:bodyPr wrap="square" lIns="0" tIns="0" rIns="0" bIns="0" rtlCol="0" anchor="ctr"/>
-          <a:lstStyle/>
-          <a:p>
-            <a:pPr indent="0" marL="0">
-              <a:buNone/>
-            </a:pPr>
-            <a:r>
-              <a:rPr lang="en-US" sz="1100" dirty="0">
-                <a:solidFill>
-                  <a:srgbClr val="111827"/>
-                </a:solidFill>
-                <a:latin typeface="Arial" pitchFamily="34" charset="0"/>
-                <a:ea typeface="Arial" pitchFamily="34" charset="-122"/>
-                <a:cs typeface="Arial" pitchFamily="34" charset="-120"/>
-              </a:rPr>
-              <a:t>of delirium is preventable with water, sleep, glasses, hearing aids and a phone call. A flag has a cheap answer.</a:t>
-            </a:r>
-            <a:endParaRPr lang="en-US" sz="1100" dirty="0"/>
-          </a:p>
-        </p:txBody>
-      </p:sp>
-      <p:sp>
-        <p:nvSpPr>
-          <p:cNvPr id="22" name="Text 20"/>
-          <p:cNvSpPr txBox="1"/>
-          <p:nvPr/>
-        </p:nvSpPr>
-        <p:spPr>
-          <a:xfrm>
-            <a:off x="548640" y="4434840"/>
-            <a:ext cx="8046720" cy="457200"/>
-          </a:xfrm>
-          <a:prstGeom prst="rect">
-            <a:avLst/>
-          </a:prstGeom>
-          <a:noFill/>
-          <a:ln/>
-        </p:spPr>
-        <p:txBody>
-          <a:bodyPr wrap="square" lIns="0" tIns="0" rIns="0" bIns="0" rtlCol="0" anchor="ctr"/>
-          <a:lstStyle/>
-          <a:p>
-            <a:pPr indent="0" marL="0">
-              <a:buNone/>
-            </a:pPr>
-            <a:r>
-              <a:rPr lang="en-US" sz="1500" i="1" dirty="0">
-                <a:solidFill>
-                  <a:srgbClr val="1E40AF"/>
-                </a:solidFill>
-                <a:latin typeface="Arial" pitchFamily="34" charset="0"/>
-                <a:ea typeface="Arial" pitchFamily="34" charset="-122"/>
-                <a:cs typeface="Arial" pitchFamily="34" charset="-120"/>
-              </a:rPr>
-              <a:t>Delirium is a change from your own baseline. The home never had one.</a:t>
-            </a:r>
-            <a:endParaRPr lang="en-US" sz="1500" dirty="0"/>
+              <a:t>The same construct every day, at home, against her own usual. That is the white space.</a:t>
+            </a:r>
+            <a:endParaRPr lang="en-US" sz="1400" dirty="0"/>
           </a:p>
         </p:txBody>
       </p:sp>
@@ -4725,8 +4863,8 @@
         </p:blipFill>
         <p:spPr>
           <a:xfrm>
-            <a:off x="7818120" y="4206240"/>
-            <a:ext cx="868680" cy="868680"/>
+            <a:off x="7818120" y="4069080"/>
+            <a:ext cx="960120" cy="960120"/>
           </a:xfrm>
           <a:prstGeom prst="rect">
             <a:avLst/>
@@ -4813,7 +4951,7 @@
         <p:spPr>
           <a:xfrm>
             <a:off x="548640" y="1005840"/>
-            <a:ext cx="4023360" cy="457200"/>
+            <a:ext cx="4023360" cy="502920"/>
           </a:xfrm>
           <a:prstGeom prst="rect">
             <a:avLst/>
@@ -4837,7 +4975,7 @@
                 <a:ea typeface="Arial" pitchFamily="34" charset="-122"/>
                 <a:cs typeface="Arial" pitchFamily="34" charset="-120"/>
               </a:rPr>
-              <a:t>A nurse writes the question in plain words. Ernie asks it every morning.</a:t>
+              <a:t>A nurse writes the question in plain words. Ernie asks it every morning and reads the answer.</a:t>
             </a:r>
             <a:endParaRPr lang="en-US" sz="1400" dirty="0"/>
           </a:p>
@@ -4851,12 +4989,12 @@
         </p:nvSpPr>
         <p:spPr>
           <a:xfrm>
-            <a:off x="548640" y="1554480"/>
-            <a:ext cx="4023360" cy="502920"/>
+            <a:off x="548640" y="1600200"/>
+            <a:ext cx="4023360" cy="493776"/>
           </a:xfrm>
           <a:prstGeom prst="roundRect">
             <a:avLst>
-              <a:gd name="adj" fmla="val 27273"/>
+              <a:gd name="adj" fmla="val 27778"/>
             </a:avLst>
           </a:prstGeom>
           <a:solidFill>
@@ -4878,8 +5016,8 @@
         </p:nvSpPr>
         <p:spPr>
           <a:xfrm>
-            <a:off x="731520" y="1554480"/>
-            <a:ext cx="3749040" cy="502920"/>
+            <a:off x="731520" y="1600200"/>
+            <a:ext cx="3749040" cy="493776"/>
           </a:xfrm>
           <a:prstGeom prst="rect">
             <a:avLst/>
@@ -4917,12 +5055,12 @@
         </p:nvSpPr>
         <p:spPr>
           <a:xfrm>
-            <a:off x="548640" y="2176272"/>
-            <a:ext cx="4023360" cy="502920"/>
+            <a:off x="548640" y="2203704"/>
+            <a:ext cx="4023360" cy="493776"/>
           </a:xfrm>
           <a:prstGeom prst="roundRect">
             <a:avLst>
-              <a:gd name="adj" fmla="val 27273"/>
+              <a:gd name="adj" fmla="val 27778"/>
             </a:avLst>
           </a:prstGeom>
           <a:solidFill>
@@ -4944,8 +5082,8 @@
         </p:nvSpPr>
         <p:spPr>
           <a:xfrm>
-            <a:off x="731520" y="2176272"/>
-            <a:ext cx="3749040" cy="502920"/>
+            <a:off x="731520" y="2203704"/>
+            <a:ext cx="3749040" cy="493776"/>
           </a:xfrm>
           <a:prstGeom prst="rect">
             <a:avLst/>
@@ -4983,12 +5121,12 @@
         </p:nvSpPr>
         <p:spPr>
           <a:xfrm>
-            <a:off x="548640" y="2798064"/>
-            <a:ext cx="4023360" cy="502920"/>
+            <a:off x="548640" y="2807208"/>
+            <a:ext cx="4023360" cy="493776"/>
           </a:xfrm>
           <a:prstGeom prst="roundRect">
             <a:avLst>
-              <a:gd name="adj" fmla="val 27273"/>
+              <a:gd name="adj" fmla="val 27778"/>
             </a:avLst>
           </a:prstGeom>
           <a:solidFill>
@@ -5010,8 +5148,8 @@
         </p:nvSpPr>
         <p:spPr>
           <a:xfrm>
-            <a:off x="731520" y="2798064"/>
-            <a:ext cx="3749040" cy="502920"/>
+            <a:off x="731520" y="2807208"/>
+            <a:ext cx="3749040" cy="493776"/>
           </a:xfrm>
           <a:prstGeom prst="rect">
             <a:avLst/>
@@ -5049,12 +5187,12 @@
         </p:nvSpPr>
         <p:spPr>
           <a:xfrm>
-            <a:off x="548640" y="3419856"/>
-            <a:ext cx="4023360" cy="502920"/>
+            <a:off x="548640" y="3410712"/>
+            <a:ext cx="4023360" cy="493776"/>
           </a:xfrm>
           <a:prstGeom prst="roundRect">
             <a:avLst>
-              <a:gd name="adj" fmla="val 27273"/>
+              <a:gd name="adj" fmla="val 27778"/>
             </a:avLst>
           </a:prstGeom>
           <a:solidFill>
@@ -5076,8 +5214,8 @@
         </p:nvSpPr>
         <p:spPr>
           <a:xfrm>
-            <a:off x="731520" y="3419856"/>
-            <a:ext cx="3749040" cy="502920"/>
+            <a:off x="731520" y="3410712"/>
+            <a:ext cx="3749040" cy="493776"/>
           </a:xfrm>
           <a:prstGeom prst="rect">
             <a:avLst/>
@@ -5140,7 +5278,7 @@
                 <a:ea typeface="Arial" pitchFamily="34" charset="-122"/>
                 <a:cs typeface="Arial" pitchFamily="34" charset="-120"/>
               </a:rPr>
-              <a:t>Refused at the desk: clinical words, instructions, more than six a day.</a:t>
+              <a:t>The runbook refuses clinical words, instructions, and more than six questions a day.</a:t>
             </a:r>
             <a:endParaRPr lang="en-US" sz="1100" dirty="0"/>
           </a:p>
@@ -5479,7 +5617,7 @@
                 <a:ea typeface="Arial" pitchFamily="34" charset="-122"/>
                 <a:cs typeface="Arial" pitchFamily="34" charset="-120"/>
               </a:rPr>
-              <a:t>Design, not yet built. Decision support, never a diagnosis; a human on every flag.</a:t>
+              <a:t>Designed, not yet built. Decision support, never a diagnosis; a human on every flag.</a:t>
             </a:r>
             <a:endParaRPr lang="en-US" sz="950" dirty="0"/>
           </a:p>
@@ -5838,7 +5976,7 @@
                 <a:ea typeface="Arial" pitchFamily="34" charset="-122"/>
                 <a:cs typeface="Arial" pitchFamily="34" charset="-120"/>
               </a:rPr>
-              <a:t>Does a finger signature hold a baseline? Does the doodle beat the check-in?</a:t>
+              <a:t>Does a finger signature hold a baseline? Does a live doodle beat a check-in?</a:t>
             </a:r>
             <a:endParaRPr lang="en-US" sz="1200" dirty="0"/>
           </a:p>
@@ -6021,7 +6159,7 @@
                 <a:ea typeface="Arial" pitchFamily="34" charset="-122"/>
                 <a:cs typeface="Arial" pitchFamily="34" charset="-120"/>
               </a:rPr>
-              <a:t>How it was built: nine design docs, a component kit that bakes in the 80+ criteria, a critic that audits every screen, and Claude for the research, the reading of replies, and the code.</a:t>
+              <a:t>How it was built: nine design docs, a component kit that bakes in the 80+ criteria, a critic that audits every screen, and Claude for the research, for reading replies, and for the code.</a:t>
             </a:r>
             <a:endParaRPr lang="en-US" sz="1100" dirty="0"/>
           </a:p>

</xml_diff>

<commit_message>
Talk deck: trim the build-pipeline slide
Co-Authored-By: Claude Fable 5.1 <noreply@anthropic.com>
Claude-Session: https://claude.ai/code/session_013zf8N3BNKm8ntFDtGarkNG
</commit_message>
<xml_diff>
--- a/docs/talk/ernie-talk.pptx
+++ b/docs/talk/ernie-talk.pptx
@@ -1191,7 +1191,7 @@
           <a:p>
             <a:r>
               <a:rPr lang="en-US" dirty="0"/>
-              <a:t>4:05. This was built as a pipeline, not a one-off. A research agent produced the insight map and the 80+ criteria. Nine sketches on one doc template, product and engineering together. A component kit with the criteria baked in, synced to Claude Design. The app itself. And a reviewer in the loop: before any UI change merges, a senior-centred critic drives the real page and blocks anything an 84-year-old could not use.</a:t>
+              <a:t>4:05. Built as a pipeline, not a one-off. A research agent produced the insight map and the 80+ criteria. Nine sketches on one doc template, product and engineering together. A component kit with the criteria baked in, synced to Claude Design. One small web service; Claude reads her replies as data and never advises. And a reviewer in the loop: before any UI change merges, a senior-centred critic drives the real page and blocks anything an 84-year-old could not use.</a:t>
             </a:r>
             <a:endParaRPr lang="en-US" dirty="0"/>
           </a:p>
@@ -4130,7 +4130,7 @@
                 <a:ea typeface="Arial" pitchFamily="34" charset="-122"/>
                 <a:cs typeface="Arial" pitchFamily="34" charset="-120"/>
               </a:rPr>
-              <a:t>A pipeline with a reviewer in it, so every screen that ships is one an 84-year-old can use.</a:t>
+              <a:t>A pipeline with a reviewer in it.</a:t>
             </a:r>
             <a:endParaRPr lang="en-US" sz="1500" dirty="0"/>
           </a:p>
@@ -4145,11 +4145,11 @@
         <p:spPr>
           <a:xfrm>
             <a:off x="548640" y="1600200"/>
-            <a:ext cx="1874520" cy="1874520"/>
+            <a:ext cx="1874520" cy="1691640"/>
           </a:xfrm>
           <a:prstGeom prst="roundRect">
             <a:avLst>
-              <a:gd name="adj" fmla="val 7317"/>
+              <a:gd name="adj" fmla="val 8108"/>
             </a:avLst>
           </a:prstGeom>
           <a:solidFill>
@@ -4171,24 +4171,24 @@
         </p:nvSpPr>
         <p:spPr>
           <a:xfrm>
-            <a:off x="685800" y="1709928"/>
-            <a:ext cx="1188720" cy="365760"/>
-          </a:xfrm>
-          <a:prstGeom prst="rect">
-            <a:avLst/>
-          </a:prstGeom>
-          <a:noFill/>
-          <a:ln/>
-        </p:spPr>
-        <p:txBody>
-          <a:bodyPr wrap="square" lIns="0" tIns="0" rIns="0" bIns="0" rtlCol="0" anchor="ctr"/>
-          <a:lstStyle/>
-          <a:p>
-            <a:pPr indent="0" marL="0">
-              <a:buNone/>
-            </a:pPr>
-            <a:r>
-              <a:rPr lang="en-US" sz="1500" b="1" dirty="0">
+            <a:off x="713232" y="1737360"/>
+            <a:ext cx="1143000" cy="365760"/>
+          </a:xfrm>
+          <a:prstGeom prst="rect">
+            <a:avLst/>
+          </a:prstGeom>
+          <a:noFill/>
+          <a:ln/>
+        </p:spPr>
+        <p:txBody>
+          <a:bodyPr wrap="square" lIns="0" tIns="0" rIns="0" bIns="0" rtlCol="0" anchor="ctr"/>
+          <a:lstStyle/>
+          <a:p>
+            <a:pPr indent="0" marL="0">
+              <a:buNone/>
+            </a:pPr>
+            <a:r>
+              <a:rPr lang="en-US" sz="1600" b="1" dirty="0">
                 <a:solidFill>
                   <a:srgbClr val="111827"/>
                 </a:solidFill>
@@ -4198,7 +4198,7 @@
               </a:rPr>
               <a:t>Research</a:t>
             </a:r>
-            <a:endParaRPr lang="en-US" sz="1500" dirty="0"/>
+            <a:endParaRPr lang="en-US" sz="1600" dirty="0"/>
           </a:p>
         </p:txBody>
       </p:sp>
@@ -4218,8 +4218,8 @@
         </p:blipFill>
         <p:spPr>
           <a:xfrm>
-            <a:off x="1856232" y="1655064"/>
-            <a:ext cx="502920" cy="502920"/>
+            <a:off x="1819656" y="1673352"/>
+            <a:ext cx="530352" cy="530352"/>
           </a:xfrm>
           <a:prstGeom prst="rect">
             <a:avLst/>
@@ -4234,24 +4234,24 @@
         </p:nvSpPr>
         <p:spPr>
           <a:xfrm>
-            <a:off x="685800" y="2103120"/>
-            <a:ext cx="1600200" cy="1280160"/>
-          </a:xfrm>
-          <a:prstGeom prst="rect">
-            <a:avLst/>
-          </a:prstGeom>
-          <a:noFill/>
-          <a:ln/>
-        </p:spPr>
-        <p:txBody>
-          <a:bodyPr wrap="square" lIns="0" tIns="0" rIns="0" bIns="0" rtlCol="0" anchor="ctr"/>
-          <a:lstStyle/>
-          <a:p>
-            <a:pPr indent="0" marL="0">
-              <a:buNone/>
-            </a:pPr>
-            <a:r>
-              <a:rPr lang="en-US" sz="950" dirty="0">
+            <a:off x="713232" y="2240280"/>
+            <a:ext cx="1545336" cy="960120"/>
+          </a:xfrm>
+          <a:prstGeom prst="rect">
+            <a:avLst/>
+          </a:prstGeom>
+          <a:noFill/>
+          <a:ln/>
+        </p:spPr>
+        <p:txBody>
+          <a:bodyPr wrap="square" lIns="0" tIns="0" rIns="0" bIns="0" rtlCol="0" anchor="ctr"/>
+          <a:lstStyle/>
+          <a:p>
+            <a:pPr indent="0" marL="0">
+              <a:buNone/>
+            </a:pPr>
+            <a:r>
+              <a:rPr lang="en-US" sz="1150" dirty="0">
                 <a:solidFill>
                   <a:srgbClr val="4B5563"/>
                 </a:solidFill>
@@ -4259,9 +4259,9 @@
                 <a:ea typeface="Arial" pitchFamily="34" charset="-122"/>
                 <a:cs typeface="Arial" pitchFamily="34" charset="-120"/>
               </a:rPr>
-              <a:t>A Claude research agent read the value-based-care and delirium literature and wrote the insight map. A second pass turned W3C, NN/g and gerontology studies into the 80+ design criteria.</a:t>
-            </a:r>
-            <a:endParaRPr lang="en-US" sz="950" dirty="0"/>
+              <a:t>A Claude research agent wrote the insight map and the 80+ design criteria.</a:t>
+            </a:r>
+            <a:endParaRPr lang="en-US" sz="1150" dirty="0"/>
           </a:p>
         </p:txBody>
       </p:sp>
@@ -4273,7 +4273,7 @@
         </p:nvSpPr>
         <p:spPr>
           <a:xfrm>
-            <a:off x="2441448" y="2011680"/>
+            <a:off x="2441448" y="1965960"/>
             <a:ext cx="146304" cy="0"/>
           </a:xfrm>
           <a:prstGeom prst="line">
@@ -4298,11 +4298,11 @@
         <p:spPr>
           <a:xfrm>
             <a:off x="2606040" y="1600200"/>
-            <a:ext cx="1874520" cy="1874520"/>
+            <a:ext cx="1874520" cy="1691640"/>
           </a:xfrm>
           <a:prstGeom prst="roundRect">
             <a:avLst>
-              <a:gd name="adj" fmla="val 7317"/>
+              <a:gd name="adj" fmla="val 8108"/>
             </a:avLst>
           </a:prstGeom>
           <a:solidFill>
@@ -4324,24 +4324,24 @@
         </p:nvSpPr>
         <p:spPr>
           <a:xfrm>
-            <a:off x="2743200" y="1709928"/>
-            <a:ext cx="1188720" cy="365760"/>
-          </a:xfrm>
-          <a:prstGeom prst="rect">
-            <a:avLst/>
-          </a:prstGeom>
-          <a:noFill/>
-          <a:ln/>
-        </p:spPr>
-        <p:txBody>
-          <a:bodyPr wrap="square" lIns="0" tIns="0" rIns="0" bIns="0" rtlCol="0" anchor="ctr"/>
-          <a:lstStyle/>
-          <a:p>
-            <a:pPr indent="0" marL="0">
-              <a:buNone/>
-            </a:pPr>
-            <a:r>
-              <a:rPr lang="en-US" sz="1500" b="1" dirty="0">
+            <a:off x="2770632" y="1737360"/>
+            <a:ext cx="1143000" cy="365760"/>
+          </a:xfrm>
+          <a:prstGeom prst="rect">
+            <a:avLst/>
+          </a:prstGeom>
+          <a:noFill/>
+          <a:ln/>
+        </p:spPr>
+        <p:txBody>
+          <a:bodyPr wrap="square" lIns="0" tIns="0" rIns="0" bIns="0" rtlCol="0" anchor="ctr"/>
+          <a:lstStyle/>
+          <a:p>
+            <a:pPr indent="0" marL="0">
+              <a:buNone/>
+            </a:pPr>
+            <a:r>
+              <a:rPr lang="en-US" sz="1600" b="1" dirty="0">
                 <a:solidFill>
                   <a:srgbClr val="111827"/>
                 </a:solidFill>
@@ -4351,7 +4351,7 @@
               </a:rPr>
               <a:t>Sketches</a:t>
             </a:r>
-            <a:endParaRPr lang="en-US" sz="1500" dirty="0"/>
+            <a:endParaRPr lang="en-US" sz="1600" dirty="0"/>
           </a:p>
         </p:txBody>
       </p:sp>
@@ -4371,8 +4371,8 @@
         </p:blipFill>
         <p:spPr>
           <a:xfrm>
-            <a:off x="3913632" y="1655064"/>
-            <a:ext cx="502920" cy="502920"/>
+            <a:off x="3877056" y="1673352"/>
+            <a:ext cx="530352" cy="530352"/>
           </a:xfrm>
           <a:prstGeom prst="rect">
             <a:avLst/>
@@ -4387,24 +4387,24 @@
         </p:nvSpPr>
         <p:spPr>
           <a:xfrm>
-            <a:off x="2743200" y="2103120"/>
-            <a:ext cx="1600200" cy="1280160"/>
-          </a:xfrm>
-          <a:prstGeom prst="rect">
-            <a:avLst/>
-          </a:prstGeom>
-          <a:noFill/>
-          <a:ln/>
-        </p:spPr>
-        <p:txBody>
-          <a:bodyPr wrap="square" lIns="0" tIns="0" rIns="0" bIns="0" rtlCol="0" anchor="ctr"/>
-          <a:lstStyle/>
-          <a:p>
-            <a:pPr indent="0" marL="0">
-              <a:buNone/>
-            </a:pPr>
-            <a:r>
-              <a:rPr lang="en-US" sz="950" dirty="0">
+            <a:off x="2770632" y="2240280"/>
+            <a:ext cx="1545336" cy="960120"/>
+          </a:xfrm>
+          <a:prstGeom prst="rect">
+            <a:avLst/>
+          </a:prstGeom>
+          <a:noFill/>
+          <a:ln/>
+        </p:spPr>
+        <p:txBody>
+          <a:bodyPr wrap="square" lIns="0" tIns="0" rIns="0" bIns="0" rtlCol="0" anchor="ctr"/>
+          <a:lstStyle/>
+          <a:p>
+            <a:pPr indent="0" marL="0">
+              <a:buNone/>
+            </a:pPr>
+            <a:r>
+              <a:rPr lang="en-US" sz="1150" dirty="0">
                 <a:solidFill>
                   <a:srgbClr val="4B5563"/>
                 </a:solidFill>
@@ -4412,9 +4412,9 @@
                 <a:ea typeface="Arial" pitchFamily="34" charset="-122"/>
                 <a:cs typeface="Arial" pitchFamily="34" charset="-120"/>
               </a:rPr>
-              <a:t>Nine design docs on one template, product and engineering in one file: guest book, doodle, find the family, clues, coherence chat, data capture, jigsaw, clinician runbook.</a:t>
-            </a:r>
-            <a:endParaRPr lang="en-US" sz="950" dirty="0"/>
+              <a:t>Nine design docs, one template. Product and engineering in one file.</a:t>
+            </a:r>
+            <a:endParaRPr lang="en-US" sz="1150" dirty="0"/>
           </a:p>
         </p:txBody>
       </p:sp>
@@ -4426,7 +4426,7 @@
         </p:nvSpPr>
         <p:spPr>
           <a:xfrm>
-            <a:off x="4498848" y="2011680"/>
+            <a:off x="4498848" y="1965960"/>
             <a:ext cx="146304" cy="0"/>
           </a:xfrm>
           <a:prstGeom prst="line">
@@ -4451,11 +4451,11 @@
         <p:spPr>
           <a:xfrm>
             <a:off x="4663440" y="1600200"/>
-            <a:ext cx="1874520" cy="1874520"/>
+            <a:ext cx="1874520" cy="1691640"/>
           </a:xfrm>
           <a:prstGeom prst="roundRect">
             <a:avLst>
-              <a:gd name="adj" fmla="val 7317"/>
+              <a:gd name="adj" fmla="val 8108"/>
             </a:avLst>
           </a:prstGeom>
           <a:solidFill>
@@ -4477,24 +4477,24 @@
         </p:nvSpPr>
         <p:spPr>
           <a:xfrm>
-            <a:off x="4800600" y="1709928"/>
-            <a:ext cx="1188720" cy="365760"/>
-          </a:xfrm>
-          <a:prstGeom prst="rect">
-            <a:avLst/>
-          </a:prstGeom>
-          <a:noFill/>
-          <a:ln/>
-        </p:spPr>
-        <p:txBody>
-          <a:bodyPr wrap="square" lIns="0" tIns="0" rIns="0" bIns="0" rtlCol="0" anchor="ctr"/>
-          <a:lstStyle/>
-          <a:p>
-            <a:pPr indent="0" marL="0">
-              <a:buNone/>
-            </a:pPr>
-            <a:r>
-              <a:rPr lang="en-US" sz="1500" b="1" dirty="0">
+            <a:off x="4828032" y="1737360"/>
+            <a:ext cx="1143000" cy="365760"/>
+          </a:xfrm>
+          <a:prstGeom prst="rect">
+            <a:avLst/>
+          </a:prstGeom>
+          <a:noFill/>
+          <a:ln/>
+        </p:spPr>
+        <p:txBody>
+          <a:bodyPr wrap="square" lIns="0" tIns="0" rIns="0" bIns="0" rtlCol="0" anchor="ctr"/>
+          <a:lstStyle/>
+          <a:p>
+            <a:pPr indent="0" marL="0">
+              <a:buNone/>
+            </a:pPr>
+            <a:r>
+              <a:rPr lang="en-US" sz="1600" b="1" dirty="0">
                 <a:solidFill>
                   <a:srgbClr val="111827"/>
                 </a:solidFill>
@@ -4504,7 +4504,7 @@
               </a:rPr>
               <a:t>ernie-ui</a:t>
             </a:r>
-            <a:endParaRPr lang="en-US" sz="1500" dirty="0"/>
+            <a:endParaRPr lang="en-US" sz="1600" dirty="0"/>
           </a:p>
         </p:txBody>
       </p:sp>
@@ -4524,8 +4524,8 @@
         </p:blipFill>
         <p:spPr>
           <a:xfrm>
-            <a:off x="5971032" y="1655064"/>
-            <a:ext cx="502920" cy="502920"/>
+            <a:off x="5934456" y="1673352"/>
+            <a:ext cx="530352" cy="530352"/>
           </a:xfrm>
           <a:prstGeom prst="rect">
             <a:avLst/>
@@ -4540,24 +4540,24 @@
         </p:nvSpPr>
         <p:spPr>
           <a:xfrm>
-            <a:off x="4800600" y="2103120"/>
-            <a:ext cx="1600200" cy="1280160"/>
-          </a:xfrm>
-          <a:prstGeom prst="rect">
-            <a:avLst/>
-          </a:prstGeom>
-          <a:noFill/>
-          <a:ln/>
-        </p:spPr>
-        <p:txBody>
-          <a:bodyPr wrap="square" lIns="0" tIns="0" rIns="0" bIns="0" rtlCol="0" anchor="ctr"/>
-          <a:lstStyle/>
-          <a:p>
-            <a:pPr indent="0" marL="0">
-              <a:buNone/>
-            </a:pPr>
-            <a:r>
-              <a:rPr lang="en-US" sz="950" dirty="0">
+            <a:off x="4828032" y="2240280"/>
+            <a:ext cx="1545336" cy="960120"/>
+          </a:xfrm>
+          <a:prstGeom prst="rect">
+            <a:avLst/>
+          </a:prstGeom>
+          <a:noFill/>
+          <a:ln/>
+        </p:spPr>
+        <p:txBody>
+          <a:bodyPr wrap="square" lIns="0" tIns="0" rIns="0" bIns="0" rtlCol="0" anchor="ctr"/>
+          <a:lstStyle/>
+          <a:p>
+            <a:pPr indent="0" marL="0">
+              <a:buNone/>
+            </a:pPr>
+            <a:r>
+              <a:rPr lang="en-US" sz="1150" dirty="0">
                 <a:solidFill>
                   <a:srgbClr val="4B5563"/>
                 </a:solidFill>
@@ -4565,9 +4565,9 @@
                 <a:ea typeface="Arial" pitchFamily="34" charset="-122"/>
                 <a:cs typeface="Arial" pitchFamily="34" charset="-120"/>
               </a:rPr>
-              <a:t>A component kit that bakes the criteria in: 56 px targets, 20 px text, 7:1 contrast, a way back on every screen. Synced to Claude Design so mockups use real parts.</a:t>
-            </a:r>
-            <a:endParaRPr lang="en-US" sz="950" dirty="0"/>
+              <a:t>A component kit with the criteria baked in. Synced to Claude Design.</a:t>
+            </a:r>
+            <a:endParaRPr lang="en-US" sz="1150" dirty="0"/>
           </a:p>
         </p:txBody>
       </p:sp>
@@ -4579,7 +4579,7 @@
         </p:nvSpPr>
         <p:spPr>
           <a:xfrm>
-            <a:off x="6556248" y="2011680"/>
+            <a:off x="6556248" y="1965960"/>
             <a:ext cx="146304" cy="0"/>
           </a:xfrm>
           <a:prstGeom prst="line">
@@ -4604,11 +4604,11 @@
         <p:spPr>
           <a:xfrm>
             <a:off x="6720840" y="1600200"/>
-            <a:ext cx="1874520" cy="1874520"/>
+            <a:ext cx="1874520" cy="1691640"/>
           </a:xfrm>
           <a:prstGeom prst="roundRect">
             <a:avLst>
-              <a:gd name="adj" fmla="val 7317"/>
+              <a:gd name="adj" fmla="val 8108"/>
             </a:avLst>
           </a:prstGeom>
           <a:solidFill>
@@ -4630,24 +4630,24 @@
         </p:nvSpPr>
         <p:spPr>
           <a:xfrm>
-            <a:off x="6858000" y="1709928"/>
-            <a:ext cx="1188720" cy="365760"/>
-          </a:xfrm>
-          <a:prstGeom prst="rect">
-            <a:avLst/>
-          </a:prstGeom>
-          <a:noFill/>
-          <a:ln/>
-        </p:spPr>
-        <p:txBody>
-          <a:bodyPr wrap="square" lIns="0" tIns="0" rIns="0" bIns="0" rtlCol="0" anchor="ctr"/>
-          <a:lstStyle/>
-          <a:p>
-            <a:pPr indent="0" marL="0">
-              <a:buNone/>
-            </a:pPr>
-            <a:r>
-              <a:rPr lang="en-US" sz="1500" b="1" dirty="0">
+            <a:off x="6885432" y="1737360"/>
+            <a:ext cx="1143000" cy="365760"/>
+          </a:xfrm>
+          <a:prstGeom prst="rect">
+            <a:avLst/>
+          </a:prstGeom>
+          <a:noFill/>
+          <a:ln/>
+        </p:spPr>
+        <p:txBody>
+          <a:bodyPr wrap="square" lIns="0" tIns="0" rIns="0" bIns="0" rtlCol="0" anchor="ctr"/>
+          <a:lstStyle/>
+          <a:p>
+            <a:pPr indent="0" marL="0">
+              <a:buNone/>
+            </a:pPr>
+            <a:r>
+              <a:rPr lang="en-US" sz="1600" b="1" dirty="0">
                 <a:solidFill>
                   <a:srgbClr val="FFFFFF"/>
                 </a:solidFill>
@@ -4657,7 +4657,7 @@
               </a:rPr>
               <a:t>The app</a:t>
             </a:r>
-            <a:endParaRPr lang="en-US" sz="1500" dirty="0"/>
+            <a:endParaRPr lang="en-US" sz="1600" dirty="0"/>
           </a:p>
         </p:txBody>
       </p:sp>
@@ -4669,24 +4669,24 @@
         </p:nvSpPr>
         <p:spPr>
           <a:xfrm>
-            <a:off x="6858000" y="2103120"/>
-            <a:ext cx="1600200" cy="1280160"/>
-          </a:xfrm>
-          <a:prstGeom prst="rect">
-            <a:avLst/>
-          </a:prstGeom>
-          <a:noFill/>
-          <a:ln/>
-        </p:spPr>
-        <p:txBody>
-          <a:bodyPr wrap="square" lIns="0" tIns="0" rIns="0" bIns="0" rtlCol="0" anchor="ctr"/>
-          <a:lstStyle/>
-          <a:p>
-            <a:pPr indent="0" marL="0">
-              <a:buNone/>
-            </a:pPr>
-            <a:r>
-              <a:rPr lang="en-US" sz="950" dirty="0">
+            <a:off x="6885432" y="2240280"/>
+            <a:ext cx="1545336" cy="960120"/>
+          </a:xfrm>
+          <a:prstGeom prst="rect">
+            <a:avLst/>
+          </a:prstGeom>
+          <a:noFill/>
+          <a:ln/>
+        </p:spPr>
+        <p:txBody>
+          <a:bodyPr wrap="square" lIns="0" tIns="0" rIns="0" bIns="0" rtlCol="0" anchor="ctr"/>
+          <a:lstStyle/>
+          <a:p>
+            <a:pPr indent="0" marL="0">
+              <a:buNone/>
+            </a:pPr>
+            <a:r>
+              <a:rPr lang="en-US" sz="1150" dirty="0">
                 <a:solidFill>
                   <a:srgbClr val="C7D2FE"/>
                 </a:solidFill>
@@ -4694,9 +4694,9 @@
                 <a:ea typeface="Arial" pitchFamily="34" charset="-122"/>
                 <a:cs typeface="Arial" pitchFamily="34" charset="-120"/>
               </a:rPr>
-              <a:t>One Node process: the daily visit and a reader. Claude reads her replies as data and never advises; the tap-only fallback works with no model at all.</a:t>
-            </a:r>
-            <a:endParaRPr lang="en-US" sz="950" dirty="0"/>
+              <a:t>One small web service. Claude reads her replies as data, never advice. Works without a model.</a:t>
+            </a:r>
+            <a:endParaRPr lang="en-US" sz="1150" dirty="0"/>
           </a:p>
         </p:txBody>
       </p:sp>
@@ -4708,12 +4708,12 @@
         </p:nvSpPr>
         <p:spPr>
           <a:xfrm>
-            <a:off x="548640" y="3703320"/>
-            <a:ext cx="8046720" cy="777240"/>
+            <a:off x="548640" y="3657600"/>
+            <a:ext cx="8046720" cy="822960"/>
           </a:xfrm>
           <a:prstGeom prst="roundRect">
             <a:avLst>
-              <a:gd name="adj" fmla="val 17647"/>
+              <a:gd name="adj" fmla="val 16667"/>
             </a:avLst>
           </a:prstGeom>
           <a:solidFill>
@@ -4735,24 +4735,24 @@
         </p:nvSpPr>
         <p:spPr>
           <a:xfrm>
-            <a:off x="731520" y="3776472"/>
-            <a:ext cx="1280160" cy="320040"/>
-          </a:xfrm>
-          <a:prstGeom prst="rect">
-            <a:avLst/>
-          </a:prstGeom>
-          <a:noFill/>
-          <a:ln/>
-        </p:spPr>
-        <p:txBody>
-          <a:bodyPr wrap="square" lIns="0" tIns="0" rIns="0" bIns="0" rtlCol="0" anchor="ctr"/>
-          <a:lstStyle/>
-          <a:p>
-            <a:pPr indent="0" marL="0">
-              <a:buNone/>
-            </a:pPr>
-            <a:r>
-              <a:rPr lang="en-US" sz="1400" b="1" dirty="0">
+            <a:off x="731520" y="3749040"/>
+            <a:ext cx="1371600" cy="365760"/>
+          </a:xfrm>
+          <a:prstGeom prst="rect">
+            <a:avLst/>
+          </a:prstGeom>
+          <a:noFill/>
+          <a:ln/>
+        </p:spPr>
+        <p:txBody>
+          <a:bodyPr wrap="square" lIns="0" tIns="0" rIns="0" bIns="0" rtlCol="0" anchor="ctr"/>
+          <a:lstStyle/>
+          <a:p>
+            <a:pPr indent="0" marL="0">
+              <a:buNone/>
+            </a:pPr>
+            <a:r>
+              <a:rPr lang="en-US" sz="1600" b="1" dirty="0">
                 <a:solidFill>
                   <a:srgbClr val="1E40AF"/>
                 </a:solidFill>
@@ -4762,7 +4762,7 @@
               </a:rPr>
               <a:t>ux-critic</a:t>
             </a:r>
-            <a:endParaRPr lang="en-US" sz="1400" dirty="0"/>
+            <a:endParaRPr lang="en-US" sz="1600" dirty="0"/>
           </a:p>
         </p:txBody>
       </p:sp>
@@ -4774,24 +4774,24 @@
         </p:nvSpPr>
         <p:spPr>
           <a:xfrm>
-            <a:off x="2011680" y="3749040"/>
-            <a:ext cx="6400800" cy="713232"/>
-          </a:xfrm>
-          <a:prstGeom prst="rect">
-            <a:avLst/>
-          </a:prstGeom>
-          <a:noFill/>
-          <a:ln/>
-        </p:spPr>
-        <p:txBody>
-          <a:bodyPr wrap="square" lIns="0" tIns="0" rIns="0" bIns="0" rtlCol="0" anchor="ctr"/>
-          <a:lstStyle/>
-          <a:p>
-            <a:pPr indent="0" marL="0">
-              <a:buNone/>
-            </a:pPr>
-            <a:r>
-              <a:rPr lang="en-US" sz="950" dirty="0">
+            <a:off x="2103120" y="3730752"/>
+            <a:ext cx="6309360" cy="685800"/>
+          </a:xfrm>
+          <a:prstGeom prst="rect">
+            <a:avLst/>
+          </a:prstGeom>
+          <a:noFill/>
+          <a:ln/>
+        </p:spPr>
+        <p:txBody>
+          <a:bodyPr wrap="square" lIns="0" tIns="0" rIns="0" bIns="0" rtlCol="0" anchor="ctr"/>
+          <a:lstStyle/>
+          <a:p>
+            <a:pPr indent="0" marL="0">
+              <a:buNone/>
+            </a:pPr>
+            <a:r>
+              <a:rPr lang="en-US" sz="1150" dirty="0">
                 <a:solidFill>
                   <a:srgbClr val="111827"/>
                 </a:solidFill>
@@ -4799,9 +4799,9 @@
                 <a:ea typeface="Arial" pitchFamily="34" charset="-122"/>
                 <a:cs typeface="Arial" pitchFamily="34" charset="-120"/>
               </a:rPr>
-              <a:t>A senior-centred reviewer that runs before every pull request: Playwright drives the real page, axe-core checks WCAG, custom checks measure targets, text size, jargon, motion and reflow at 200% zoom against the 80+ checklist. It returns a ranked list; a Blocker or High item blocks the merge.</a:t>
-            </a:r>
-            <a:endParaRPr lang="en-US" sz="950" dirty="0"/>
+              <a:t>Runs before every pull request. Drives the real page, checks it against the 80+ checklist, and blocks anything an 84-year-old could not use.</a:t>
+            </a:r>
+            <a:endParaRPr lang="en-US" sz="1150" dirty="0"/>
           </a:p>
         </p:txBody>
       </p:sp>
@@ -4813,8 +4813,8 @@
         </p:nvSpPr>
         <p:spPr>
           <a:xfrm>
-            <a:off x="7406640" y="3493008"/>
-            <a:ext cx="0" cy="192024"/>
+            <a:off x="7406640" y="3310128"/>
+            <a:ext cx="0" cy="329184"/>
           </a:xfrm>
           <a:prstGeom prst="line">
             <a:avLst/>
@@ -4837,8 +4837,8 @@
         </p:nvSpPr>
         <p:spPr>
           <a:xfrm flipV="1">
-            <a:off x="1463040" y="3493008"/>
-            <a:ext cx="0" cy="192024"/>
+            <a:off x="1463040" y="3310128"/>
+            <a:ext cx="0" cy="329184"/>
           </a:xfrm>
           <a:prstGeom prst="line">
             <a:avLst/>
@@ -4861,7 +4861,7 @@
         </p:nvSpPr>
         <p:spPr>
           <a:xfrm>
-            <a:off x="7498080" y="3493008"/>
+            <a:off x="7498080" y="3401568"/>
             <a:ext cx="731520" cy="182880"/>
           </a:xfrm>
           <a:prstGeom prst="rect">
@@ -4900,8 +4900,8 @@
         </p:nvSpPr>
         <p:spPr>
           <a:xfrm>
-            <a:off x="1554480" y="3493008"/>
-            <a:ext cx="1097280" cy="182880"/>
+            <a:off x="1554480" y="3401568"/>
+            <a:ext cx="731520" cy="182880"/>
           </a:xfrm>
           <a:prstGeom prst="rect">
             <a:avLst/>
@@ -4925,7 +4925,7 @@
                 <a:ea typeface="Arial" pitchFamily="34" charset="-122"/>
                 <a:cs typeface="Arial" pitchFamily="34" charset="-120"/>
               </a:rPr>
-              <a:t>fixes go back</a:t>
+              <a:t>fixes</a:t>
             </a:r>
             <a:endParaRPr lang="en-US" sz="800" dirty="0"/>
           </a:p>
@@ -4964,7 +4964,7 @@
                 <a:ea typeface="Arial" pitchFamily="34" charset="-122"/>
                 <a:cs typeface="Arial" pitchFamily="34" charset="-120"/>
               </a:rPr>
-              <a:t>Everything in this pipeline is in the repository: docs/, packages/ernie-ui, packages/app, tools/ux-audit, .claude/agents/ux-critic.md.</a:t>
+              <a:t>All of it is in the repository.</a:t>
             </a:r>
             <a:endParaRPr lang="en-US" sz="800" dirty="0"/>
           </a:p>

</xml_diff>

<commit_message>
Talk deck: critic feeds fixes into ernie-ui, not research
Co-Authored-By: Claude Fable 5.1 <noreply@anthropic.com>
Claude-Session: https://claude.ai/code/session_013zf8N3BNKm8ntFDtGarkNG
</commit_message>
<xml_diff>
--- a/docs/talk/ernie-talk.pptx
+++ b/docs/talk/ernie-talk.pptx
@@ -4837,7 +4837,7 @@
         </p:nvSpPr>
         <p:spPr>
           <a:xfrm flipV="1">
-            <a:off x="1463040" y="3310128"/>
+            <a:off x="5029200" y="3310128"/>
             <a:ext cx="0" cy="329184"/>
           </a:xfrm>
           <a:prstGeom prst="line">
@@ -4900,7 +4900,7 @@
         </p:nvSpPr>
         <p:spPr>
           <a:xfrm>
-            <a:off x="1554480" y="3401568"/>
+            <a:off x="5120640" y="3401568"/>
             <a:ext cx="731520" cy="182880"/>
           </a:xfrm>
           <a:prstGeom prst="rect">

</xml_diff>

<commit_message>
Talk deck: back-of-envelope savings and lives estimates, with working
Slide 3 gains the delirium-attributable readmission cost; slide 2 the
lives ceiling; both derived on the sources page from cited figures and
labelled as upper bounds.

Co-Authored-By: Claude Fable 5.1 <noreply@anthropic.com>
Claude-Session: https://claude.ai/code/session_013zf8N3BNKm8ntFDtGarkNG
</commit_message>
<xml_diff>
--- a/docs/talk/ernie-talk.pptx
+++ b/docs/talk/ernie-talk.pptx
@@ -839,7 +839,7 @@
           <a:p>
             <a:r>
               <a:rPr lang="en-US" dirty="0"/>
-              <a:t>0:30. Margaret is a person, not a use case. Hypoactive delirium is withdrawal; the first anyone knows is the ER. Unrecognised in 60 to 75 percent of cases even where clinicians are looking, and nothing at home looks at all. The thesis in one line: delirium is a change from your own baseline, and the home never had one.</a:t>
+              <a:t>0:30. Margaret is a person, not a use case. Hypoactive delirium is withdrawal; the first anyone knows is the ER. Unrecognised in 60 to 75 percent of cases even where clinicians are looking, and nothing at home looks at all. People who have delirium are far more likely to be dead two years later; if we could prevent it at home the way hospital programmes do, that is tens of thousands of lives a year, and I will say plainly that is a ceiling, not a claim. The thesis in one line: delirium is a change from your own baseline, and the home never had one.</a:t>
             </a:r>
             <a:endParaRPr lang="en-US" dirty="0"/>
           </a:p>
@@ -927,7 +927,7 @@
           <a:p>
             <a:r>
               <a:rPr lang="en-US" dirty="0"/>
-              <a:t>1:15. Value-based care moved the cost of coming back onto the hospital: a readmission penalty is a haircut on every Medicare inpatient payment for a year, up to three percent. Sepsis and heart failure send the most people back; delirium is not a category, it rides inside those stays and more than doubles the odds of returning. A stay with delirium bills about eight thousand dollars more. A quarter of readmissions are judged avoidable, and a third of delirium is preventable with cheap measures. The outcome is decided at home, between visits, and nobody is there. So: a daily visit.</a:t>
+              <a:t>1:15. Value-based care moved the cost of coming back onto the hospital: a readmission penalty is a haircut on every Medicare inpatient payment for a year, up to three percent. Sepsis and heart failure send the most people back; delirium is not a category, it rides inside those stays and more than doubles the odds of returning. A stay with delirium bills about eight thousand dollars more. Put together, on the order of four to five billion dollars of Medicare readmissions a year ride on delirium; if a quarter of those are avoidable, that is about a billion. Upper bound, and no one has yet shown a home check-in moves it. The outcome is decided at home, between visits, and nobody is there. So: a daily visit.</a:t>
             </a:r>
             <a:endParaRPr lang="en-US" dirty="0"/>
           </a:p>
@@ -2087,11 +2087,11 @@
         <p:spPr>
           <a:xfrm>
             <a:off x="548640" y="3154680"/>
-            <a:ext cx="2468880" cy="914400"/>
+            <a:ext cx="1645920" cy="960120"/>
           </a:xfrm>
           <a:prstGeom prst="roundRect">
             <a:avLst>
-              <a:gd name="adj" fmla="val 15000"/>
+              <a:gd name="adj" fmla="val 14286"/>
             </a:avLst>
           </a:prstGeom>
           <a:solidFill>
@@ -2113,24 +2113,24 @@
         </p:nvSpPr>
         <p:spPr>
           <a:xfrm>
-            <a:off x="685800" y="3200400"/>
-            <a:ext cx="2286000" cy="457200"/>
-          </a:xfrm>
-          <a:prstGeom prst="rect">
-            <a:avLst/>
-          </a:prstGeom>
-          <a:noFill/>
-          <a:ln/>
-        </p:spPr>
-        <p:txBody>
-          <a:bodyPr wrap="square" lIns="0" tIns="0" rIns="0" bIns="0" rtlCol="0" anchor="ctr"/>
-          <a:lstStyle/>
-          <a:p>
-            <a:pPr indent="0" marL="0">
-              <a:buNone/>
-            </a:pPr>
-            <a:r>
-              <a:rPr lang="en-US" sz="2800" b="1" dirty="0">
+            <a:off x="658368" y="3200400"/>
+            <a:ext cx="1463040" cy="411480"/>
+          </a:xfrm>
+          <a:prstGeom prst="rect">
+            <a:avLst/>
+          </a:prstGeom>
+          <a:noFill/>
+          <a:ln/>
+        </p:spPr>
+        <p:txBody>
+          <a:bodyPr wrap="square" lIns="0" tIns="0" rIns="0" bIns="0" rtlCol="0" anchor="ctr"/>
+          <a:lstStyle/>
+          <a:p>
+            <a:pPr indent="0" marL="0">
+              <a:buNone/>
+            </a:pPr>
+            <a:r>
+              <a:rPr lang="en-US" sz="2200" b="1" dirty="0">
                 <a:solidFill>
                   <a:srgbClr val="1E40AF"/>
                 </a:solidFill>
@@ -2140,7 +2140,7 @@
               </a:rPr>
               <a:t>60–75%</a:t>
             </a:r>
-            <a:endParaRPr lang="en-US" sz="2800" dirty="0"/>
+            <a:endParaRPr lang="en-US" sz="2200" dirty="0"/>
           </a:p>
         </p:txBody>
       </p:sp>
@@ -2152,24 +2152,24 @@
         </p:nvSpPr>
         <p:spPr>
           <a:xfrm>
-            <a:off x="685800" y="3657600"/>
-            <a:ext cx="2286000" cy="365760"/>
-          </a:xfrm>
-          <a:prstGeom prst="rect">
-            <a:avLst/>
-          </a:prstGeom>
-          <a:noFill/>
-          <a:ln/>
-        </p:spPr>
-        <p:txBody>
-          <a:bodyPr wrap="square" lIns="0" tIns="0" rIns="0" bIns="0" rtlCol="0" anchor="ctr"/>
-          <a:lstStyle/>
-          <a:p>
-            <a:pPr indent="0" marL="0">
-              <a:buNone/>
-            </a:pPr>
-            <a:r>
-              <a:rPr lang="en-US" sz="1050" dirty="0">
+            <a:off x="658368" y="3593592"/>
+            <a:ext cx="1463040" cy="502920"/>
+          </a:xfrm>
+          <a:prstGeom prst="rect">
+            <a:avLst/>
+          </a:prstGeom>
+          <a:noFill/>
+          <a:ln/>
+        </p:spPr>
+        <p:txBody>
+          <a:bodyPr wrap="square" lIns="0" tIns="0" rIns="0" bIns="0" rtlCol="0" anchor="ctr"/>
+          <a:lstStyle/>
+          <a:p>
+            <a:pPr indent="0" marL="0">
+              <a:buNone/>
+            </a:pPr>
+            <a:r>
+              <a:rPr lang="en-US" sz="850" dirty="0">
                 <a:solidFill>
                   <a:srgbClr val="4B5563"/>
                 </a:solidFill>
@@ -2179,7 +2179,7 @@
               </a:rPr>
               <a:t>of cases unrecognised in hospital and in the ED ¹</a:t>
             </a:r>
-            <a:endParaRPr lang="en-US" sz="1050" dirty="0"/>
+            <a:endParaRPr lang="en-US" sz="850" dirty="0"/>
           </a:p>
         </p:txBody>
       </p:sp>
@@ -2191,12 +2191,12 @@
         </p:nvSpPr>
         <p:spPr>
           <a:xfrm>
-            <a:off x="3200400" y="3154680"/>
-            <a:ext cx="2468880" cy="914400"/>
+            <a:off x="2331720" y="3154680"/>
+            <a:ext cx="1645920" cy="960120"/>
           </a:xfrm>
           <a:prstGeom prst="roundRect">
             <a:avLst>
-              <a:gd name="adj" fmla="val 15000"/>
+              <a:gd name="adj" fmla="val 14286"/>
             </a:avLst>
           </a:prstGeom>
           <a:solidFill>
@@ -2218,24 +2218,24 @@
         </p:nvSpPr>
         <p:spPr>
           <a:xfrm>
-            <a:off x="3337560" y="3200400"/>
-            <a:ext cx="2286000" cy="457200"/>
-          </a:xfrm>
-          <a:prstGeom prst="rect">
-            <a:avLst/>
-          </a:prstGeom>
-          <a:noFill/>
-          <a:ln/>
-        </p:spPr>
-        <p:txBody>
-          <a:bodyPr wrap="square" lIns="0" tIns="0" rIns="0" bIns="0" rtlCol="0" anchor="ctr"/>
-          <a:lstStyle/>
-          <a:p>
-            <a:pPr indent="0" marL="0">
-              <a:buNone/>
-            </a:pPr>
-            <a:r>
-              <a:rPr lang="en-US" sz="2800" b="1" dirty="0">
+            <a:off x="2441448" y="3200400"/>
+            <a:ext cx="1463040" cy="411480"/>
+          </a:xfrm>
+          <a:prstGeom prst="rect">
+            <a:avLst/>
+          </a:prstGeom>
+          <a:noFill/>
+          <a:ln/>
+        </p:spPr>
+        <p:txBody>
+          <a:bodyPr wrap="square" lIns="0" tIns="0" rIns="0" bIns="0" rtlCol="0" anchor="ctr"/>
+          <a:lstStyle/>
+          <a:p>
+            <a:pPr indent="0" marL="0">
+              <a:buNone/>
+            </a:pPr>
+            <a:r>
+              <a:rPr lang="en-US" sz="2200" b="1" dirty="0">
                 <a:solidFill>
                   <a:srgbClr val="1E40AF"/>
                 </a:solidFill>
@@ -2245,7 +2245,7 @@
               </a:rPr>
               <a:t>7 M+</a:t>
             </a:r>
-            <a:endParaRPr lang="en-US" sz="2800" dirty="0"/>
+            <a:endParaRPr lang="en-US" sz="2200" dirty="0"/>
           </a:p>
         </p:txBody>
       </p:sp>
@@ -2257,24 +2257,24 @@
         </p:nvSpPr>
         <p:spPr>
           <a:xfrm>
-            <a:off x="3337560" y="3657600"/>
-            <a:ext cx="2286000" cy="365760"/>
-          </a:xfrm>
-          <a:prstGeom prst="rect">
-            <a:avLst/>
-          </a:prstGeom>
-          <a:noFill/>
-          <a:ln/>
-        </p:spPr>
-        <p:txBody>
-          <a:bodyPr wrap="square" lIns="0" tIns="0" rIns="0" bIns="0" rtlCol="0" anchor="ctr"/>
-          <a:lstStyle/>
-          <a:p>
-            <a:pPr indent="0" marL="0">
-              <a:buNone/>
-            </a:pPr>
-            <a:r>
-              <a:rPr lang="en-US" sz="1050" dirty="0">
+            <a:off x="2441448" y="3593592"/>
+            <a:ext cx="1463040" cy="502920"/>
+          </a:xfrm>
+          <a:prstGeom prst="rect">
+            <a:avLst/>
+          </a:prstGeom>
+          <a:noFill/>
+          <a:ln/>
+        </p:spPr>
+        <p:txBody>
+          <a:bodyPr wrap="square" lIns="0" tIns="0" rIns="0" bIns="0" rtlCol="0" anchor="ctr"/>
+          <a:lstStyle/>
+          <a:p>
+            <a:pPr indent="0" marL="0">
+              <a:buNone/>
+            </a:pPr>
+            <a:r>
+              <a:rPr lang="en-US" sz="850" dirty="0">
                 <a:solidFill>
                   <a:srgbClr val="4B5563"/>
                 </a:solidFill>
@@ -2284,13 +2284,118 @@
               </a:rPr>
               <a:t>hospitalised US adults affected each year ²</a:t>
             </a:r>
-            <a:endParaRPr lang="en-US" sz="1050" dirty="0"/>
-          </a:p>
-        </p:txBody>
-      </p:sp>
-      <p:sp>
-        <p:nvSpPr>
-          <p:cNvPr id="11" name="Text 9"/>
+            <a:endParaRPr lang="en-US" sz="850" dirty="0"/>
+          </a:p>
+        </p:txBody>
+      </p:sp>
+      <p:sp>
+        <p:nvSpPr>
+          <p:cNvPr id="11" name="Shape 9"/>
+          <p:cNvSpPr/>
+          <p:nvPr/>
+        </p:nvSpPr>
+        <p:spPr>
+          <a:xfrm>
+            <a:off x="4114800" y="3154680"/>
+            <a:ext cx="1645920" cy="960120"/>
+          </a:xfrm>
+          <a:prstGeom prst="roundRect">
+            <a:avLst>
+              <a:gd name="adj" fmla="val 14286"/>
+            </a:avLst>
+          </a:prstGeom>
+          <a:solidFill>
+            <a:srgbClr val="DBEAFE"/>
+          </a:solidFill>
+          <a:ln w="12700">
+            <a:solidFill>
+              <a:srgbClr val="4B5563"/>
+            </a:solidFill>
+            <a:prstDash val="solid"/>
+          </a:ln>
+        </p:spPr>
+      </p:sp>
+      <p:sp>
+        <p:nvSpPr>
+          <p:cNvPr id="12" name="Text 10"/>
+          <p:cNvSpPr txBox="1"/>
+          <p:nvPr/>
+        </p:nvSpPr>
+        <p:spPr>
+          <a:xfrm>
+            <a:off x="4224528" y="3200400"/>
+            <a:ext cx="1463040" cy="411480"/>
+          </a:xfrm>
+          <a:prstGeom prst="rect">
+            <a:avLst/>
+          </a:prstGeom>
+          <a:noFill/>
+          <a:ln/>
+        </p:spPr>
+        <p:txBody>
+          <a:bodyPr wrap="square" lIns="0" tIns="0" rIns="0" bIns="0" rtlCol="0" anchor="ctr"/>
+          <a:lstStyle/>
+          <a:p>
+            <a:pPr indent="0" marL="0">
+              <a:buNone/>
+            </a:pPr>
+            <a:r>
+              <a:rPr lang="en-US" sz="2200" b="1" dirty="0">
+                <a:solidFill>
+                  <a:srgbClr val="1E40AF"/>
+                </a:solidFill>
+                <a:latin typeface="Arial" pitchFamily="34" charset="0"/>
+                <a:ea typeface="Arial" pitchFamily="34" charset="-122"/>
+                <a:cs typeface="Arial" pitchFamily="34" charset="-120"/>
+              </a:rPr>
+              <a:t>40–100 k</a:t>
+            </a:r>
+            <a:endParaRPr lang="en-US" sz="2200" dirty="0"/>
+          </a:p>
+        </p:txBody>
+      </p:sp>
+      <p:sp>
+        <p:nvSpPr>
+          <p:cNvPr id="13" name="Text 11"/>
+          <p:cNvSpPr txBox="1"/>
+          <p:nvPr/>
+        </p:nvSpPr>
+        <p:spPr>
+          <a:xfrm>
+            <a:off x="4224528" y="3593592"/>
+            <a:ext cx="1463040" cy="502920"/>
+          </a:xfrm>
+          <a:prstGeom prst="rect">
+            <a:avLst/>
+          </a:prstGeom>
+          <a:noFill/>
+          <a:ln/>
+        </p:spPr>
+        <p:txBody>
+          <a:bodyPr wrap="square" lIns="0" tIns="0" rIns="0" bIns="0" rtlCol="0" anchor="ctr"/>
+          <a:lstStyle/>
+          <a:p>
+            <a:pPr indent="0" marL="0">
+              <a:buNone/>
+            </a:pPr>
+            <a:r>
+              <a:rPr lang="en-US" sz="850" dirty="0">
+                <a:solidFill>
+                  <a:srgbClr val="4B5563"/>
+                </a:solidFill>
+                <a:latin typeface="Arial" pitchFamily="34" charset="0"/>
+                <a:ea typeface="Arial" pitchFamily="34" charset="-122"/>
+                <a:cs typeface="Arial" pitchFamily="34" charset="-120"/>
+              </a:rPr>
+              <a:t>lives a year, if home detection prevented delirium as well as hospital programmes do. A ceiling ⁸</a:t>
+            </a:r>
+            <a:endParaRPr lang="en-US" sz="850" dirty="0"/>
+          </a:p>
+        </p:txBody>
+      </p:sp>
+      <p:sp>
+        <p:nvSpPr>
+          <p:cNvPr id="14" name="Text 12"/>
           <p:cNvSpPr txBox="1"/>
           <p:nvPr/>
         </p:nvSpPr>
@@ -2329,7 +2434,7 @@
       </p:sp>
       <p:sp>
         <p:nvSpPr>
-          <p:cNvPr id="12" name="Text 10"/>
+          <p:cNvPr id="15" name="Text 13"/>
           <p:cNvSpPr txBox="1"/>
           <p:nvPr/>
         </p:nvSpPr>
@@ -2360,7 +2465,7 @@
                 <a:ea typeface="Arial" pitchFamily="34" charset="-122"/>
                 <a:cs typeface="Arial" pitchFamily="34" charset="-120"/>
               </a:rPr>
-              <a:t>¹ Unrecognised in up to 60% of hospital cases and ~75% in the ED: Delirium in Hospitalized Older Adults, narrative review (PMC 2026); Han et al., ED delirium screening (PMC 2024).  ² Frontiers in Public Health 2026, Medicare Current Beneficiary Survey 2019–21.</a:t>
+              <a:t>¹ Narrative review (PMC 2026); ED delirium screening (PMC 2024).  ² Frontiers in Public Health 2026, MCBS 2019–21.  ⁸ Witlox et al., JAMA 2010 (38.0% vs 27.5% dead at ~2 years, adjusted HR 1.95) × 1.3–2.6 M older adults a year × 30–40% preventable (HELP). Association, not proof; see sources slide.</a:t>
             </a:r>
             <a:endParaRPr lang="en-US" sz="800" dirty="0"/>
           </a:p>
@@ -2368,7 +2473,7 @@
       </p:sp>
       <p:sp>
         <p:nvSpPr>
-          <p:cNvPr id="13" name="Shape 11"/>
+          <p:cNvPr id="16" name="Shape 14"/>
           <p:cNvSpPr/>
           <p:nvPr/>
         </p:nvSpPr>
@@ -2395,7 +2500,7 @@
       </p:sp>
       <p:pic>
         <p:nvPicPr>
-          <p:cNvPr id="14" name="Image 0" descr="../shots/03-book-page-c.png">    </p:cNvPr>
+          <p:cNvPr id="17" name="Image 0" descr="../shots/03-book-page-c.png">    </p:cNvPr>
           <p:cNvPicPr>
             <a:picLocks noChangeAspect="1"/>
           </p:cNvPicPr>
@@ -2888,7 +2993,7 @@
                 <a:ea typeface="Arial" pitchFamily="34" charset="-122"/>
                 <a:cs typeface="Arial" pitchFamily="34" charset="-120"/>
               </a:rPr>
-              <a:t>~27%</a:t>
+              <a:t>$3.6–5.4 B</a:t>
             </a:r>
             <a:endParaRPr lang="en-US" sz="2100" dirty="0"/>
           </a:p>
@@ -2927,7 +3032,7 @@
                 <a:ea typeface="Arial" pitchFamily="34" charset="-122"/>
                 <a:cs typeface="Arial" pitchFamily="34" charset="-120"/>
               </a:rPr>
-              <a:t>of readmissions judged avoidable (median of 34 studies). Delirium itself: 30–40% preventable ⁶</a:t>
+              <a:t>a year of Medicare readmissions attributable to delirium. If a quarter is avoidable, as for readmissions generally: about $1 B ⁶ ⁷</a:t>
             </a:r>
             <a:endParaRPr lang="en-US" sz="900" dirty="0"/>
           </a:p>
@@ -2966,7 +3071,7 @@
                 <a:ea typeface="Arial" pitchFamily="34" charset="-122"/>
                 <a:cs typeface="Arial" pitchFamily="34" charset="-120"/>
               </a:rPr>
-              <a:t>³ AHRQ HCUP Statistical Brief 307, Nationwide Readmissions Database 2020.  ⁴ CMS Hospital Readmissions Reduction Program; KFF, 10 Years of Hospital Readmissions Penalties (FY2022).  ⁵ Community hospital cohort, n = 8,645, OR 2.60 (PMC 2019).  ⁶ van Walraven et al., CMAJ 2011; Inouye et al., NEJM 1999 (HELP).</a:t>
+              <a:t>³ AHRQ HCUP Statistical Brief 307, NRD 2020.  ⁴ CMS HRRP; KFF, 10 Years of Hospital Readmissions Penalties (FY2022).  ⁵ Community hospital cohort, n = 8,645, OR 2.60 (PMC 2019).  ⁶ van Walraven et al., CMAJ 2011.  ⁷ Back-of-envelope from ²,³,⁵: upper bound, assumes the association is causal; see sources slide.</a:t>
             </a:r>
             <a:endParaRPr lang="en-US" sz="800" dirty="0"/>
           </a:p>
@@ -5702,7 +5807,7 @@
         </p:nvSpPr>
         <p:spPr>
           <a:xfrm>
-            <a:off x="548640" y="1005840"/>
+            <a:off x="548640" y="914400"/>
             <a:ext cx="274320" cy="274320"/>
           </a:xfrm>
           <a:prstGeom prst="rect">
@@ -5741,24 +5846,24 @@
         </p:nvSpPr>
         <p:spPr>
           <a:xfrm>
-            <a:off x="868680" y="1005840"/>
-            <a:ext cx="4846320" cy="603504"/>
-          </a:xfrm>
-          <a:prstGeom prst="rect">
-            <a:avLst/>
-          </a:prstGeom>
-          <a:noFill/>
-          <a:ln/>
-        </p:spPr>
-        <p:txBody>
-          <a:bodyPr wrap="square" lIns="0" tIns="0" rIns="0" bIns="0" rtlCol="0" anchor="ctr"/>
-          <a:lstStyle/>
-          <a:p>
-            <a:pPr indent="0" marL="0">
-              <a:buNone/>
-            </a:pPr>
-            <a:r>
-              <a:rPr lang="en-US" sz="900" dirty="0">
+            <a:off x="868680" y="914400"/>
+            <a:ext cx="5120640" cy="320040"/>
+          </a:xfrm>
+          <a:prstGeom prst="rect">
+            <a:avLst/>
+          </a:prstGeom>
+          <a:noFill/>
+          <a:ln/>
+        </p:spPr>
+        <p:txBody>
+          <a:bodyPr wrap="square" lIns="0" tIns="0" rIns="0" bIns="0" rtlCol="0" anchor="ctr"/>
+          <a:lstStyle/>
+          <a:p>
+            <a:pPr indent="0" marL="0">
+              <a:buNone/>
+            </a:pPr>
+            <a:r>
+              <a:rPr lang="en-US" sz="750" dirty="0">
                 <a:solidFill>
                   <a:srgbClr val="111827"/>
                 </a:solidFill>
@@ -5768,7 +5873,7 @@
               </a:rPr>
               <a:t>Delirium unrecognised in up to 60% of hospital cases and about 75% in the emergency department.</a:t>
             </a:r>
-            <a:endParaRPr lang="en-US" sz="900" dirty="0"/>
+            <a:endParaRPr lang="en-US" sz="750" dirty="0"/>
           </a:p>
         </p:txBody>
       </p:sp>
@@ -5780,24 +5885,24 @@
         </p:nvSpPr>
         <p:spPr>
           <a:xfrm>
-            <a:off x="5852160" y="1005840"/>
-            <a:ext cx="2834640" cy="603504"/>
-          </a:xfrm>
-          <a:prstGeom prst="rect">
-            <a:avLst/>
-          </a:prstGeom>
-          <a:noFill/>
-          <a:ln/>
-        </p:spPr>
-        <p:txBody>
-          <a:bodyPr wrap="square" lIns="0" tIns="0" rIns="0" bIns="0" rtlCol="0" anchor="ctr"/>
-          <a:lstStyle/>
-          <a:p>
-            <a:pPr indent="0" marL="0">
-              <a:buNone/>
-            </a:pPr>
-            <a:r>
-              <a:rPr lang="en-US" sz="850" i="1" dirty="0">
+            <a:off x="6126480" y="914400"/>
+            <a:ext cx="2560320" cy="320040"/>
+          </a:xfrm>
+          <a:prstGeom prst="rect">
+            <a:avLst/>
+          </a:prstGeom>
+          <a:noFill/>
+          <a:ln/>
+        </p:spPr>
+        <p:txBody>
+          <a:bodyPr wrap="square" lIns="0" tIns="0" rIns="0" bIns="0" rtlCol="0" anchor="ctr"/>
+          <a:lstStyle/>
+          <a:p>
+            <a:pPr indent="0" marL="0">
+              <a:buNone/>
+            </a:pPr>
+            <a:r>
+              <a:rPr lang="en-US" sz="750" i="1" dirty="0">
                 <a:solidFill>
                   <a:srgbClr val="4B5563"/>
                 </a:solidFill>
@@ -5807,7 +5912,7 @@
               </a:rPr>
               <a:t>Delirium in Hospitalized Older Adults: A Narrative Review (PMC, 2026); Delirium screening in the emergency department (PMC, 2024).</a:t>
             </a:r>
-            <a:endParaRPr lang="en-US" sz="850" dirty="0"/>
+            <a:endParaRPr lang="en-US" sz="750" dirty="0"/>
           </a:p>
         </p:txBody>
       </p:sp>
@@ -5819,7 +5924,7 @@
         </p:nvSpPr>
         <p:spPr>
           <a:xfrm>
-            <a:off x="548640" y="1627632"/>
+            <a:off x="548640" y="1280160"/>
             <a:ext cx="274320" cy="274320"/>
           </a:xfrm>
           <a:prstGeom prst="rect">
@@ -5858,24 +5963,24 @@
         </p:nvSpPr>
         <p:spPr>
           <a:xfrm>
-            <a:off x="868680" y="1627632"/>
-            <a:ext cx="4846320" cy="603504"/>
-          </a:xfrm>
-          <a:prstGeom prst="rect">
-            <a:avLst/>
-          </a:prstGeom>
-          <a:noFill/>
-          <a:ln/>
-        </p:spPr>
-        <p:txBody>
-          <a:bodyPr wrap="square" lIns="0" tIns="0" rIns="0" bIns="0" rtlCol="0" anchor="ctr"/>
-          <a:lstStyle/>
-          <a:p>
-            <a:pPr indent="0" marL="0">
-              <a:buNone/>
-            </a:pPr>
-            <a:r>
-              <a:rPr lang="en-US" sz="900" dirty="0">
+            <a:off x="868680" y="1280160"/>
+            <a:ext cx="5120640" cy="365760"/>
+          </a:xfrm>
+          <a:prstGeom prst="rect">
+            <a:avLst/>
+          </a:prstGeom>
+          <a:noFill/>
+          <a:ln/>
+        </p:spPr>
+        <p:txBody>
+          <a:bodyPr wrap="square" lIns="0" tIns="0" rIns="0" bIns="0" rtlCol="0" anchor="ctr"/>
+          <a:lstStyle/>
+          <a:p>
+            <a:pPr indent="0" marL="0">
+              <a:buNone/>
+            </a:pPr>
+            <a:r>
+              <a:rPr lang="en-US" sz="750" dirty="0">
                 <a:solidFill>
                   <a:srgbClr val="111827"/>
                 </a:solidFill>
@@ -5885,7 +5990,7 @@
               </a:rPr>
               <a:t>Delirium affects over 7 million hospitalised US adults a year; 11% of Medicare beneficiaries had an episode; +$8,110 hospital charges per delirium stay (95% CI $1,860–$14,360).</a:t>
             </a:r>
-            <a:endParaRPr lang="en-US" sz="900" dirty="0"/>
+            <a:endParaRPr lang="en-US" sz="750" dirty="0"/>
           </a:p>
         </p:txBody>
       </p:sp>
@@ -5897,24 +6002,24 @@
         </p:nvSpPr>
         <p:spPr>
           <a:xfrm>
-            <a:off x="5852160" y="1627632"/>
-            <a:ext cx="2834640" cy="603504"/>
-          </a:xfrm>
-          <a:prstGeom prst="rect">
-            <a:avLst/>
-          </a:prstGeom>
-          <a:noFill/>
-          <a:ln/>
-        </p:spPr>
-        <p:txBody>
-          <a:bodyPr wrap="square" lIns="0" tIns="0" rIns="0" bIns="0" rtlCol="0" anchor="ctr"/>
-          <a:lstStyle/>
-          <a:p>
-            <a:pPr indent="0" marL="0">
-              <a:buNone/>
-            </a:pPr>
-            <a:r>
-              <a:rPr lang="en-US" sz="850" i="1" dirty="0">
+            <a:off x="6126480" y="1280160"/>
+            <a:ext cx="2560320" cy="365760"/>
+          </a:xfrm>
+          <a:prstGeom prst="rect">
+            <a:avLst/>
+          </a:prstGeom>
+          <a:noFill/>
+          <a:ln/>
+        </p:spPr>
+        <p:txBody>
+          <a:bodyPr wrap="square" lIns="0" tIns="0" rIns="0" bIns="0" rtlCol="0" anchor="ctr"/>
+          <a:lstStyle/>
+          <a:p>
+            <a:pPr indent="0" marL="0">
+              <a:buNone/>
+            </a:pPr>
+            <a:r>
+              <a:rPr lang="en-US" sz="750" i="1" dirty="0">
                 <a:solidFill>
                   <a:srgbClr val="4B5563"/>
                 </a:solidFill>
@@ -5924,7 +6029,7 @@
               </a:rPr>
               <a:t>Additional hospitalization costs associated with delirium among older adults, Frontiers in Public Health, 2026 (Medicare Current Beneficiary Survey 2019–2021).</a:t>
             </a:r>
-            <a:endParaRPr lang="en-US" sz="850" dirty="0"/>
+            <a:endParaRPr lang="en-US" sz="750" dirty="0"/>
           </a:p>
         </p:txBody>
       </p:sp>
@@ -5936,7 +6041,7 @@
         </p:nvSpPr>
         <p:spPr>
           <a:xfrm>
-            <a:off x="548640" y="2249424"/>
+            <a:off x="548640" y="1691640"/>
             <a:ext cx="274320" cy="274320"/>
           </a:xfrm>
           <a:prstGeom prst="rect">
@@ -5975,24 +6080,24 @@
         </p:nvSpPr>
         <p:spPr>
           <a:xfrm>
-            <a:off x="868680" y="2249424"/>
-            <a:ext cx="4846320" cy="603504"/>
-          </a:xfrm>
-          <a:prstGeom prst="rect">
-            <a:avLst/>
-          </a:prstGeom>
-          <a:noFill/>
-          <a:ln/>
-        </p:spPr>
-        <p:txBody>
-          <a:bodyPr wrap="square" lIns="0" tIns="0" rIns="0" bIns="0" rtlCol="0" anchor="ctr"/>
-          <a:lstStyle/>
-          <a:p>
-            <a:pPr indent="0" marL="0">
-              <a:buNone/>
-            </a:pPr>
-            <a:r>
-              <a:rPr lang="en-US" sz="900" dirty="0">
+            <a:off x="868680" y="1691640"/>
+            <a:ext cx="5120640" cy="457200"/>
+          </a:xfrm>
+          <a:prstGeom prst="rect">
+            <a:avLst/>
+          </a:prstGeom>
+          <a:noFill/>
+          <a:ln/>
+        </p:spPr>
+        <p:txBody>
+          <a:bodyPr wrap="square" lIns="0" tIns="0" rIns="0" bIns="0" rtlCol="0" anchor="ctr"/>
+          <a:lstStyle/>
+          <a:p>
+            <a:pPr indent="0" marL="0">
+              <a:buNone/>
+            </a:pPr>
+            <a:r>
+              <a:rPr lang="en-US" sz="750" dirty="0">
                 <a:solidFill>
                   <a:srgbClr val="111827"/>
                 </a:solidFill>
@@ -6002,7 +6107,7 @@
               </a:rPr>
               <a:t>Medicare: 2,002,700 30-day readmissions in 2020, 17.0 per 100 index stays, $36.2 B aggregate, $18,100 average. Top causes at index admission: septicemia 207,300; heart failure 147,800; acute renal failure 60,000; pneumonia 58,900; diabetes with complications 58,700.</a:t>
             </a:r>
-            <a:endParaRPr lang="en-US" sz="900" dirty="0"/>
+            <a:endParaRPr lang="en-US" sz="750" dirty="0"/>
           </a:p>
         </p:txBody>
       </p:sp>
@@ -6014,24 +6119,24 @@
         </p:nvSpPr>
         <p:spPr>
           <a:xfrm>
-            <a:off x="5852160" y="2249424"/>
-            <a:ext cx="2834640" cy="603504"/>
-          </a:xfrm>
-          <a:prstGeom prst="rect">
-            <a:avLst/>
-          </a:prstGeom>
-          <a:noFill/>
-          <a:ln/>
-        </p:spPr>
-        <p:txBody>
-          <a:bodyPr wrap="square" lIns="0" tIns="0" rIns="0" bIns="0" rtlCol="0" anchor="ctr"/>
-          <a:lstStyle/>
-          <a:p>
-            <a:pPr indent="0" marL="0">
-              <a:buNone/>
-            </a:pPr>
-            <a:r>
-              <a:rPr lang="en-US" sz="850" i="1" dirty="0">
+            <a:off x="6126480" y="1691640"/>
+            <a:ext cx="2560320" cy="457200"/>
+          </a:xfrm>
+          <a:prstGeom prst="rect">
+            <a:avLst/>
+          </a:prstGeom>
+          <a:noFill/>
+          <a:ln/>
+        </p:spPr>
+        <p:txBody>
+          <a:bodyPr wrap="square" lIns="0" tIns="0" rIns="0" bIns="0" rtlCol="0" anchor="ctr"/>
+          <a:lstStyle/>
+          <a:p>
+            <a:pPr indent="0" marL="0">
+              <a:buNone/>
+            </a:pPr>
+            <a:r>
+              <a:rPr lang="en-US" sz="750" i="1" dirty="0">
                 <a:solidFill>
                   <a:srgbClr val="4B5563"/>
                 </a:solidFill>
@@ -6041,7 +6146,7 @@
               </a:rPr>
               <a:t>AHRQ HCUP Statistical Brief #307, Nationwide Readmissions Database, 2020.</a:t>
             </a:r>
-            <a:endParaRPr lang="en-US" sz="850" dirty="0"/>
+            <a:endParaRPr lang="en-US" sz="750" dirty="0"/>
           </a:p>
         </p:txBody>
       </p:sp>
@@ -6053,7 +6158,7 @@
         </p:nvSpPr>
         <p:spPr>
           <a:xfrm>
-            <a:off x="548640" y="2871216"/>
+            <a:off x="548640" y="2194560"/>
             <a:ext cx="274320" cy="274320"/>
           </a:xfrm>
           <a:prstGeom prst="rect">
@@ -6092,24 +6197,24 @@
         </p:nvSpPr>
         <p:spPr>
           <a:xfrm>
-            <a:off x="868680" y="2871216"/>
-            <a:ext cx="4846320" cy="603504"/>
-          </a:xfrm>
-          <a:prstGeom prst="rect">
-            <a:avLst/>
-          </a:prstGeom>
-          <a:noFill/>
-          <a:ln/>
-        </p:spPr>
-        <p:txBody>
-          <a:bodyPr wrap="square" lIns="0" tIns="0" rIns="0" bIns="0" rtlCol="0" anchor="ctr"/>
-          <a:lstStyle/>
-          <a:p>
-            <a:pPr indent="0" marL="0">
-              <a:buNone/>
-            </a:pPr>
-            <a:r>
-              <a:rPr lang="en-US" sz="900" dirty="0">
+            <a:off x="868680" y="2194560"/>
+            <a:ext cx="5120640" cy="457200"/>
+          </a:xfrm>
+          <a:prstGeom prst="rect">
+            <a:avLst/>
+          </a:prstGeom>
+          <a:noFill/>
+          <a:ln/>
+        </p:spPr>
+        <p:txBody>
+          <a:bodyPr wrap="square" lIns="0" tIns="0" rIns="0" bIns="0" rtlCol="0" anchor="ctr"/>
+          <a:lstStyle/>
+          <a:p>
+            <a:pPr indent="0" marL="0">
+              <a:buNone/>
+            </a:pPr>
+            <a:r>
+              <a:rPr lang="en-US" sz="750" dirty="0">
                 <a:solidFill>
                   <a:srgbClr val="111827"/>
                 </a:solidFill>
@@ -6119,7 +6224,7 @@
               </a:rPr>
               <a:t>HRRP reduces a hospital’s Medicare inpatient payments by up to 3% for a fiscal year when 30-day readmissions for six conditions exceed the expected rate. FY2022: 2,499 of 3,139 hospitals penalised, average 0.64%, 39 at the 3% maximum, about $521 M withheld.</a:t>
             </a:r>
-            <a:endParaRPr lang="en-US" sz="900" dirty="0"/>
+            <a:endParaRPr lang="en-US" sz="750" dirty="0"/>
           </a:p>
         </p:txBody>
       </p:sp>
@@ -6131,24 +6236,24 @@
         </p:nvSpPr>
         <p:spPr>
           <a:xfrm>
-            <a:off x="5852160" y="2871216"/>
-            <a:ext cx="2834640" cy="603504"/>
-          </a:xfrm>
-          <a:prstGeom prst="rect">
-            <a:avLst/>
-          </a:prstGeom>
-          <a:noFill/>
-          <a:ln/>
-        </p:spPr>
-        <p:txBody>
-          <a:bodyPr wrap="square" lIns="0" tIns="0" rIns="0" bIns="0" rtlCol="0" anchor="ctr"/>
-          <a:lstStyle/>
-          <a:p>
-            <a:pPr indent="0" marL="0">
-              <a:buNone/>
-            </a:pPr>
-            <a:r>
-              <a:rPr lang="en-US" sz="850" i="1" dirty="0">
+            <a:off x="6126480" y="2194560"/>
+            <a:ext cx="2560320" cy="457200"/>
+          </a:xfrm>
+          <a:prstGeom prst="rect">
+            <a:avLst/>
+          </a:prstGeom>
+          <a:noFill/>
+          <a:ln/>
+        </p:spPr>
+        <p:txBody>
+          <a:bodyPr wrap="square" lIns="0" tIns="0" rIns="0" bIns="0" rtlCol="0" anchor="ctr"/>
+          <a:lstStyle/>
+          <a:p>
+            <a:pPr indent="0" marL="0">
+              <a:buNone/>
+            </a:pPr>
+            <a:r>
+              <a:rPr lang="en-US" sz="750" i="1" dirty="0">
                 <a:solidFill>
                   <a:srgbClr val="4B5563"/>
                 </a:solidFill>
@@ -6158,7 +6263,7 @@
               </a:rPr>
               <a:t>CMS, Hospital Readmissions Reduction Program; KFF, 10 Years of Hospital Readmissions Penalties.</a:t>
             </a:r>
-            <a:endParaRPr lang="en-US" sz="850" dirty="0"/>
+            <a:endParaRPr lang="en-US" sz="750" dirty="0"/>
           </a:p>
         </p:txBody>
       </p:sp>
@@ -6170,7 +6275,7 @@
         </p:nvSpPr>
         <p:spPr>
           <a:xfrm>
-            <a:off x="548640" y="3493008"/>
+            <a:off x="548640" y="2697480"/>
             <a:ext cx="274320" cy="274320"/>
           </a:xfrm>
           <a:prstGeom prst="rect">
@@ -6209,24 +6314,24 @@
         </p:nvSpPr>
         <p:spPr>
           <a:xfrm>
-            <a:off x="868680" y="3493008"/>
-            <a:ext cx="4846320" cy="603504"/>
-          </a:xfrm>
-          <a:prstGeom prst="rect">
-            <a:avLst/>
-          </a:prstGeom>
-          <a:noFill/>
-          <a:ln/>
-        </p:spPr>
-        <p:txBody>
-          <a:bodyPr wrap="square" lIns="0" tIns="0" rIns="0" bIns="0" rtlCol="0" anchor="ctr"/>
-          <a:lstStyle/>
-          <a:p>
-            <a:pPr indent="0" marL="0">
-              <a:buNone/>
-            </a:pPr>
-            <a:r>
-              <a:rPr lang="en-US" sz="900" dirty="0">
+            <a:off x="868680" y="2697480"/>
+            <a:ext cx="5120640" cy="365760"/>
+          </a:xfrm>
+          <a:prstGeom prst="rect">
+            <a:avLst/>
+          </a:prstGeom>
+          <a:noFill/>
+          <a:ln/>
+        </p:spPr>
+        <p:txBody>
+          <a:bodyPr wrap="square" lIns="0" tIns="0" rIns="0" bIns="0" rtlCol="0" anchor="ctr"/>
+          <a:lstStyle/>
+          <a:p>
+            <a:pPr indent="0" marL="0">
+              <a:buNone/>
+            </a:pPr>
+            <a:r>
+              <a:rPr lang="en-US" sz="750" dirty="0">
                 <a:solidFill>
                   <a:srgbClr val="111827"/>
                 </a:solidFill>
@@ -6236,7 +6341,7 @@
               </a:rPr>
               <a:t>Inpatient delirium associated with 30-day readmission, adjusted OR 2.60 (95% CI 1.96–3.44); 718 delirious vs 7,927 non-delirious patients, one community hospital, 2010–2015.</a:t>
             </a:r>
-            <a:endParaRPr lang="en-US" sz="900" dirty="0"/>
+            <a:endParaRPr lang="en-US" sz="750" dirty="0"/>
           </a:p>
         </p:txBody>
       </p:sp>
@@ -6248,24 +6353,24 @@
         </p:nvSpPr>
         <p:spPr>
           <a:xfrm>
-            <a:off x="5852160" y="3493008"/>
-            <a:ext cx="2834640" cy="603504"/>
-          </a:xfrm>
-          <a:prstGeom prst="rect">
-            <a:avLst/>
-          </a:prstGeom>
-          <a:noFill/>
-          <a:ln/>
-        </p:spPr>
-        <p:txBody>
-          <a:bodyPr wrap="square" lIns="0" tIns="0" rIns="0" bIns="0" rtlCol="0" anchor="ctr"/>
-          <a:lstStyle/>
-          <a:p>
-            <a:pPr indent="0" marL="0">
-              <a:buNone/>
-            </a:pPr>
-            <a:r>
-              <a:rPr lang="en-US" sz="850" i="1" dirty="0">
+            <a:off x="6126480" y="2697480"/>
+            <a:ext cx="2560320" cy="365760"/>
+          </a:xfrm>
+          <a:prstGeom prst="rect">
+            <a:avLst/>
+          </a:prstGeom>
+          <a:noFill/>
+          <a:ln/>
+        </p:spPr>
+        <p:txBody>
+          <a:bodyPr wrap="square" lIns="0" tIns="0" rIns="0" bIns="0" rtlCol="0" anchor="ctr"/>
+          <a:lstStyle/>
+          <a:p>
+            <a:pPr indent="0" marL="0">
+              <a:buNone/>
+            </a:pPr>
+            <a:r>
+              <a:rPr lang="en-US" sz="750" i="1" dirty="0">
                 <a:solidFill>
                   <a:srgbClr val="4B5563"/>
                 </a:solidFill>
@@ -6275,7 +6380,7 @@
               </a:rPr>
               <a:t>Association between Inpatient Delirium and Hospital Readmission in Patients ≥65 (PMC, 2019).</a:t>
             </a:r>
-            <a:endParaRPr lang="en-US" sz="850" dirty="0"/>
+            <a:endParaRPr lang="en-US" sz="750" dirty="0"/>
           </a:p>
         </p:txBody>
       </p:sp>
@@ -6287,7 +6392,7 @@
         </p:nvSpPr>
         <p:spPr>
           <a:xfrm>
-            <a:off x="548640" y="4114800"/>
+            <a:off x="548640" y="3108960"/>
             <a:ext cx="274320" cy="274320"/>
           </a:xfrm>
           <a:prstGeom prst="rect">
@@ -6326,24 +6431,24 @@
         </p:nvSpPr>
         <p:spPr>
           <a:xfrm>
-            <a:off x="868680" y="4114800"/>
-            <a:ext cx="4846320" cy="603504"/>
-          </a:xfrm>
-          <a:prstGeom prst="rect">
-            <a:avLst/>
-          </a:prstGeom>
-          <a:noFill/>
-          <a:ln/>
-        </p:spPr>
-        <p:txBody>
-          <a:bodyPr wrap="square" lIns="0" tIns="0" rIns="0" bIns="0" rtlCol="0" anchor="ctr"/>
-          <a:lstStyle/>
-          <a:p>
-            <a:pPr indent="0" marL="0">
-              <a:buNone/>
-            </a:pPr>
-            <a:r>
-              <a:rPr lang="en-US" sz="900" dirty="0">
+            <a:off x="868680" y="3108960"/>
+            <a:ext cx="5120640" cy="365760"/>
+          </a:xfrm>
+          <a:prstGeom prst="rect">
+            <a:avLst/>
+          </a:prstGeom>
+          <a:noFill/>
+          <a:ln/>
+        </p:spPr>
+        <p:txBody>
+          <a:bodyPr wrap="square" lIns="0" tIns="0" rIns="0" bIns="0" rtlCol="0" anchor="ctr"/>
+          <a:lstStyle/>
+          <a:p>
+            <a:pPr indent="0" marL="0">
+              <a:buNone/>
+            </a:pPr>
+            <a:r>
+              <a:rPr lang="en-US" sz="750" dirty="0">
                 <a:solidFill>
                   <a:srgbClr val="111827"/>
                 </a:solidFill>
@@ -6351,9 +6456,9 @@
                 <a:ea typeface="Arial" pitchFamily="34" charset="-122"/>
                 <a:cs typeface="Arial" pitchFamily="34" charset="-120"/>
               </a:rPr>
-              <a:t>Median 27% of readmissions judged avoidable across 34 studies (range 5–79%). Multicomponent prevention (HELP) cut delirium incidence from 15.0% to 9.9%, about a third to 40%.</a:t>
-            </a:r>
-            <a:endParaRPr lang="en-US" sz="900" dirty="0"/>
+              <a:t>Median 27% of readmissions judged avoidable across 34 studies (range 5–79%). Multicomponent prevention (HELP) cut delirium incidence from 15.0% to 9.9%.</a:t>
+            </a:r>
+            <a:endParaRPr lang="en-US" sz="750" dirty="0"/>
           </a:p>
         </p:txBody>
       </p:sp>
@@ -6365,24 +6470,24 @@
         </p:nvSpPr>
         <p:spPr>
           <a:xfrm>
-            <a:off x="5852160" y="4114800"/>
-            <a:ext cx="2834640" cy="603504"/>
-          </a:xfrm>
-          <a:prstGeom prst="rect">
-            <a:avLst/>
-          </a:prstGeom>
-          <a:noFill/>
-          <a:ln/>
-        </p:spPr>
-        <p:txBody>
-          <a:bodyPr wrap="square" lIns="0" tIns="0" rIns="0" bIns="0" rtlCol="0" anchor="ctr"/>
-          <a:lstStyle/>
-          <a:p>
-            <a:pPr indent="0" marL="0">
-              <a:buNone/>
-            </a:pPr>
-            <a:r>
-              <a:rPr lang="en-US" sz="850" i="1" dirty="0">
+            <a:off x="6126480" y="3108960"/>
+            <a:ext cx="2560320" cy="365760"/>
+          </a:xfrm>
+          <a:prstGeom prst="rect">
+            <a:avLst/>
+          </a:prstGeom>
+          <a:noFill/>
+          <a:ln/>
+        </p:spPr>
+        <p:txBody>
+          <a:bodyPr wrap="square" lIns="0" tIns="0" rIns="0" bIns="0" rtlCol="0" anchor="ctr"/>
+          <a:lstStyle/>
+          <a:p>
+            <a:pPr indent="0" marL="0">
+              <a:buNone/>
+            </a:pPr>
+            <a:r>
+              <a:rPr lang="en-US" sz="750" i="1" dirty="0">
                 <a:solidFill>
                   <a:srgbClr val="4B5563"/>
                 </a:solidFill>
@@ -6392,7 +6497,241 @@
               </a:rPr>
               <a:t>van Walraven et al., CMAJ 2011; Inouye et al., NEJM 1999.</a:t>
             </a:r>
-            <a:endParaRPr lang="en-US" sz="850" dirty="0"/>
+            <a:endParaRPr lang="en-US" sz="750" dirty="0"/>
+          </a:p>
+        </p:txBody>
+      </p:sp>
+      <p:sp>
+        <p:nvSpPr>
+          <p:cNvPr id="21" name="Text 19"/>
+          <p:cNvSpPr txBox="1"/>
+          <p:nvPr/>
+        </p:nvSpPr>
+        <p:spPr>
+          <a:xfrm>
+            <a:off x="548640" y="3520440"/>
+            <a:ext cx="274320" cy="274320"/>
+          </a:xfrm>
+          <a:prstGeom prst="rect">
+            <a:avLst/>
+          </a:prstGeom>
+          <a:noFill/>
+          <a:ln/>
+        </p:spPr>
+        <p:txBody>
+          <a:bodyPr wrap="square" lIns="0" tIns="0" rIns="0" bIns="0" rtlCol="0" anchor="ctr"/>
+          <a:lstStyle/>
+          <a:p>
+            <a:pPr indent="0" marL="0">
+              <a:buNone/>
+            </a:pPr>
+            <a:r>
+              <a:rPr lang="en-US" sz="1100" b="1" dirty="0">
+                <a:solidFill>
+                  <a:srgbClr val="1E40AF"/>
+                </a:solidFill>
+                <a:latin typeface="Arial" pitchFamily="34" charset="0"/>
+                <a:ea typeface="Arial" pitchFamily="34" charset="-122"/>
+                <a:cs typeface="Arial" pitchFamily="34" charset="-120"/>
+              </a:rPr>
+              <a:t>7</a:t>
+            </a:r>
+            <a:endParaRPr lang="en-US" sz="1100" dirty="0"/>
+          </a:p>
+        </p:txBody>
+      </p:sp>
+      <p:sp>
+        <p:nvSpPr>
+          <p:cNvPr id="22" name="Text 20"/>
+          <p:cNvSpPr txBox="1"/>
+          <p:nvPr/>
+        </p:nvSpPr>
+        <p:spPr>
+          <a:xfrm>
+            <a:off x="868680" y="3520440"/>
+            <a:ext cx="5120640" cy="612648"/>
+          </a:xfrm>
+          <a:prstGeom prst="rect">
+            <a:avLst/>
+          </a:prstGeom>
+          <a:noFill/>
+          <a:ln/>
+        </p:spPr>
+        <p:txBody>
+          <a:bodyPr wrap="square" lIns="0" tIns="0" rIns="0" bIns="0" rtlCol="0" anchor="ctr"/>
+          <a:lstStyle/>
+          <a:p>
+            <a:pPr indent="0" marL="0">
+              <a:buNone/>
+            </a:pPr>
+            <a:r>
+              <a:rPr lang="en-US" sz="750" dirty="0">
+                <a:solidFill>
+                  <a:srgbClr val="111827"/>
+                </a:solidFill>
+                <a:latin typeface="Arial" pitchFamily="34" charset="0"/>
+                <a:ea typeface="Arial" pitchFamily="34" charset="-122"/>
+                <a:cs typeface="Arial" pitchFamily="34" charset="-120"/>
+              </a:rPr>
+              <a:t>Back of the envelope: 11.8 M Medicare stays × 11% = 1.3 M delirium stays. With 2.0–2.6× the readmission risk and a 17% overall rate, delirium stays run 15–23 points above the rest: 200–300 k excess readmissions × $18,100 = $3.6–5.4 B a year. × 27% avoidable ≈ $1.0–1.5 B. Upper bound: delirium also marks sicker patients, and no trial yet shows a home check-in reduces readmissions.</a:t>
+            </a:r>
+            <a:endParaRPr lang="en-US" sz="750" dirty="0"/>
+          </a:p>
+        </p:txBody>
+      </p:sp>
+      <p:sp>
+        <p:nvSpPr>
+          <p:cNvPr id="23" name="Text 21"/>
+          <p:cNvSpPr txBox="1"/>
+          <p:nvPr/>
+        </p:nvSpPr>
+        <p:spPr>
+          <a:xfrm>
+            <a:off x="6126480" y="3520440"/>
+            <a:ext cx="2560320" cy="612648"/>
+          </a:xfrm>
+          <a:prstGeom prst="rect">
+            <a:avLst/>
+          </a:prstGeom>
+          <a:noFill/>
+          <a:ln/>
+        </p:spPr>
+        <p:txBody>
+          <a:bodyPr wrap="square" lIns="0" tIns="0" rIns="0" bIns="0" rtlCol="0" anchor="ctr"/>
+          <a:lstStyle/>
+          <a:p>
+            <a:pPr indent="0" marL="0">
+              <a:buNone/>
+            </a:pPr>
+            <a:r>
+              <a:rPr lang="en-US" sz="750" i="1" dirty="0">
+                <a:solidFill>
+                  <a:srgbClr val="4B5563"/>
+                </a:solidFill>
+                <a:latin typeface="Arial" pitchFamily="34" charset="0"/>
+                <a:ea typeface="Arial" pitchFamily="34" charset="-122"/>
+                <a:cs typeface="Arial" pitchFamily="34" charset="-120"/>
+              </a:rPr>
+              <a:t>Derived from sources 2, 3 and 5.</a:t>
+            </a:r>
+            <a:endParaRPr lang="en-US" sz="750" dirty="0"/>
+          </a:p>
+        </p:txBody>
+      </p:sp>
+      <p:sp>
+        <p:nvSpPr>
+          <p:cNvPr id="24" name="Text 22"/>
+          <p:cNvSpPr txBox="1"/>
+          <p:nvPr/>
+        </p:nvSpPr>
+        <p:spPr>
+          <a:xfrm>
+            <a:off x="548640" y="4178808"/>
+            <a:ext cx="274320" cy="274320"/>
+          </a:xfrm>
+          <a:prstGeom prst="rect">
+            <a:avLst/>
+          </a:prstGeom>
+          <a:noFill/>
+          <a:ln/>
+        </p:spPr>
+        <p:txBody>
+          <a:bodyPr wrap="square" lIns="0" tIns="0" rIns="0" bIns="0" rtlCol="0" anchor="ctr"/>
+          <a:lstStyle/>
+          <a:p>
+            <a:pPr indent="0" marL="0">
+              <a:buNone/>
+            </a:pPr>
+            <a:r>
+              <a:rPr lang="en-US" sz="1100" b="1" dirty="0">
+                <a:solidFill>
+                  <a:srgbClr val="1E40AF"/>
+                </a:solidFill>
+                <a:latin typeface="Arial" pitchFamily="34" charset="0"/>
+                <a:ea typeface="Arial" pitchFamily="34" charset="-122"/>
+                <a:cs typeface="Arial" pitchFamily="34" charset="-120"/>
+              </a:rPr>
+              <a:t>8</a:t>
+            </a:r>
+            <a:endParaRPr lang="en-US" sz="1100" dirty="0"/>
+          </a:p>
+        </p:txBody>
+      </p:sp>
+      <p:sp>
+        <p:nvSpPr>
+          <p:cNvPr id="25" name="Text 23"/>
+          <p:cNvSpPr txBox="1"/>
+          <p:nvPr/>
+        </p:nvSpPr>
+        <p:spPr>
+          <a:xfrm>
+            <a:off x="868680" y="4178808"/>
+            <a:ext cx="5120640" cy="667512"/>
+          </a:xfrm>
+          <a:prstGeom prst="rect">
+            <a:avLst/>
+          </a:prstGeom>
+          <a:noFill/>
+          <a:ln/>
+        </p:spPr>
+        <p:txBody>
+          <a:bodyPr wrap="square" lIns="0" tIns="0" rIns="0" bIns="0" rtlCol="0" anchor="ctr"/>
+          <a:lstStyle/>
+          <a:p>
+            <a:pPr indent="0" marL="0">
+              <a:buNone/>
+            </a:pPr>
+            <a:r>
+              <a:rPr lang="en-US" sz="750" dirty="0">
+                <a:solidFill>
+                  <a:srgbClr val="111827"/>
+                </a:solidFill>
+                <a:latin typeface="Arial" pitchFamily="34" charset="0"/>
+                <a:ea typeface="Arial" pitchFamily="34" charset="-122"/>
+                <a:cs typeface="Arial" pitchFamily="34" charset="-120"/>
+              </a:rPr>
+              <a:t>Lives: 38.0% of older patients who had delirium were dead at ~2 years vs 27.5% of controls (adjusted HR 1.95, 95% CI 1.51–2.52; 7 studies). That 10-point excess on 1.3–2.6 M older adults a year is 130–270 k deaths associated with delirium. If home detection prevented delirium as well as in-hospital programmes (30–40%) and deaths fell with it: 40–100 k a year. Association only; delirium also marks frailty, and no trial shows a home check-in saves lives.</a:t>
+            </a:r>
+            <a:endParaRPr lang="en-US" sz="750" dirty="0"/>
+          </a:p>
+        </p:txBody>
+      </p:sp>
+      <p:sp>
+        <p:nvSpPr>
+          <p:cNvPr id="26" name="Text 24"/>
+          <p:cNvSpPr txBox="1"/>
+          <p:nvPr/>
+        </p:nvSpPr>
+        <p:spPr>
+          <a:xfrm>
+            <a:off x="6126480" y="4178808"/>
+            <a:ext cx="2560320" cy="667512"/>
+          </a:xfrm>
+          <a:prstGeom prst="rect">
+            <a:avLst/>
+          </a:prstGeom>
+          <a:noFill/>
+          <a:ln/>
+        </p:spPr>
+        <p:txBody>
+          <a:bodyPr wrap="square" lIns="0" tIns="0" rIns="0" bIns="0" rtlCol="0" anchor="ctr"/>
+          <a:lstStyle/>
+          <a:p>
+            <a:pPr indent="0" marL="0">
+              <a:buNone/>
+            </a:pPr>
+            <a:r>
+              <a:rPr lang="en-US" sz="750" i="1" dirty="0">
+                <a:solidFill>
+                  <a:srgbClr val="4B5563"/>
+                </a:solidFill>
+                <a:latin typeface="Arial" pitchFamily="34" charset="0"/>
+                <a:ea typeface="Arial" pitchFamily="34" charset="-122"/>
+                <a:cs typeface="Arial" pitchFamily="34" charset="-120"/>
+              </a:rPr>
+              <a:t>Witlox et al., JAMA 2010; Inouye et al., NEJM 1999; sources 2 and 3.</a:t>
+            </a:r>
+            <a:endParaRPr lang="en-US" sz="750" dirty="0"/>
           </a:p>
         </p:txBody>
       </p:sp>

</xml_diff>

<commit_message>
Talk deck: name TEAM, LEAD and ACCESS as the payment rails
Co-Authored-By: Claude Fable 5.1 <noreply@anthropic.com>
Claude-Session: https://claude.ai/code/session_013zf8N3BNKm8ntFDtGarkNG
</commit_message>
<xml_diff>
--- a/docs/talk/ernie-talk.pptx
+++ b/docs/talk/ernie-talk.pptx
@@ -927,7 +927,7 @@
           <a:p>
             <a:r>
               <a:rPr lang="en-US" dirty="0"/>
-              <a:t>1:15. Value-based care moved the cost of coming back onto the hospital: a readmission penalty is a haircut on every Medicare inpatient payment for a year, up to three percent. Sepsis and heart failure send the most people back; delirium is not a category, it rides inside those stays and more than doubles the odds of returning. A stay with delirium bills about eight thousand dollars more. Put together, on the order of four to five billion dollars of Medicare readmissions a year ride on delirium; if a quarter of those are avoidable, that is about a billion. Upper bound, and no one has yet shown a home check-in moves it. The outcome is decided at home, between visits, and nobody is there. So: a daily visit.</a:t>
+              <a:t>1:15. Value-based care moved the cost of coming back onto the hospital: a readmission penalty is a haircut on every Medicare inpatient payment for a year, up to three percent. Sepsis and heart failure send the most people back; delirium is not a category, it rides inside those stays and more than doubles the odds of returning. A stay with delirium bills about eight thousand dollars more. Put together, on the order of four to five billion dollars of Medicare readmissions a year ride on delirium; if a quarter of those are avoidable, that is about a billion. Upper bound, and no one has yet shown a home check-in moves it. And the rails now exist: TEAM and LEAD put hospitals and ACOs at risk for these 30 days, and since July ACCESS pays fixed outcome-aligned amounts for tech-enabled chronic care. The outcome is decided at home, between visits, and nobody is there. So: a daily visit.</a:t>
             </a:r>
             <a:endParaRPr lang="en-US" dirty="0"/>
           </a:p>
@@ -1279,7 +1279,7 @@
           <a:p>
             <a:r>
               <a:rPr lang="en-US" dirty="0"/>
-              <a:t>4:40. Three next steps, then the honesty line: synthetic data, decision support, a human on every flag. Close on Margaret: the point is that someone notices on the day it starts.</a:t>
+              <a:t>4:40. Three next steps. Who pays: ACCESS is the first CMS model that pays fixed outcome-aligned amounts for tech-enabled chronic care, and TEAM and LEAD make providers carry the 30 days, so a daily visit is what those models pay for. Then the honesty line: synthetic data, decision support, a human on every flag. Close on Margaret: the point is that someone notices on the day it starts.</a:t>
             </a:r>
             <a:endParaRPr lang="en-US" dirty="0"/>
           </a:p>
@@ -2601,24 +2601,24 @@
         </p:nvSpPr>
         <p:spPr>
           <a:xfrm>
-            <a:off x="548640" y="914400"/>
-            <a:ext cx="8046720" cy="548640"/>
-          </a:xfrm>
-          <a:prstGeom prst="rect">
-            <a:avLst/>
-          </a:prstGeom>
-          <a:noFill/>
-          <a:ln/>
-        </p:spPr>
-        <p:txBody>
-          <a:bodyPr wrap="square" lIns="0" tIns="0" rIns="0" bIns="0" rtlCol="0" anchor="ctr"/>
-          <a:lstStyle/>
-          <a:p>
-            <a:pPr indent="0" marL="0">
-              <a:buNone/>
-            </a:pPr>
-            <a:r>
-              <a:rPr lang="en-US" sz="1500" dirty="0">
+            <a:off x="548640" y="987552"/>
+            <a:ext cx="8046720" cy="502920"/>
+          </a:xfrm>
+          <a:prstGeom prst="rect">
+            <a:avLst/>
+          </a:prstGeom>
+          <a:noFill/>
+          <a:ln/>
+        </p:spPr>
+        <p:txBody>
+          <a:bodyPr wrap="square" lIns="0" tIns="0" rIns="0" bIns="0" rtlCol="0" anchor="ctr"/>
+          <a:lstStyle/>
+          <a:p>
+            <a:pPr indent="0" marL="0">
+              <a:buNone/>
+            </a:pPr>
+            <a:r>
+              <a:rPr lang="en-US" sz="1400" dirty="0">
                 <a:solidFill>
                   <a:srgbClr val="4B5563"/>
                 </a:solidFill>
@@ -2626,9 +2626,9 @@
                 <a:ea typeface="Arial" pitchFamily="34" charset="-122"/>
                 <a:cs typeface="Arial" pitchFamily="34" charset="-120"/>
               </a:rPr>
-              <a:t>Value-based care makes hospitals carry the cost of patients who come back. What sends Medicare patients back, and what a missed bad day costs.</a:t>
-            </a:r>
-            <a:endParaRPr lang="en-US" sz="1500" dirty="0"/>
+              <a:t>Hospitals and ACOs now carry the cost of the 30 days after discharge (TEAM, LEAD), and since July CMS’s ACCESS model pays fixed amounts for tech-enabled chronic care ⁹.</a:t>
+            </a:r>
+            <a:endParaRPr lang="en-US" sz="1400" dirty="0"/>
           </a:p>
         </p:txBody>
       </p:sp>
@@ -2640,7 +2640,7 @@
         </p:nvSpPr>
         <p:spPr>
           <a:xfrm>
-            <a:off x="548640" y="1508760"/>
+            <a:off x="548640" y="1572768"/>
             <a:ext cx="4846320" cy="274320"/>
           </a:xfrm>
           <a:prstGeom prst="rect">
@@ -2678,8 +2678,8 @@
           <p:nvPr/>
         </p:nvGraphicFramePr>
         <p:xfrm>
-          <a:off x="457200" y="1783080"/>
-          <a:ext cx="4846320" cy="2331720"/>
+          <a:off x="457200" y="1828800"/>
+          <a:ext cx="4846320" cy="2286000"/>
         </p:xfrm>
         <a:graphic xmlns:a="http://schemas.openxmlformats.org/drawingml/2006/main">
           <a:graphicData uri="http://schemas.openxmlformats.org/drawingml/2006/chart">
@@ -3071,7 +3071,7 @@
                 <a:ea typeface="Arial" pitchFamily="34" charset="-122"/>
                 <a:cs typeface="Arial" pitchFamily="34" charset="-120"/>
               </a:rPr>
-              <a:t>³ AHRQ HCUP Statistical Brief 307, NRD 2020.  ⁴ CMS HRRP; KFF, 10 Years of Hospital Readmissions Penalties (FY2022).  ⁵ Community hospital cohort, n = 8,645, OR 2.60 (PMC 2019).  ⁶ van Walraven et al., CMAJ 2011.  ⁷ Back-of-envelope from ²,³,⁵: upper bound, assumes the association is causal; see sources slide.</a:t>
+              <a:t>³ AHRQ HCUP Statistical Brief 307, NRD 2020.  ⁴ CMS HRRP; KFF, 10 Years of Hospital Readmissions Penalties (FY2022).  ⁵ Community hospital cohort, n = 8,645, OR 2.60 (PMC 2019).  ⁶ van Walraven et al., CMAJ 2011.  ⁷ Back-of-envelope from ²,³,⁵: upper bound; see sources slide.  ⁹ CMS Innovation Center: TEAM (2026), LEAD (2027), ACCESS (July 2026).</a:t>
             </a:r>
             <a:endParaRPr lang="en-US" sz="800" dirty="0"/>
           </a:p>
@@ -5617,9 +5617,153 @@
           </a:p>
         </p:txBody>
       </p:sp>
+      <p:sp>
+        <p:nvSpPr>
+          <p:cNvPr id="16" name="Shape 14"/>
+          <p:cNvSpPr/>
+          <p:nvPr/>
+        </p:nvSpPr>
+        <p:spPr>
+          <a:xfrm>
+            <a:off x="6035040" y="548640"/>
+            <a:ext cx="2560320" cy="2331720"/>
+          </a:xfrm>
+          <a:prstGeom prst="roundRect">
+            <a:avLst>
+              <a:gd name="adj" fmla="val 5882"/>
+            </a:avLst>
+          </a:prstGeom>
+          <a:solidFill>
+            <a:srgbClr val="1E40AF"/>
+          </a:solidFill>
+          <a:ln w="12700">
+            <a:solidFill>
+              <a:srgbClr val="4B5563"/>
+            </a:solidFill>
+            <a:prstDash val="solid"/>
+          </a:ln>
+        </p:spPr>
+      </p:sp>
+      <p:sp>
+        <p:nvSpPr>
+          <p:cNvPr id="17" name="Text 15"/>
+          <p:cNvSpPr txBox="1"/>
+          <p:nvPr/>
+        </p:nvSpPr>
+        <p:spPr>
+          <a:xfrm>
+            <a:off x="6217920" y="658368"/>
+            <a:ext cx="2194560" cy="365760"/>
+          </a:xfrm>
+          <a:prstGeom prst="rect">
+            <a:avLst/>
+          </a:prstGeom>
+          <a:noFill/>
+          <a:ln/>
+        </p:spPr>
+        <p:txBody>
+          <a:bodyPr wrap="square" lIns="0" tIns="0" rIns="0" bIns="0" rtlCol="0" anchor="ctr"/>
+          <a:lstStyle/>
+          <a:p>
+            <a:pPr indent="0" marL="0">
+              <a:buNone/>
+            </a:pPr>
+            <a:r>
+              <a:rPr lang="en-US" sz="1600" b="1" dirty="0">
+                <a:solidFill>
+                  <a:srgbClr val="FFFFFF"/>
+                </a:solidFill>
+                <a:latin typeface="Arial" pitchFamily="34" charset="0"/>
+                <a:ea typeface="Arial" pitchFamily="34" charset="-122"/>
+                <a:cs typeface="Arial" pitchFamily="34" charset="-120"/>
+              </a:rPr>
+              <a:t>Who pays</a:t>
+            </a:r>
+            <a:endParaRPr lang="en-US" sz="1600" dirty="0"/>
+          </a:p>
+        </p:txBody>
+      </p:sp>
+      <p:sp>
+        <p:nvSpPr>
+          <p:cNvPr id="18" name="Text 16"/>
+          <p:cNvSpPr txBox="1"/>
+          <p:nvPr/>
+        </p:nvSpPr>
+        <p:spPr>
+          <a:xfrm>
+            <a:off x="6217920" y="1051560"/>
+            <a:ext cx="2194560" cy="1371600"/>
+          </a:xfrm>
+          <a:prstGeom prst="rect">
+            <a:avLst/>
+          </a:prstGeom>
+          <a:noFill/>
+          <a:ln/>
+        </p:spPr>
+        <p:txBody>
+          <a:bodyPr wrap="square" lIns="0" tIns="0" rIns="0" bIns="0" rtlCol="0" anchor="ctr"/>
+          <a:lstStyle/>
+          <a:p>
+            <a:pPr indent="0" marL="0">
+              <a:buNone/>
+            </a:pPr>
+            <a:r>
+              <a:rPr lang="en-US" sz="1050" dirty="0">
+                <a:solidFill>
+                  <a:srgbClr val="FFFFFF"/>
+                </a:solidFill>
+                <a:latin typeface="Arial" pitchFamily="34" charset="0"/>
+                <a:ea typeface="Arial" pitchFamily="34" charset="-122"/>
+                <a:cs typeface="Arial" pitchFamily="34" charset="-120"/>
+              </a:rPr>
+              <a:t>CMS’s ACCESS model (July 2026) pays fixed, outcome-aligned amounts for tech-enabled chronic care instead of fee-for-service. TEAM and LEAD make hospitals and ACOs carry the 30 days at home.</a:t>
+            </a:r>
+            <a:endParaRPr lang="en-US" sz="1050" dirty="0"/>
+          </a:p>
+        </p:txBody>
+      </p:sp>
+      <p:sp>
+        <p:nvSpPr>
+          <p:cNvPr id="19" name="Text 17"/>
+          <p:cNvSpPr txBox="1"/>
+          <p:nvPr/>
+        </p:nvSpPr>
+        <p:spPr>
+          <a:xfrm>
+            <a:off x="6217920" y="2395728"/>
+            <a:ext cx="2194560" cy="411480"/>
+          </a:xfrm>
+          <a:prstGeom prst="rect">
+            <a:avLst/>
+          </a:prstGeom>
+          <a:noFill/>
+          <a:ln/>
+        </p:spPr>
+        <p:txBody>
+          <a:bodyPr wrap="square" lIns="0" tIns="0" rIns="0" bIns="0" rtlCol="0" anchor="ctr"/>
+          <a:lstStyle/>
+          <a:p>
+            <a:pPr indent="0" marL="0">
+              <a:buNone/>
+            </a:pPr>
+            <a:r>
+              <a:rPr lang="en-US" sz="1050" b="1" dirty="0">
+                <a:solidFill>
+                  <a:srgbClr val="C7D2FE"/>
+                </a:solidFill>
+                <a:latin typeface="Arial" pitchFamily="34" charset="0"/>
+                <a:ea typeface="Arial" pitchFamily="34" charset="-122"/>
+                <a:cs typeface="Arial" pitchFamily="34" charset="-120"/>
+              </a:rPr>
+              <a:t>A daily visit is what those models pay for ⁹</a:t>
+            </a:r>
+            <a:endParaRPr lang="en-US" sz="1050" dirty="0"/>
+          </a:p>
+        </p:txBody>
+      </p:sp>
       <p:pic>
         <p:nvPicPr>
-          <p:cNvPr id="16" name="Image 0" descr="../shots/doodle-half-a-house-white.png">    </p:cNvPr>
+          <p:cNvPr id="20" name="Image 0" descr="../shots/doodle-half-a-house-white.png">    </p:cNvPr>
           <p:cNvPicPr>
             <a:picLocks noChangeAspect="1"/>
           </p:cNvPicPr>
@@ -5633,65 +5777,17 @@
         </p:blipFill>
         <p:spPr>
           <a:xfrm>
-            <a:off x="6035040" y="457200"/>
-            <a:ext cx="1463040" cy="1463040"/>
+            <a:off x="6675120" y="2971800"/>
+            <a:ext cx="1280160" cy="1280160"/>
           </a:xfrm>
           <a:prstGeom prst="rect">
             <a:avLst/>
           </a:prstGeom>
         </p:spPr>
       </p:pic>
-      <p:pic>
-        <p:nvPicPr>
-          <p:cNvPr id="17" name="Image 1" descr="../shots/doodle-cat-with-no-face-white.png">    </p:cNvPr>
-          <p:cNvPicPr>
-            <a:picLocks noChangeAspect="1"/>
-          </p:cNvPicPr>
-          <p:nvPr/>
-        </p:nvPicPr>
-        <p:blipFill>
-          <a:blip r:embed="rId2"/>
-          <a:stretch>
-            <a:fillRect/>
-          </a:stretch>
-        </p:blipFill>
-        <p:spPr>
-          <a:xfrm>
-            <a:off x="7315200" y="1554480"/>
-            <a:ext cx="1463040" cy="1463040"/>
-          </a:xfrm>
-          <a:prstGeom prst="rect">
-            <a:avLst/>
-          </a:prstGeom>
-        </p:spPr>
-      </p:pic>
-      <p:pic>
-        <p:nvPicPr>
-          <p:cNvPr id="18" name="Image 2" descr="../shots/doodle-flower-with-no-petals-white.png">    </p:cNvPr>
-          <p:cNvPicPr>
-            <a:picLocks noChangeAspect="1"/>
-          </p:cNvPicPr>
-          <p:nvPr/>
-        </p:nvPicPr>
-        <p:blipFill>
-          <a:blip r:embed="rId3"/>
-          <a:stretch>
-            <a:fillRect/>
-          </a:stretch>
-        </p:blipFill>
-        <p:spPr>
-          <a:xfrm>
-            <a:off x="6035040" y="2651760"/>
-            <a:ext cx="1463040" cy="1463040"/>
-          </a:xfrm>
-          <a:prstGeom prst="rect">
-            <a:avLst/>
-          </a:prstGeom>
-        </p:spPr>
-      </p:pic>
-      <p:sp>
-        <p:nvSpPr>
-          <p:cNvPr id="19" name="Text 14"/>
+      <p:sp>
+        <p:nvSpPr>
+          <p:cNvPr id="21" name="Text 18"/>
           <p:cNvSpPr txBox="1"/>
           <p:nvPr/>
         </p:nvSpPr>
@@ -5807,7 +5903,7 @@
         </p:nvSpPr>
         <p:spPr>
           <a:xfrm>
-            <a:off x="548640" y="914400"/>
+            <a:off x="548640" y="868680"/>
             <a:ext cx="274320" cy="274320"/>
           </a:xfrm>
           <a:prstGeom prst="rect">
@@ -5846,24 +5942,24 @@
         </p:nvSpPr>
         <p:spPr>
           <a:xfrm>
-            <a:off x="868680" y="914400"/>
-            <a:ext cx="5120640" cy="320040"/>
-          </a:xfrm>
-          <a:prstGeom prst="rect">
-            <a:avLst/>
-          </a:prstGeom>
-          <a:noFill/>
-          <a:ln/>
-        </p:spPr>
-        <p:txBody>
-          <a:bodyPr wrap="square" lIns="0" tIns="0" rIns="0" bIns="0" rtlCol="0" anchor="ctr"/>
-          <a:lstStyle/>
-          <a:p>
-            <a:pPr indent="0" marL="0">
-              <a:buNone/>
-            </a:pPr>
-            <a:r>
-              <a:rPr lang="en-US" sz="750" dirty="0">
+            <a:off x="868680" y="868680"/>
+            <a:ext cx="5120640" cy="292608"/>
+          </a:xfrm>
+          <a:prstGeom prst="rect">
+            <a:avLst/>
+          </a:prstGeom>
+          <a:noFill/>
+          <a:ln/>
+        </p:spPr>
+        <p:txBody>
+          <a:bodyPr wrap="square" lIns="0" tIns="0" rIns="0" bIns="0" rtlCol="0" anchor="ctr"/>
+          <a:lstStyle/>
+          <a:p>
+            <a:pPr indent="0" marL="0">
+              <a:buNone/>
+            </a:pPr>
+            <a:r>
+              <a:rPr lang="en-US" sz="720" dirty="0">
                 <a:solidFill>
                   <a:srgbClr val="111827"/>
                 </a:solidFill>
@@ -5873,7 +5969,7 @@
               </a:rPr>
               <a:t>Delirium unrecognised in up to 60% of hospital cases and about 75% in the emergency department.</a:t>
             </a:r>
-            <a:endParaRPr lang="en-US" sz="750" dirty="0"/>
+            <a:endParaRPr lang="en-US" sz="720" dirty="0"/>
           </a:p>
         </p:txBody>
       </p:sp>
@@ -5885,24 +5981,24 @@
         </p:nvSpPr>
         <p:spPr>
           <a:xfrm>
-            <a:off x="6126480" y="914400"/>
-            <a:ext cx="2560320" cy="320040"/>
-          </a:xfrm>
-          <a:prstGeom prst="rect">
-            <a:avLst/>
-          </a:prstGeom>
-          <a:noFill/>
-          <a:ln/>
-        </p:spPr>
-        <p:txBody>
-          <a:bodyPr wrap="square" lIns="0" tIns="0" rIns="0" bIns="0" rtlCol="0" anchor="ctr"/>
-          <a:lstStyle/>
-          <a:p>
-            <a:pPr indent="0" marL="0">
-              <a:buNone/>
-            </a:pPr>
-            <a:r>
-              <a:rPr lang="en-US" sz="750" i="1" dirty="0">
+            <a:off x="6126480" y="868680"/>
+            <a:ext cx="2560320" cy="292608"/>
+          </a:xfrm>
+          <a:prstGeom prst="rect">
+            <a:avLst/>
+          </a:prstGeom>
+          <a:noFill/>
+          <a:ln/>
+        </p:spPr>
+        <p:txBody>
+          <a:bodyPr wrap="square" lIns="0" tIns="0" rIns="0" bIns="0" rtlCol="0" anchor="ctr"/>
+          <a:lstStyle/>
+          <a:p>
+            <a:pPr indent="0" marL="0">
+              <a:buNone/>
+            </a:pPr>
+            <a:r>
+              <a:rPr lang="en-US" sz="720" i="1" dirty="0">
                 <a:solidFill>
                   <a:srgbClr val="4B5563"/>
                 </a:solidFill>
@@ -5912,7 +6008,7 @@
               </a:rPr>
               <a:t>Delirium in Hospitalized Older Adults: A Narrative Review (PMC, 2026); Delirium screening in the emergency department (PMC, 2024).</a:t>
             </a:r>
-            <a:endParaRPr lang="en-US" sz="750" dirty="0"/>
+            <a:endParaRPr lang="en-US" sz="720" dirty="0"/>
           </a:p>
         </p:txBody>
       </p:sp>
@@ -5924,7 +6020,7 @@
         </p:nvSpPr>
         <p:spPr>
           <a:xfrm>
-            <a:off x="548640" y="1280160"/>
+            <a:off x="548640" y="1197864"/>
             <a:ext cx="274320" cy="274320"/>
           </a:xfrm>
           <a:prstGeom prst="rect">
@@ -5963,24 +6059,24 @@
         </p:nvSpPr>
         <p:spPr>
           <a:xfrm>
-            <a:off x="868680" y="1280160"/>
-            <a:ext cx="5120640" cy="365760"/>
-          </a:xfrm>
-          <a:prstGeom prst="rect">
-            <a:avLst/>
-          </a:prstGeom>
-          <a:noFill/>
-          <a:ln/>
-        </p:spPr>
-        <p:txBody>
-          <a:bodyPr wrap="square" lIns="0" tIns="0" rIns="0" bIns="0" rtlCol="0" anchor="ctr"/>
-          <a:lstStyle/>
-          <a:p>
-            <a:pPr indent="0" marL="0">
-              <a:buNone/>
-            </a:pPr>
-            <a:r>
-              <a:rPr lang="en-US" sz="750" dirty="0">
+            <a:off x="868680" y="1197864"/>
+            <a:ext cx="5120640" cy="347472"/>
+          </a:xfrm>
+          <a:prstGeom prst="rect">
+            <a:avLst/>
+          </a:prstGeom>
+          <a:noFill/>
+          <a:ln/>
+        </p:spPr>
+        <p:txBody>
+          <a:bodyPr wrap="square" lIns="0" tIns="0" rIns="0" bIns="0" rtlCol="0" anchor="ctr"/>
+          <a:lstStyle/>
+          <a:p>
+            <a:pPr indent="0" marL="0">
+              <a:buNone/>
+            </a:pPr>
+            <a:r>
+              <a:rPr lang="en-US" sz="720" dirty="0">
                 <a:solidFill>
                   <a:srgbClr val="111827"/>
                 </a:solidFill>
@@ -5990,7 +6086,7 @@
               </a:rPr>
               <a:t>Delirium affects over 7 million hospitalised US adults a year; 11% of Medicare beneficiaries had an episode; +$8,110 hospital charges per delirium stay (95% CI $1,860–$14,360).</a:t>
             </a:r>
-            <a:endParaRPr lang="en-US" sz="750" dirty="0"/>
+            <a:endParaRPr lang="en-US" sz="720" dirty="0"/>
           </a:p>
         </p:txBody>
       </p:sp>
@@ -6002,24 +6098,24 @@
         </p:nvSpPr>
         <p:spPr>
           <a:xfrm>
-            <a:off x="6126480" y="1280160"/>
-            <a:ext cx="2560320" cy="365760"/>
-          </a:xfrm>
-          <a:prstGeom prst="rect">
-            <a:avLst/>
-          </a:prstGeom>
-          <a:noFill/>
-          <a:ln/>
-        </p:spPr>
-        <p:txBody>
-          <a:bodyPr wrap="square" lIns="0" tIns="0" rIns="0" bIns="0" rtlCol="0" anchor="ctr"/>
-          <a:lstStyle/>
-          <a:p>
-            <a:pPr indent="0" marL="0">
-              <a:buNone/>
-            </a:pPr>
-            <a:r>
-              <a:rPr lang="en-US" sz="750" i="1" dirty="0">
+            <a:off x="6126480" y="1197864"/>
+            <a:ext cx="2560320" cy="347472"/>
+          </a:xfrm>
+          <a:prstGeom prst="rect">
+            <a:avLst/>
+          </a:prstGeom>
+          <a:noFill/>
+          <a:ln/>
+        </p:spPr>
+        <p:txBody>
+          <a:bodyPr wrap="square" lIns="0" tIns="0" rIns="0" bIns="0" rtlCol="0" anchor="ctr"/>
+          <a:lstStyle/>
+          <a:p>
+            <a:pPr indent="0" marL="0">
+              <a:buNone/>
+            </a:pPr>
+            <a:r>
+              <a:rPr lang="en-US" sz="720" i="1" dirty="0">
                 <a:solidFill>
                   <a:srgbClr val="4B5563"/>
                 </a:solidFill>
@@ -6029,7 +6125,7 @@
               </a:rPr>
               <a:t>Additional hospitalization costs associated with delirium among older adults, Frontiers in Public Health, 2026 (Medicare Current Beneficiary Survey 2019–2021).</a:t>
             </a:r>
-            <a:endParaRPr lang="en-US" sz="750" dirty="0"/>
+            <a:endParaRPr lang="en-US" sz="720" dirty="0"/>
           </a:p>
         </p:txBody>
       </p:sp>
@@ -6041,7 +6137,7 @@
         </p:nvSpPr>
         <p:spPr>
           <a:xfrm>
-            <a:off x="548640" y="1691640"/>
+            <a:off x="548640" y="1581912"/>
             <a:ext cx="274320" cy="274320"/>
           </a:xfrm>
           <a:prstGeom prst="rect">
@@ -6080,24 +6176,24 @@
         </p:nvSpPr>
         <p:spPr>
           <a:xfrm>
-            <a:off x="868680" y="1691640"/>
-            <a:ext cx="5120640" cy="457200"/>
-          </a:xfrm>
-          <a:prstGeom prst="rect">
-            <a:avLst/>
-          </a:prstGeom>
-          <a:noFill/>
-          <a:ln/>
-        </p:spPr>
-        <p:txBody>
-          <a:bodyPr wrap="square" lIns="0" tIns="0" rIns="0" bIns="0" rtlCol="0" anchor="ctr"/>
-          <a:lstStyle/>
-          <a:p>
-            <a:pPr indent="0" marL="0">
-              <a:buNone/>
-            </a:pPr>
-            <a:r>
-              <a:rPr lang="en-US" sz="750" dirty="0">
+            <a:off x="868680" y="1581912"/>
+            <a:ext cx="5120640" cy="420624"/>
+          </a:xfrm>
+          <a:prstGeom prst="rect">
+            <a:avLst/>
+          </a:prstGeom>
+          <a:noFill/>
+          <a:ln/>
+        </p:spPr>
+        <p:txBody>
+          <a:bodyPr wrap="square" lIns="0" tIns="0" rIns="0" bIns="0" rtlCol="0" anchor="ctr"/>
+          <a:lstStyle/>
+          <a:p>
+            <a:pPr indent="0" marL="0">
+              <a:buNone/>
+            </a:pPr>
+            <a:r>
+              <a:rPr lang="en-US" sz="720" dirty="0">
                 <a:solidFill>
                   <a:srgbClr val="111827"/>
                 </a:solidFill>
@@ -6107,7 +6203,7 @@
               </a:rPr>
               <a:t>Medicare: 2,002,700 30-day readmissions in 2020, 17.0 per 100 index stays, $36.2 B aggregate, $18,100 average. Top causes at index admission: septicemia 207,300; heart failure 147,800; acute renal failure 60,000; pneumonia 58,900; diabetes with complications 58,700.</a:t>
             </a:r>
-            <a:endParaRPr lang="en-US" sz="750" dirty="0"/>
+            <a:endParaRPr lang="en-US" sz="720" dirty="0"/>
           </a:p>
         </p:txBody>
       </p:sp>
@@ -6119,24 +6215,24 @@
         </p:nvSpPr>
         <p:spPr>
           <a:xfrm>
-            <a:off x="6126480" y="1691640"/>
-            <a:ext cx="2560320" cy="457200"/>
-          </a:xfrm>
-          <a:prstGeom prst="rect">
-            <a:avLst/>
-          </a:prstGeom>
-          <a:noFill/>
-          <a:ln/>
-        </p:spPr>
-        <p:txBody>
-          <a:bodyPr wrap="square" lIns="0" tIns="0" rIns="0" bIns="0" rtlCol="0" anchor="ctr"/>
-          <a:lstStyle/>
-          <a:p>
-            <a:pPr indent="0" marL="0">
-              <a:buNone/>
-            </a:pPr>
-            <a:r>
-              <a:rPr lang="en-US" sz="750" i="1" dirty="0">
+            <a:off x="6126480" y="1581912"/>
+            <a:ext cx="2560320" cy="420624"/>
+          </a:xfrm>
+          <a:prstGeom prst="rect">
+            <a:avLst/>
+          </a:prstGeom>
+          <a:noFill/>
+          <a:ln/>
+        </p:spPr>
+        <p:txBody>
+          <a:bodyPr wrap="square" lIns="0" tIns="0" rIns="0" bIns="0" rtlCol="0" anchor="ctr"/>
+          <a:lstStyle/>
+          <a:p>
+            <a:pPr indent="0" marL="0">
+              <a:buNone/>
+            </a:pPr>
+            <a:r>
+              <a:rPr lang="en-US" sz="720" i="1" dirty="0">
                 <a:solidFill>
                   <a:srgbClr val="4B5563"/>
                 </a:solidFill>
@@ -6146,7 +6242,7 @@
               </a:rPr>
               <a:t>AHRQ HCUP Statistical Brief #307, Nationwide Readmissions Database, 2020.</a:t>
             </a:r>
-            <a:endParaRPr lang="en-US" sz="750" dirty="0"/>
+            <a:endParaRPr lang="en-US" sz="720" dirty="0"/>
           </a:p>
         </p:txBody>
       </p:sp>
@@ -6158,7 +6254,7 @@
         </p:nvSpPr>
         <p:spPr>
           <a:xfrm>
-            <a:off x="548640" y="2194560"/>
+            <a:off x="548640" y="2039112"/>
             <a:ext cx="274320" cy="274320"/>
           </a:xfrm>
           <a:prstGeom prst="rect">
@@ -6197,24 +6293,24 @@
         </p:nvSpPr>
         <p:spPr>
           <a:xfrm>
-            <a:off x="868680" y="2194560"/>
-            <a:ext cx="5120640" cy="457200"/>
-          </a:xfrm>
-          <a:prstGeom prst="rect">
-            <a:avLst/>
-          </a:prstGeom>
-          <a:noFill/>
-          <a:ln/>
-        </p:spPr>
-        <p:txBody>
-          <a:bodyPr wrap="square" lIns="0" tIns="0" rIns="0" bIns="0" rtlCol="0" anchor="ctr"/>
-          <a:lstStyle/>
-          <a:p>
-            <a:pPr indent="0" marL="0">
-              <a:buNone/>
-            </a:pPr>
-            <a:r>
-              <a:rPr lang="en-US" sz="750" dirty="0">
+            <a:off x="868680" y="2039112"/>
+            <a:ext cx="5120640" cy="420624"/>
+          </a:xfrm>
+          <a:prstGeom prst="rect">
+            <a:avLst/>
+          </a:prstGeom>
+          <a:noFill/>
+          <a:ln/>
+        </p:spPr>
+        <p:txBody>
+          <a:bodyPr wrap="square" lIns="0" tIns="0" rIns="0" bIns="0" rtlCol="0" anchor="ctr"/>
+          <a:lstStyle/>
+          <a:p>
+            <a:pPr indent="0" marL="0">
+              <a:buNone/>
+            </a:pPr>
+            <a:r>
+              <a:rPr lang="en-US" sz="720" dirty="0">
                 <a:solidFill>
                   <a:srgbClr val="111827"/>
                 </a:solidFill>
@@ -6224,7 +6320,7 @@
               </a:rPr>
               <a:t>HRRP reduces a hospital’s Medicare inpatient payments by up to 3% for a fiscal year when 30-day readmissions for six conditions exceed the expected rate. FY2022: 2,499 of 3,139 hospitals penalised, average 0.64%, 39 at the 3% maximum, about $521 M withheld.</a:t>
             </a:r>
-            <a:endParaRPr lang="en-US" sz="750" dirty="0"/>
+            <a:endParaRPr lang="en-US" sz="720" dirty="0"/>
           </a:p>
         </p:txBody>
       </p:sp>
@@ -6236,24 +6332,24 @@
         </p:nvSpPr>
         <p:spPr>
           <a:xfrm>
-            <a:off x="6126480" y="2194560"/>
-            <a:ext cx="2560320" cy="457200"/>
-          </a:xfrm>
-          <a:prstGeom prst="rect">
-            <a:avLst/>
-          </a:prstGeom>
-          <a:noFill/>
-          <a:ln/>
-        </p:spPr>
-        <p:txBody>
-          <a:bodyPr wrap="square" lIns="0" tIns="0" rIns="0" bIns="0" rtlCol="0" anchor="ctr"/>
-          <a:lstStyle/>
-          <a:p>
-            <a:pPr indent="0" marL="0">
-              <a:buNone/>
-            </a:pPr>
-            <a:r>
-              <a:rPr lang="en-US" sz="750" i="1" dirty="0">
+            <a:off x="6126480" y="2039112"/>
+            <a:ext cx="2560320" cy="420624"/>
+          </a:xfrm>
+          <a:prstGeom prst="rect">
+            <a:avLst/>
+          </a:prstGeom>
+          <a:noFill/>
+          <a:ln/>
+        </p:spPr>
+        <p:txBody>
+          <a:bodyPr wrap="square" lIns="0" tIns="0" rIns="0" bIns="0" rtlCol="0" anchor="ctr"/>
+          <a:lstStyle/>
+          <a:p>
+            <a:pPr indent="0" marL="0">
+              <a:buNone/>
+            </a:pPr>
+            <a:r>
+              <a:rPr lang="en-US" sz="720" i="1" dirty="0">
                 <a:solidFill>
                   <a:srgbClr val="4B5563"/>
                 </a:solidFill>
@@ -6263,7 +6359,7 @@
               </a:rPr>
               <a:t>CMS, Hospital Readmissions Reduction Program; KFF, 10 Years of Hospital Readmissions Penalties.</a:t>
             </a:r>
-            <a:endParaRPr lang="en-US" sz="750" dirty="0"/>
+            <a:endParaRPr lang="en-US" sz="720" dirty="0"/>
           </a:p>
         </p:txBody>
       </p:sp>
@@ -6275,7 +6371,7 @@
         </p:nvSpPr>
         <p:spPr>
           <a:xfrm>
-            <a:off x="548640" y="2697480"/>
+            <a:off x="548640" y="2496312"/>
             <a:ext cx="274320" cy="274320"/>
           </a:xfrm>
           <a:prstGeom prst="rect">
@@ -6314,24 +6410,24 @@
         </p:nvSpPr>
         <p:spPr>
           <a:xfrm>
-            <a:off x="868680" y="2697480"/>
-            <a:ext cx="5120640" cy="365760"/>
-          </a:xfrm>
-          <a:prstGeom prst="rect">
-            <a:avLst/>
-          </a:prstGeom>
-          <a:noFill/>
-          <a:ln/>
-        </p:spPr>
-        <p:txBody>
-          <a:bodyPr wrap="square" lIns="0" tIns="0" rIns="0" bIns="0" rtlCol="0" anchor="ctr"/>
-          <a:lstStyle/>
-          <a:p>
-            <a:pPr indent="0" marL="0">
-              <a:buNone/>
-            </a:pPr>
-            <a:r>
-              <a:rPr lang="en-US" sz="750" dirty="0">
+            <a:off x="868680" y="2496312"/>
+            <a:ext cx="5120640" cy="329184"/>
+          </a:xfrm>
+          <a:prstGeom prst="rect">
+            <a:avLst/>
+          </a:prstGeom>
+          <a:noFill/>
+          <a:ln/>
+        </p:spPr>
+        <p:txBody>
+          <a:bodyPr wrap="square" lIns="0" tIns="0" rIns="0" bIns="0" rtlCol="0" anchor="ctr"/>
+          <a:lstStyle/>
+          <a:p>
+            <a:pPr indent="0" marL="0">
+              <a:buNone/>
+            </a:pPr>
+            <a:r>
+              <a:rPr lang="en-US" sz="720" dirty="0">
                 <a:solidFill>
                   <a:srgbClr val="111827"/>
                 </a:solidFill>
@@ -6341,7 +6437,7 @@
               </a:rPr>
               <a:t>Inpatient delirium associated with 30-day readmission, adjusted OR 2.60 (95% CI 1.96–3.44); 718 delirious vs 7,927 non-delirious patients, one community hospital, 2010–2015.</a:t>
             </a:r>
-            <a:endParaRPr lang="en-US" sz="750" dirty="0"/>
+            <a:endParaRPr lang="en-US" sz="720" dirty="0"/>
           </a:p>
         </p:txBody>
       </p:sp>
@@ -6353,24 +6449,24 @@
         </p:nvSpPr>
         <p:spPr>
           <a:xfrm>
-            <a:off x="6126480" y="2697480"/>
-            <a:ext cx="2560320" cy="365760"/>
-          </a:xfrm>
-          <a:prstGeom prst="rect">
-            <a:avLst/>
-          </a:prstGeom>
-          <a:noFill/>
-          <a:ln/>
-        </p:spPr>
-        <p:txBody>
-          <a:bodyPr wrap="square" lIns="0" tIns="0" rIns="0" bIns="0" rtlCol="0" anchor="ctr"/>
-          <a:lstStyle/>
-          <a:p>
-            <a:pPr indent="0" marL="0">
-              <a:buNone/>
-            </a:pPr>
-            <a:r>
-              <a:rPr lang="en-US" sz="750" i="1" dirty="0">
+            <a:off x="6126480" y="2496312"/>
+            <a:ext cx="2560320" cy="329184"/>
+          </a:xfrm>
+          <a:prstGeom prst="rect">
+            <a:avLst/>
+          </a:prstGeom>
+          <a:noFill/>
+          <a:ln/>
+        </p:spPr>
+        <p:txBody>
+          <a:bodyPr wrap="square" lIns="0" tIns="0" rIns="0" bIns="0" rtlCol="0" anchor="ctr"/>
+          <a:lstStyle/>
+          <a:p>
+            <a:pPr indent="0" marL="0">
+              <a:buNone/>
+            </a:pPr>
+            <a:r>
+              <a:rPr lang="en-US" sz="720" i="1" dirty="0">
                 <a:solidFill>
                   <a:srgbClr val="4B5563"/>
                 </a:solidFill>
@@ -6380,7 +6476,7 @@
               </a:rPr>
               <a:t>Association between Inpatient Delirium and Hospital Readmission in Patients ≥65 (PMC, 2019).</a:t>
             </a:r>
-            <a:endParaRPr lang="en-US" sz="750" dirty="0"/>
+            <a:endParaRPr lang="en-US" sz="720" dirty="0"/>
           </a:p>
         </p:txBody>
       </p:sp>
@@ -6392,7 +6488,7 @@
         </p:nvSpPr>
         <p:spPr>
           <a:xfrm>
-            <a:off x="548640" y="3108960"/>
+            <a:off x="548640" y="2862072"/>
             <a:ext cx="274320" cy="274320"/>
           </a:xfrm>
           <a:prstGeom prst="rect">
@@ -6431,24 +6527,24 @@
         </p:nvSpPr>
         <p:spPr>
           <a:xfrm>
-            <a:off x="868680" y="3108960"/>
-            <a:ext cx="5120640" cy="365760"/>
-          </a:xfrm>
-          <a:prstGeom prst="rect">
-            <a:avLst/>
-          </a:prstGeom>
-          <a:noFill/>
-          <a:ln/>
-        </p:spPr>
-        <p:txBody>
-          <a:bodyPr wrap="square" lIns="0" tIns="0" rIns="0" bIns="0" rtlCol="0" anchor="ctr"/>
-          <a:lstStyle/>
-          <a:p>
-            <a:pPr indent="0" marL="0">
-              <a:buNone/>
-            </a:pPr>
-            <a:r>
-              <a:rPr lang="en-US" sz="750" dirty="0">
+            <a:off x="868680" y="2862072"/>
+            <a:ext cx="5120640" cy="329184"/>
+          </a:xfrm>
+          <a:prstGeom prst="rect">
+            <a:avLst/>
+          </a:prstGeom>
+          <a:noFill/>
+          <a:ln/>
+        </p:spPr>
+        <p:txBody>
+          <a:bodyPr wrap="square" lIns="0" tIns="0" rIns="0" bIns="0" rtlCol="0" anchor="ctr"/>
+          <a:lstStyle/>
+          <a:p>
+            <a:pPr indent="0" marL="0">
+              <a:buNone/>
+            </a:pPr>
+            <a:r>
+              <a:rPr lang="en-US" sz="720" dirty="0">
                 <a:solidFill>
                   <a:srgbClr val="111827"/>
                 </a:solidFill>
@@ -6458,7 +6554,7 @@
               </a:rPr>
               <a:t>Median 27% of readmissions judged avoidable across 34 studies (range 5–79%). Multicomponent prevention (HELP) cut delirium incidence from 15.0% to 9.9%.</a:t>
             </a:r>
-            <a:endParaRPr lang="en-US" sz="750" dirty="0"/>
+            <a:endParaRPr lang="en-US" sz="720" dirty="0"/>
           </a:p>
         </p:txBody>
       </p:sp>
@@ -6470,24 +6566,24 @@
         </p:nvSpPr>
         <p:spPr>
           <a:xfrm>
-            <a:off x="6126480" y="3108960"/>
-            <a:ext cx="2560320" cy="365760"/>
-          </a:xfrm>
-          <a:prstGeom prst="rect">
-            <a:avLst/>
-          </a:prstGeom>
-          <a:noFill/>
-          <a:ln/>
-        </p:spPr>
-        <p:txBody>
-          <a:bodyPr wrap="square" lIns="0" tIns="0" rIns="0" bIns="0" rtlCol="0" anchor="ctr"/>
-          <a:lstStyle/>
-          <a:p>
-            <a:pPr indent="0" marL="0">
-              <a:buNone/>
-            </a:pPr>
-            <a:r>
-              <a:rPr lang="en-US" sz="750" i="1" dirty="0">
+            <a:off x="6126480" y="2862072"/>
+            <a:ext cx="2560320" cy="329184"/>
+          </a:xfrm>
+          <a:prstGeom prst="rect">
+            <a:avLst/>
+          </a:prstGeom>
+          <a:noFill/>
+          <a:ln/>
+        </p:spPr>
+        <p:txBody>
+          <a:bodyPr wrap="square" lIns="0" tIns="0" rIns="0" bIns="0" rtlCol="0" anchor="ctr"/>
+          <a:lstStyle/>
+          <a:p>
+            <a:pPr indent="0" marL="0">
+              <a:buNone/>
+            </a:pPr>
+            <a:r>
+              <a:rPr lang="en-US" sz="720" i="1" dirty="0">
                 <a:solidFill>
                   <a:srgbClr val="4B5563"/>
                 </a:solidFill>
@@ -6497,7 +6593,7 @@
               </a:rPr>
               <a:t>van Walraven et al., CMAJ 2011; Inouye et al., NEJM 1999.</a:t>
             </a:r>
-            <a:endParaRPr lang="en-US" sz="750" dirty="0"/>
+            <a:endParaRPr lang="en-US" sz="720" dirty="0"/>
           </a:p>
         </p:txBody>
       </p:sp>
@@ -6509,7 +6605,7 @@
         </p:nvSpPr>
         <p:spPr>
           <a:xfrm>
-            <a:off x="548640" y="3520440"/>
+            <a:off x="548640" y="3227832"/>
             <a:ext cx="274320" cy="274320"/>
           </a:xfrm>
           <a:prstGeom prst="rect">
@@ -6548,24 +6644,24 @@
         </p:nvSpPr>
         <p:spPr>
           <a:xfrm>
-            <a:off x="868680" y="3520440"/>
-            <a:ext cx="5120640" cy="612648"/>
-          </a:xfrm>
-          <a:prstGeom prst="rect">
-            <a:avLst/>
-          </a:prstGeom>
-          <a:noFill/>
-          <a:ln/>
-        </p:spPr>
-        <p:txBody>
-          <a:bodyPr wrap="square" lIns="0" tIns="0" rIns="0" bIns="0" rtlCol="0" anchor="ctr"/>
-          <a:lstStyle/>
-          <a:p>
-            <a:pPr indent="0" marL="0">
-              <a:buNone/>
-            </a:pPr>
-            <a:r>
-              <a:rPr lang="en-US" sz="750" dirty="0">
+            <a:off x="868680" y="3227832"/>
+            <a:ext cx="5120640" cy="566928"/>
+          </a:xfrm>
+          <a:prstGeom prst="rect">
+            <a:avLst/>
+          </a:prstGeom>
+          <a:noFill/>
+          <a:ln/>
+        </p:spPr>
+        <p:txBody>
+          <a:bodyPr wrap="square" lIns="0" tIns="0" rIns="0" bIns="0" rtlCol="0" anchor="ctr"/>
+          <a:lstStyle/>
+          <a:p>
+            <a:pPr indent="0" marL="0">
+              <a:buNone/>
+            </a:pPr>
+            <a:r>
+              <a:rPr lang="en-US" sz="720" dirty="0">
                 <a:solidFill>
                   <a:srgbClr val="111827"/>
                 </a:solidFill>
@@ -6575,7 +6671,7 @@
               </a:rPr>
               <a:t>Back of the envelope: 11.8 M Medicare stays × 11% = 1.3 M delirium stays. With 2.0–2.6× the readmission risk and a 17% overall rate, delirium stays run 15–23 points above the rest: 200–300 k excess readmissions × $18,100 = $3.6–5.4 B a year. × 27% avoidable ≈ $1.0–1.5 B. Upper bound: delirium also marks sicker patients, and no trial yet shows a home check-in reduces readmissions.</a:t>
             </a:r>
-            <a:endParaRPr lang="en-US" sz="750" dirty="0"/>
+            <a:endParaRPr lang="en-US" sz="720" dirty="0"/>
           </a:p>
         </p:txBody>
       </p:sp>
@@ -6587,24 +6683,24 @@
         </p:nvSpPr>
         <p:spPr>
           <a:xfrm>
-            <a:off x="6126480" y="3520440"/>
-            <a:ext cx="2560320" cy="612648"/>
-          </a:xfrm>
-          <a:prstGeom prst="rect">
-            <a:avLst/>
-          </a:prstGeom>
-          <a:noFill/>
-          <a:ln/>
-        </p:spPr>
-        <p:txBody>
-          <a:bodyPr wrap="square" lIns="0" tIns="0" rIns="0" bIns="0" rtlCol="0" anchor="ctr"/>
-          <a:lstStyle/>
-          <a:p>
-            <a:pPr indent="0" marL="0">
-              <a:buNone/>
-            </a:pPr>
-            <a:r>
-              <a:rPr lang="en-US" sz="750" i="1" dirty="0">
+            <a:off x="6126480" y="3227832"/>
+            <a:ext cx="2560320" cy="566928"/>
+          </a:xfrm>
+          <a:prstGeom prst="rect">
+            <a:avLst/>
+          </a:prstGeom>
+          <a:noFill/>
+          <a:ln/>
+        </p:spPr>
+        <p:txBody>
+          <a:bodyPr wrap="square" lIns="0" tIns="0" rIns="0" bIns="0" rtlCol="0" anchor="ctr"/>
+          <a:lstStyle/>
+          <a:p>
+            <a:pPr indent="0" marL="0">
+              <a:buNone/>
+            </a:pPr>
+            <a:r>
+              <a:rPr lang="en-US" sz="720" i="1" dirty="0">
                 <a:solidFill>
                   <a:srgbClr val="4B5563"/>
                 </a:solidFill>
@@ -6614,7 +6710,7 @@
               </a:rPr>
               <a:t>Derived from sources 2, 3 and 5.</a:t>
             </a:r>
-            <a:endParaRPr lang="en-US" sz="750" dirty="0"/>
+            <a:endParaRPr lang="en-US" sz="720" dirty="0"/>
           </a:p>
         </p:txBody>
       </p:sp>
@@ -6626,7 +6722,7 @@
         </p:nvSpPr>
         <p:spPr>
           <a:xfrm>
-            <a:off x="548640" y="4178808"/>
+            <a:off x="548640" y="3831336"/>
             <a:ext cx="274320" cy="274320"/>
           </a:xfrm>
           <a:prstGeom prst="rect">
@@ -6665,24 +6761,24 @@
         </p:nvSpPr>
         <p:spPr>
           <a:xfrm>
-            <a:off x="868680" y="4178808"/>
-            <a:ext cx="5120640" cy="667512"/>
-          </a:xfrm>
-          <a:prstGeom prst="rect">
-            <a:avLst/>
-          </a:prstGeom>
-          <a:noFill/>
-          <a:ln/>
-        </p:spPr>
-        <p:txBody>
-          <a:bodyPr wrap="square" lIns="0" tIns="0" rIns="0" bIns="0" rtlCol="0" anchor="ctr"/>
-          <a:lstStyle/>
-          <a:p>
-            <a:pPr indent="0" marL="0">
-              <a:buNone/>
-            </a:pPr>
-            <a:r>
-              <a:rPr lang="en-US" sz="750" dirty="0">
+            <a:off x="868680" y="3831336"/>
+            <a:ext cx="5120640" cy="621792"/>
+          </a:xfrm>
+          <a:prstGeom prst="rect">
+            <a:avLst/>
+          </a:prstGeom>
+          <a:noFill/>
+          <a:ln/>
+        </p:spPr>
+        <p:txBody>
+          <a:bodyPr wrap="square" lIns="0" tIns="0" rIns="0" bIns="0" rtlCol="0" anchor="ctr"/>
+          <a:lstStyle/>
+          <a:p>
+            <a:pPr indent="0" marL="0">
+              <a:buNone/>
+            </a:pPr>
+            <a:r>
+              <a:rPr lang="en-US" sz="720" dirty="0">
                 <a:solidFill>
                   <a:srgbClr val="111827"/>
                 </a:solidFill>
@@ -6692,7 +6788,7 @@
               </a:rPr>
               <a:t>Lives: 38.0% of older patients who had delirium were dead at ~2 years vs 27.5% of controls (adjusted HR 1.95, 95% CI 1.51–2.52; 7 studies). That 10-point excess on 1.3–2.6 M older adults a year is 130–270 k deaths associated with delirium. If home detection prevented delirium as well as in-hospital programmes (30–40%) and deaths fell with it: 40–100 k a year. Association only; delirium also marks frailty, and no trial shows a home check-in saves lives.</a:t>
             </a:r>
-            <a:endParaRPr lang="en-US" sz="750" dirty="0"/>
+            <a:endParaRPr lang="en-US" sz="720" dirty="0"/>
           </a:p>
         </p:txBody>
       </p:sp>
@@ -6704,24 +6800,24 @@
         </p:nvSpPr>
         <p:spPr>
           <a:xfrm>
-            <a:off x="6126480" y="4178808"/>
-            <a:ext cx="2560320" cy="667512"/>
-          </a:xfrm>
-          <a:prstGeom prst="rect">
-            <a:avLst/>
-          </a:prstGeom>
-          <a:noFill/>
-          <a:ln/>
-        </p:spPr>
-        <p:txBody>
-          <a:bodyPr wrap="square" lIns="0" tIns="0" rIns="0" bIns="0" rtlCol="0" anchor="ctr"/>
-          <a:lstStyle/>
-          <a:p>
-            <a:pPr indent="0" marL="0">
-              <a:buNone/>
-            </a:pPr>
-            <a:r>
-              <a:rPr lang="en-US" sz="750" i="1" dirty="0">
+            <a:off x="6126480" y="3831336"/>
+            <a:ext cx="2560320" cy="621792"/>
+          </a:xfrm>
+          <a:prstGeom prst="rect">
+            <a:avLst/>
+          </a:prstGeom>
+          <a:noFill/>
+          <a:ln/>
+        </p:spPr>
+        <p:txBody>
+          <a:bodyPr wrap="square" lIns="0" tIns="0" rIns="0" bIns="0" rtlCol="0" anchor="ctr"/>
+          <a:lstStyle/>
+          <a:p>
+            <a:pPr indent="0" marL="0">
+              <a:buNone/>
+            </a:pPr>
+            <a:r>
+              <a:rPr lang="en-US" sz="720" i="1" dirty="0">
                 <a:solidFill>
                   <a:srgbClr val="4B5563"/>
                 </a:solidFill>
@@ -6731,7 +6827,124 @@
               </a:rPr>
               <a:t>Witlox et al., JAMA 2010; Inouye et al., NEJM 1999; sources 2 and 3.</a:t>
             </a:r>
-            <a:endParaRPr lang="en-US" sz="750" dirty="0"/>
+            <a:endParaRPr lang="en-US" sz="720" dirty="0"/>
+          </a:p>
+        </p:txBody>
+      </p:sp>
+      <p:sp>
+        <p:nvSpPr>
+          <p:cNvPr id="27" name="Text 25"/>
+          <p:cNvSpPr txBox="1"/>
+          <p:nvPr/>
+        </p:nvSpPr>
+        <p:spPr>
+          <a:xfrm>
+            <a:off x="548640" y="4489704"/>
+            <a:ext cx="274320" cy="274320"/>
+          </a:xfrm>
+          <a:prstGeom prst="rect">
+            <a:avLst/>
+          </a:prstGeom>
+          <a:noFill/>
+          <a:ln/>
+        </p:spPr>
+        <p:txBody>
+          <a:bodyPr wrap="square" lIns="0" tIns="0" rIns="0" bIns="0" rtlCol="0" anchor="ctr"/>
+          <a:lstStyle/>
+          <a:p>
+            <a:pPr indent="0" marL="0">
+              <a:buNone/>
+            </a:pPr>
+            <a:r>
+              <a:rPr lang="en-US" sz="1100" b="1" dirty="0">
+                <a:solidFill>
+                  <a:srgbClr val="1E40AF"/>
+                </a:solidFill>
+                <a:latin typeface="Arial" pitchFamily="34" charset="0"/>
+                <a:ea typeface="Arial" pitchFamily="34" charset="-122"/>
+                <a:cs typeface="Arial" pitchFamily="34" charset="-120"/>
+              </a:rPr>
+              <a:t>9</a:t>
+            </a:r>
+            <a:endParaRPr lang="en-US" sz="1100" dirty="0"/>
+          </a:p>
+        </p:txBody>
+      </p:sp>
+      <p:sp>
+        <p:nvSpPr>
+          <p:cNvPr id="28" name="Text 26"/>
+          <p:cNvSpPr txBox="1"/>
+          <p:nvPr/>
+        </p:nvSpPr>
+        <p:spPr>
+          <a:xfrm>
+            <a:off x="868680" y="4489704"/>
+            <a:ext cx="5120640" cy="475488"/>
+          </a:xfrm>
+          <a:prstGeom prst="rect">
+            <a:avLst/>
+          </a:prstGeom>
+          <a:noFill/>
+          <a:ln/>
+        </p:spPr>
+        <p:txBody>
+          <a:bodyPr wrap="square" lIns="0" tIns="0" rIns="0" bIns="0" rtlCol="0" anchor="ctr"/>
+          <a:lstStyle/>
+          <a:p>
+            <a:pPr indent="0" marL="0">
+              <a:buNone/>
+            </a:pPr>
+            <a:r>
+              <a:rPr lang="en-US" sz="720" dirty="0">
+                <a:solidFill>
+                  <a:srgbClr val="111827"/>
+                </a:solidFill>
+                <a:latin typeface="Arial" pitchFamily="34" charset="0"/>
+                <a:ea typeface="Arial" pitchFamily="34" charset="-122"/>
+                <a:cs typeface="Arial" pitchFamily="34" charset="-120"/>
+              </a:rPr>
+              <a:t>ACCESS (Advancing Chronic Care with Effective, Scalable Solutions): voluntary 10-year model from 1 July 2026 paying recurring outcome-aligned payments for technology-enabled chronic care; ~150 digital health companies and providers selected. TEAM: mandatory bundled payment for five surgical episodes at ~750 hospitals from January 2026. LEAD: 10-year ACO model from 2027, replacing ACO REACH.</a:t>
+            </a:r>
+            <a:endParaRPr lang="en-US" sz="720" dirty="0"/>
+          </a:p>
+        </p:txBody>
+      </p:sp>
+      <p:sp>
+        <p:nvSpPr>
+          <p:cNvPr id="29" name="Text 27"/>
+          <p:cNvSpPr txBox="1"/>
+          <p:nvPr/>
+        </p:nvSpPr>
+        <p:spPr>
+          <a:xfrm>
+            <a:off x="6126480" y="4489704"/>
+            <a:ext cx="2560320" cy="475488"/>
+          </a:xfrm>
+          <a:prstGeom prst="rect">
+            <a:avLst/>
+          </a:prstGeom>
+          <a:noFill/>
+          <a:ln/>
+        </p:spPr>
+        <p:txBody>
+          <a:bodyPr wrap="square" lIns="0" tIns="0" rIns="0" bIns="0" rtlCol="0" anchor="ctr"/>
+          <a:lstStyle/>
+          <a:p>
+            <a:pPr indent="0" marL="0">
+              <a:buNone/>
+            </a:pPr>
+            <a:r>
+              <a:rPr lang="en-US" sz="720" i="1" dirty="0">
+                <a:solidFill>
+                  <a:srgbClr val="4B5563"/>
+                </a:solidFill>
+                <a:latin typeface="Arial" pitchFamily="34" charset="0"/>
+                <a:ea typeface="Arial" pitchFamily="34" charset="-122"/>
+                <a:cs typeface="Arial" pitchFamily="34" charset="-120"/>
+              </a:rPr>
+              <a:t>CMS Innovation Center model pages; Fierce Healthcare, Dec 2025 and Apr 2026.</a:t>
+            </a:r>
+            <a:endParaRPr lang="en-US" sz="720" dirty="0"/>
           </a:p>
         </p:txBody>
       </p:sp>

</xml_diff>